<commit_message>
Scinder la couverture Jacoco par type de test (JUnit vs Cucumber)
mvn test genere desormais trois rapports (jacoco-report-junit,
jacoco-report-cucumber, jacoco-report global) au lieu d'un seul, en
fusionnant l'agent -javaagent de jacoco-maven-plugin avec les donnees
separees de l'extension quarkus-jacoco (code execute dans le
QuarkusClassLoader). Script coverage-summary.sh, DESCRIPTION.md et la
presentation mis a jour avec les vraies mesures (JUnit et Cucumber
couvrent des lignes presque disjointes).

Co-Authored-By: Claude Sonnet 5 <noreply@anthropic.com>
Claude-Session: https://claude.ai/code/session_01UJ8K2KSjB3mCiTjCx3LvFL
</commit_message>
<xml_diff>
--- a/presentation/couverture-code-conference.pptx
+++ b/presentation/couverture-code-conference.pptx
@@ -10673,21 +10673,193 @@
                 </a:solidFill>
                 <a:latin typeface="Calibri"/>
               </a:rPr>
-              <a:t>Mesure réelle, extraite du build — couverture de lignes par classe</a:t>
-            </a:r>
-          </a:p>
-        </p:txBody>
-      </p:sp>
-      <p:sp>
-        <p:nvSpPr>
-          <p:cNvPr id="6" name="TextBox 5"/>
+              <a:t>Mesure réelle, extraite du build — couverture de lignes, JUnit contre Cucumber</a:t>
+            </a:r>
+          </a:p>
+        </p:txBody>
+      </p:sp>
+      <p:sp>
+        <p:nvSpPr>
+          <p:cNvPr id="6" name="Rectangle 5"/>
+          <p:cNvSpPr/>
+          <p:nvPr/>
+        </p:nvSpPr>
+        <p:spPr>
+          <a:xfrm>
+            <a:off x="822960" y="1874519"/>
+            <a:ext cx="292608" cy="164592"/>
+          </a:xfrm>
+          <a:prstGeom prst="rect">
+            <a:avLst/>
+          </a:prstGeom>
+          <a:solidFill>
+            <a:srgbClr val="C79A52"/>
+          </a:solidFill>
+          <a:ln>
+            <a:noFill/>
+          </a:ln>
+          <a:effectLst/>
+        </p:spPr>
+        <p:style>
+          <a:lnRef idx="1">
+            <a:schemeClr val="accent1"/>
+          </a:lnRef>
+          <a:fillRef idx="3">
+            <a:schemeClr val="accent1"/>
+          </a:fillRef>
+          <a:effectRef idx="2">
+            <a:schemeClr val="accent1"/>
+          </a:effectRef>
+          <a:fontRef idx="minor">
+            <a:schemeClr val="lt1"/>
+          </a:fontRef>
+        </p:style>
+        <p:txBody>
+          <a:bodyPr rtlCol="0" anchor="ctr"/>
+          <a:lstStyle/>
+          <a:p>
+            <a:pPr algn="ctr"/>
+          </a:p>
+        </p:txBody>
+      </p:sp>
+      <p:sp>
+        <p:nvSpPr>
+          <p:cNvPr id="7" name="TextBox 6"/>
           <p:cNvSpPr txBox="1"/>
           <p:nvPr/>
         </p:nvSpPr>
         <p:spPr>
           <a:xfrm>
-            <a:off x="822960" y="2039112"/>
-            <a:ext cx="2331720" cy="365760"/>
+            <a:off x="1188720" y="1847087"/>
+            <a:ext cx="1828800" cy="274320"/>
+          </a:xfrm>
+          <a:prstGeom prst="rect">
+            <a:avLst/>
+          </a:prstGeom>
+          <a:noFill/>
+        </p:spPr>
+        <p:txBody>
+          <a:bodyPr wrap="square" anchor="t" lIns="0" rIns="0" tIns="0" bIns="0">
+            <a:spAutoFit/>
+          </a:bodyPr>
+          <a:lstStyle/>
+          <a:p>
+            <a:pPr algn="l">
+              <a:lnSpc>
+                <a:spcPct val="100000"/>
+              </a:lnSpc>
+              <a:spcAft>
+                <a:spcPts val="0"/>
+              </a:spcAft>
+            </a:pPr>
+            <a:r>
+              <a:rPr sz="1200" b="1" i="0">
+                <a:solidFill>
+                  <a:srgbClr val="162844"/>
+                </a:solidFill>
+                <a:latin typeface="Calibri"/>
+              </a:rPr>
+              <a:t>JUnit (unitaire)</a:t>
+            </a:r>
+          </a:p>
+        </p:txBody>
+      </p:sp>
+      <p:sp>
+        <p:nvSpPr>
+          <p:cNvPr id="8" name="Rectangle 7"/>
+          <p:cNvSpPr/>
+          <p:nvPr/>
+        </p:nvSpPr>
+        <p:spPr>
+          <a:xfrm>
+            <a:off x="3017520" y="1874519"/>
+            <a:ext cx="292608" cy="164592"/>
+          </a:xfrm>
+          <a:prstGeom prst="rect">
+            <a:avLst/>
+          </a:prstGeom>
+          <a:solidFill>
+            <a:srgbClr val="5C8C86"/>
+          </a:solidFill>
+          <a:ln>
+            <a:noFill/>
+          </a:ln>
+          <a:effectLst/>
+        </p:spPr>
+        <p:style>
+          <a:lnRef idx="1">
+            <a:schemeClr val="accent1"/>
+          </a:lnRef>
+          <a:fillRef idx="3">
+            <a:schemeClr val="accent1"/>
+          </a:fillRef>
+          <a:effectRef idx="2">
+            <a:schemeClr val="accent1"/>
+          </a:effectRef>
+          <a:fontRef idx="minor">
+            <a:schemeClr val="lt1"/>
+          </a:fontRef>
+        </p:style>
+        <p:txBody>
+          <a:bodyPr rtlCol="0" anchor="ctr"/>
+          <a:lstStyle/>
+          <a:p>
+            <a:pPr algn="ctr"/>
+          </a:p>
+        </p:txBody>
+      </p:sp>
+      <p:sp>
+        <p:nvSpPr>
+          <p:cNvPr id="9" name="TextBox 8"/>
+          <p:cNvSpPr txBox="1"/>
+          <p:nvPr/>
+        </p:nvSpPr>
+        <p:spPr>
+          <a:xfrm>
+            <a:off x="3383280" y="1847087"/>
+            <a:ext cx="2743200" cy="274320"/>
+          </a:xfrm>
+          <a:prstGeom prst="rect">
+            <a:avLst/>
+          </a:prstGeom>
+          <a:noFill/>
+        </p:spPr>
+        <p:txBody>
+          <a:bodyPr wrap="square" anchor="t" lIns="0" rIns="0" tIns="0" bIns="0">
+            <a:spAutoFit/>
+          </a:bodyPr>
+          <a:lstStyle/>
+          <a:p>
+            <a:pPr algn="l">
+              <a:lnSpc>
+                <a:spcPct val="100000"/>
+              </a:lnSpc>
+              <a:spcAft>
+                <a:spcPts val="0"/>
+              </a:spcAft>
+            </a:pPr>
+            <a:r>
+              <a:rPr sz="1200" b="1" i="0">
+                <a:solidFill>
+                  <a:srgbClr val="162844"/>
+                </a:solidFill>
+                <a:latin typeface="Calibri"/>
+              </a:rPr>
+              <a:t>Cucumber (intégration)</a:t>
+            </a:r>
+          </a:p>
+        </p:txBody>
+      </p:sp>
+      <p:sp>
+        <p:nvSpPr>
+          <p:cNvPr id="10" name="TextBox 9"/>
+          <p:cNvSpPr txBox="1"/>
+          <p:nvPr/>
+        </p:nvSpPr>
+        <p:spPr>
+          <a:xfrm>
+            <a:off x="822960" y="2441448"/>
+            <a:ext cx="2423160" cy="365760"/>
           </a:xfrm>
           <a:prstGeom prst="rect">
             <a:avLst/>
@@ -10715,21 +10887,21 @@
                 </a:solidFill>
                 <a:latin typeface="Calibri"/>
               </a:rPr>
-              <a:t>RecurrenceRequest (DTO)</a:t>
-            </a:r>
-          </a:p>
-        </p:txBody>
-      </p:sp>
-      <p:sp>
-        <p:nvSpPr>
-          <p:cNvPr id="7" name="Rectangle 6"/>
+              <a:t>CalendarResource</a:t>
+            </a:r>
+          </a:p>
+        </p:txBody>
+      </p:sp>
+      <p:sp>
+        <p:nvSpPr>
+          <p:cNvPr id="11" name="Rectangle 10"/>
           <p:cNvSpPr/>
           <p:nvPr/>
         </p:nvSpPr>
         <p:spPr>
           <a:xfrm>
-            <a:off x="3291840" y="2011680"/>
-            <a:ext cx="7406640" cy="310896"/>
+            <a:off x="3383280" y="2331720"/>
+            <a:ext cx="7315200" cy="201168"/>
           </a:xfrm>
           <a:prstGeom prst="rect">
             <a:avLst/>
@@ -10766,20 +10938,20 @@
       </p:sp>
       <p:sp>
         <p:nvSpPr>
-          <p:cNvPr id="8" name="Rectangle 7"/>
+          <p:cNvPr id="12" name="Rectangle 11"/>
           <p:cNvSpPr/>
           <p:nvPr/>
         </p:nvSpPr>
         <p:spPr>
           <a:xfrm>
-            <a:off x="3291840" y="2011680"/>
-            <a:ext cx="148132" cy="310896"/>
-          </a:xfrm>
-          <a:prstGeom prst="rect">
-            <a:avLst/>
-          </a:prstGeom>
-          <a:solidFill>
-            <a:srgbClr val="BF6F5D"/>
+            <a:off x="3383280" y="2331720"/>
+            <a:ext cx="73152" cy="201168"/>
+          </a:xfrm>
+          <a:prstGeom prst="rect">
+            <a:avLst/>
+          </a:prstGeom>
+          <a:solidFill>
+            <a:srgbClr val="C79A52"/>
           </a:solidFill>
           <a:ln>
             <a:noFill/>
@@ -10810,14 +10982,14 @@
       </p:sp>
       <p:sp>
         <p:nvSpPr>
-          <p:cNvPr id="9" name="TextBox 8"/>
+          <p:cNvPr id="13" name="TextBox 12"/>
           <p:cNvSpPr txBox="1"/>
           <p:nvPr/>
         </p:nvSpPr>
         <p:spPr>
           <a:xfrm>
-            <a:off x="10789920" y="2029968"/>
-            <a:ext cx="640080" cy="320040"/>
+            <a:off x="10789920" y="2313432"/>
+            <a:ext cx="640080" cy="274320"/>
           </a:xfrm>
           <a:prstGeom prst="rect">
             <a:avLst/>
@@ -10839,7 +11011,7 @@
               </a:spcAft>
             </a:pPr>
             <a:r>
-              <a:rPr sz="1250" b="1" i="0">
+              <a:rPr sz="1150" b="1" i="0">
                 <a:solidFill>
                   <a:srgbClr val="162844"/>
                 </a:solidFill>
@@ -10852,14 +11024,144 @@
       </p:sp>
       <p:sp>
         <p:nvSpPr>
-          <p:cNvPr id="10" name="TextBox 9"/>
+          <p:cNvPr id="14" name="Rectangle 13"/>
+          <p:cNvSpPr/>
+          <p:nvPr/>
+        </p:nvSpPr>
+        <p:spPr>
+          <a:xfrm>
+            <a:off x="3383280" y="2587752"/>
+            <a:ext cx="7315200" cy="201168"/>
+          </a:xfrm>
+          <a:prstGeom prst="rect">
+            <a:avLst/>
+          </a:prstGeom>
+          <a:solidFill>
+            <a:srgbClr val="EAE6DA"/>
+          </a:solidFill>
+          <a:ln>
+            <a:noFill/>
+          </a:ln>
+          <a:effectLst/>
+        </p:spPr>
+        <p:style>
+          <a:lnRef idx="1">
+            <a:schemeClr val="accent1"/>
+          </a:lnRef>
+          <a:fillRef idx="3">
+            <a:schemeClr val="accent1"/>
+          </a:fillRef>
+          <a:effectRef idx="2">
+            <a:schemeClr val="accent1"/>
+          </a:effectRef>
+          <a:fontRef idx="minor">
+            <a:schemeClr val="lt1"/>
+          </a:fontRef>
+        </p:style>
+        <p:txBody>
+          <a:bodyPr rtlCol="0" anchor="ctr"/>
+          <a:lstStyle/>
+          <a:p>
+            <a:pPr algn="ctr"/>
+          </a:p>
+        </p:txBody>
+      </p:sp>
+      <p:sp>
+        <p:nvSpPr>
+          <p:cNvPr id="15" name="Rectangle 14"/>
+          <p:cNvSpPr/>
+          <p:nvPr/>
+        </p:nvSpPr>
+        <p:spPr>
+          <a:xfrm>
+            <a:off x="3383280" y="2587752"/>
+            <a:ext cx="4242816" cy="201168"/>
+          </a:xfrm>
+          <a:prstGeom prst="rect">
+            <a:avLst/>
+          </a:prstGeom>
+          <a:solidFill>
+            <a:srgbClr val="5C8C86"/>
+          </a:solidFill>
+          <a:ln>
+            <a:noFill/>
+          </a:ln>
+          <a:effectLst/>
+        </p:spPr>
+        <p:style>
+          <a:lnRef idx="1">
+            <a:schemeClr val="accent1"/>
+          </a:lnRef>
+          <a:fillRef idx="3">
+            <a:schemeClr val="accent1"/>
+          </a:fillRef>
+          <a:effectRef idx="2">
+            <a:schemeClr val="accent1"/>
+          </a:effectRef>
+          <a:fontRef idx="minor">
+            <a:schemeClr val="lt1"/>
+          </a:fontRef>
+        </p:style>
+        <p:txBody>
+          <a:bodyPr rtlCol="0" anchor="ctr"/>
+          <a:lstStyle/>
+          <a:p>
+            <a:pPr algn="ctr"/>
+          </a:p>
+        </p:txBody>
+      </p:sp>
+      <p:sp>
+        <p:nvSpPr>
+          <p:cNvPr id="16" name="TextBox 15"/>
           <p:cNvSpPr txBox="1"/>
           <p:nvPr/>
         </p:nvSpPr>
         <p:spPr>
           <a:xfrm>
-            <a:off x="822960" y="2514600"/>
-            <a:ext cx="2331720" cy="365760"/>
+            <a:off x="10789920" y="2569464"/>
+            <a:ext cx="640080" cy="274320"/>
+          </a:xfrm>
+          <a:prstGeom prst="rect">
+            <a:avLst/>
+          </a:prstGeom>
+          <a:noFill/>
+        </p:spPr>
+        <p:txBody>
+          <a:bodyPr wrap="square" anchor="t" lIns="0" rIns="0" tIns="0" bIns="0">
+            <a:spAutoFit/>
+          </a:bodyPr>
+          <a:lstStyle/>
+          <a:p>
+            <a:pPr algn="l">
+              <a:lnSpc>
+                <a:spcPct val="100000"/>
+              </a:lnSpc>
+              <a:spcAft>
+                <a:spcPts val="0"/>
+              </a:spcAft>
+            </a:pPr>
+            <a:r>
+              <a:rPr sz="1150" b="1" i="0">
+                <a:solidFill>
+                  <a:srgbClr val="162844"/>
+                </a:solidFill>
+                <a:latin typeface="Calibri"/>
+              </a:rPr>
+              <a:t>58%</a:t>
+            </a:r>
+          </a:p>
+        </p:txBody>
+      </p:sp>
+      <p:sp>
+        <p:nvSpPr>
+          <p:cNvPr id="17" name="TextBox 16"/>
+          <p:cNvSpPr txBox="1"/>
+          <p:nvPr/>
+        </p:nvSpPr>
+        <p:spPr>
+          <a:xfrm>
+            <a:off x="822960" y="3063240"/>
+            <a:ext cx="2423160" cy="365760"/>
           </a:xfrm>
           <a:prstGeom prst="rect">
             <a:avLst/>
@@ -10887,21 +11189,21 @@
                 </a:solidFill>
                 <a:latin typeface="Calibri"/>
               </a:rPr>
-              <a:t>CalendarResource</a:t>
-            </a:r>
-          </a:p>
-        </p:txBody>
-      </p:sp>
-      <p:sp>
-        <p:nvSpPr>
-          <p:cNvPr id="11" name="Rectangle 10"/>
+              <a:t>HolidayService</a:t>
+            </a:r>
+          </a:p>
+        </p:txBody>
+      </p:sp>
+      <p:sp>
+        <p:nvSpPr>
+          <p:cNvPr id="18" name="Rectangle 17"/>
           <p:cNvSpPr/>
           <p:nvPr/>
         </p:nvSpPr>
         <p:spPr>
           <a:xfrm>
-            <a:off x="3291840" y="2487168"/>
-            <a:ext cx="7406640" cy="310896"/>
+            <a:off x="3383280" y="2953512"/>
+            <a:ext cx="7315200" cy="201168"/>
           </a:xfrm>
           <a:prstGeom prst="rect">
             <a:avLst/>
@@ -10938,20 +11240,20 @@
       </p:sp>
       <p:sp>
         <p:nvSpPr>
-          <p:cNvPr id="12" name="Rectangle 11"/>
+          <p:cNvPr id="19" name="Rectangle 18"/>
           <p:cNvSpPr/>
           <p:nvPr/>
         </p:nvSpPr>
         <p:spPr>
           <a:xfrm>
-            <a:off x="3291840" y="2487168"/>
-            <a:ext cx="4295851" cy="310896"/>
-          </a:xfrm>
-          <a:prstGeom prst="rect">
-            <a:avLst/>
-          </a:prstGeom>
-          <a:solidFill>
-            <a:srgbClr val="BF6F5D"/>
+            <a:off x="3383280" y="2953512"/>
+            <a:ext cx="73152" cy="201168"/>
+          </a:xfrm>
+          <a:prstGeom prst="rect">
+            <a:avLst/>
+          </a:prstGeom>
+          <a:solidFill>
+            <a:srgbClr val="C79A52"/>
           </a:solidFill>
           <a:ln>
             <a:noFill/>
@@ -10982,14 +11284,14 @@
       </p:sp>
       <p:sp>
         <p:nvSpPr>
-          <p:cNvPr id="13" name="TextBox 12"/>
+          <p:cNvPr id="20" name="TextBox 19"/>
           <p:cNvSpPr txBox="1"/>
           <p:nvPr/>
         </p:nvSpPr>
         <p:spPr>
           <a:xfrm>
-            <a:off x="10789920" y="2505456"/>
-            <a:ext cx="640080" cy="320040"/>
+            <a:off x="10789920" y="2935224"/>
+            <a:ext cx="640080" cy="274320"/>
           </a:xfrm>
           <a:prstGeom prst="rect">
             <a:avLst/>
@@ -11011,27 +11313,157 @@
               </a:spcAft>
             </a:pPr>
             <a:r>
-              <a:rPr sz="1250" b="1" i="0">
+              <a:rPr sz="1150" b="1" i="0">
                 <a:solidFill>
                   <a:srgbClr val="162844"/>
                 </a:solidFill>
                 <a:latin typeface="Calibri"/>
               </a:rPr>
-              <a:t>58%</a:t>
-            </a:r>
-          </a:p>
-        </p:txBody>
-      </p:sp>
-      <p:sp>
-        <p:nvSpPr>
-          <p:cNvPr id="14" name="TextBox 13"/>
+              <a:t>0%</a:t>
+            </a:r>
+          </a:p>
+        </p:txBody>
+      </p:sp>
+      <p:sp>
+        <p:nvSpPr>
+          <p:cNvPr id="21" name="Rectangle 20"/>
+          <p:cNvSpPr/>
+          <p:nvPr/>
+        </p:nvSpPr>
+        <p:spPr>
+          <a:xfrm>
+            <a:off x="3383280" y="3209544"/>
+            <a:ext cx="7315200" cy="201168"/>
+          </a:xfrm>
+          <a:prstGeom prst="rect">
+            <a:avLst/>
+          </a:prstGeom>
+          <a:solidFill>
+            <a:srgbClr val="EAE6DA"/>
+          </a:solidFill>
+          <a:ln>
+            <a:noFill/>
+          </a:ln>
+          <a:effectLst/>
+        </p:spPr>
+        <p:style>
+          <a:lnRef idx="1">
+            <a:schemeClr val="accent1"/>
+          </a:lnRef>
+          <a:fillRef idx="3">
+            <a:schemeClr val="accent1"/>
+          </a:fillRef>
+          <a:effectRef idx="2">
+            <a:schemeClr val="accent1"/>
+          </a:effectRef>
+          <a:fontRef idx="minor">
+            <a:schemeClr val="lt1"/>
+          </a:fontRef>
+        </p:style>
+        <p:txBody>
+          <a:bodyPr rtlCol="0" anchor="ctr"/>
+          <a:lstStyle/>
+          <a:p>
+            <a:pPr algn="ctr"/>
+          </a:p>
+        </p:txBody>
+      </p:sp>
+      <p:sp>
+        <p:nvSpPr>
+          <p:cNvPr id="22" name="Rectangle 21"/>
+          <p:cNvSpPr/>
+          <p:nvPr/>
+        </p:nvSpPr>
+        <p:spPr>
+          <a:xfrm>
+            <a:off x="3383280" y="3209544"/>
+            <a:ext cx="6803136" cy="201168"/>
+          </a:xfrm>
+          <a:prstGeom prst="rect">
+            <a:avLst/>
+          </a:prstGeom>
+          <a:solidFill>
+            <a:srgbClr val="5C8C86"/>
+          </a:solidFill>
+          <a:ln>
+            <a:noFill/>
+          </a:ln>
+          <a:effectLst/>
+        </p:spPr>
+        <p:style>
+          <a:lnRef idx="1">
+            <a:schemeClr val="accent1"/>
+          </a:lnRef>
+          <a:fillRef idx="3">
+            <a:schemeClr val="accent1"/>
+          </a:fillRef>
+          <a:effectRef idx="2">
+            <a:schemeClr val="accent1"/>
+          </a:effectRef>
+          <a:fontRef idx="minor">
+            <a:schemeClr val="lt1"/>
+          </a:fontRef>
+        </p:style>
+        <p:txBody>
+          <a:bodyPr rtlCol="0" anchor="ctr"/>
+          <a:lstStyle/>
+          <a:p>
+            <a:pPr algn="ctr"/>
+          </a:p>
+        </p:txBody>
+      </p:sp>
+      <p:sp>
+        <p:nvSpPr>
+          <p:cNvPr id="23" name="TextBox 22"/>
           <p:cNvSpPr txBox="1"/>
           <p:nvPr/>
         </p:nvSpPr>
         <p:spPr>
           <a:xfrm>
-            <a:off x="822960" y="2990088"/>
-            <a:ext cx="2331720" cy="365760"/>
+            <a:off x="10789920" y="3191256"/>
+            <a:ext cx="640080" cy="274320"/>
+          </a:xfrm>
+          <a:prstGeom prst="rect">
+            <a:avLst/>
+          </a:prstGeom>
+          <a:noFill/>
+        </p:spPr>
+        <p:txBody>
+          <a:bodyPr wrap="square" anchor="t" lIns="0" rIns="0" tIns="0" bIns="0">
+            <a:spAutoFit/>
+          </a:bodyPr>
+          <a:lstStyle/>
+          <a:p>
+            <a:pPr algn="l">
+              <a:lnSpc>
+                <a:spcPct val="100000"/>
+              </a:lnSpc>
+              <a:spcAft>
+                <a:spcPts val="0"/>
+              </a:spcAft>
+            </a:pPr>
+            <a:r>
+              <a:rPr sz="1150" b="1" i="0">
+                <a:solidFill>
+                  <a:srgbClr val="162844"/>
+                </a:solidFill>
+                <a:latin typeface="Calibri"/>
+              </a:rPr>
+              <a:t>93%</a:t>
+            </a:r>
+          </a:p>
+        </p:txBody>
+      </p:sp>
+      <p:sp>
+        <p:nvSpPr>
+          <p:cNvPr id="24" name="TextBox 23"/>
+          <p:cNvSpPr txBox="1"/>
+          <p:nvPr/>
+        </p:nvSpPr>
+        <p:spPr>
+          <a:xfrm>
+            <a:off x="822960" y="3685032"/>
+            <a:ext cx="2423160" cy="365760"/>
           </a:xfrm>
           <a:prstGeom prst="rect">
             <a:avLst/>
@@ -11059,21 +11491,21 @@
                 </a:solidFill>
                 <a:latin typeface="Calibri"/>
               </a:rPr>
-              <a:t>Event (modèle)</a:t>
-            </a:r>
-          </a:p>
-        </p:txBody>
-      </p:sp>
-      <p:sp>
-        <p:nvSpPr>
-          <p:cNvPr id="15" name="Rectangle 14"/>
+              <a:t>RecurrenceService</a:t>
+            </a:r>
+          </a:p>
+        </p:txBody>
+      </p:sp>
+      <p:sp>
+        <p:nvSpPr>
+          <p:cNvPr id="25" name="Rectangle 24"/>
           <p:cNvSpPr/>
           <p:nvPr/>
         </p:nvSpPr>
         <p:spPr>
           <a:xfrm>
-            <a:off x="3291840" y="2962656"/>
-            <a:ext cx="7406640" cy="310896"/>
+            <a:off x="3383280" y="3575304"/>
+            <a:ext cx="7315200" cy="201168"/>
           </a:xfrm>
           <a:prstGeom prst="rect">
             <a:avLst/>
@@ -11110,14 +11542,14 @@
       </p:sp>
       <p:sp>
         <p:nvSpPr>
-          <p:cNvPr id="16" name="Rectangle 15"/>
+          <p:cNvPr id="26" name="Rectangle 25"/>
           <p:cNvSpPr/>
           <p:nvPr/>
         </p:nvSpPr>
         <p:spPr>
           <a:xfrm>
-            <a:off x="3291840" y="2962656"/>
-            <a:ext cx="4962448" cy="310896"/>
+            <a:off x="3383280" y="3575304"/>
+            <a:ext cx="5705856" cy="201168"/>
           </a:xfrm>
           <a:prstGeom prst="rect">
             <a:avLst/>
@@ -11154,14 +11586,14 @@
       </p:sp>
       <p:sp>
         <p:nvSpPr>
-          <p:cNvPr id="17" name="TextBox 16"/>
+          <p:cNvPr id="27" name="TextBox 26"/>
           <p:cNvSpPr txBox="1"/>
           <p:nvPr/>
         </p:nvSpPr>
         <p:spPr>
           <a:xfrm>
-            <a:off x="10789920" y="2980944"/>
-            <a:ext cx="640080" cy="320040"/>
+            <a:off x="10789920" y="3557016"/>
+            <a:ext cx="640080" cy="274320"/>
           </a:xfrm>
           <a:prstGeom prst="rect">
             <a:avLst/>
@@ -11183,27 +11615,157 @@
               </a:spcAft>
             </a:pPr>
             <a:r>
-              <a:rPr sz="1250" b="1" i="0">
+              <a:rPr sz="1150" b="1" i="0">
                 <a:solidFill>
                   <a:srgbClr val="162844"/>
                 </a:solidFill>
                 <a:latin typeface="Calibri"/>
               </a:rPr>
-              <a:t>67%</a:t>
-            </a:r>
-          </a:p>
-        </p:txBody>
-      </p:sp>
-      <p:sp>
-        <p:nvSpPr>
-          <p:cNvPr id="18" name="TextBox 17"/>
+              <a:t>78%</a:t>
+            </a:r>
+          </a:p>
+        </p:txBody>
+      </p:sp>
+      <p:sp>
+        <p:nvSpPr>
+          <p:cNvPr id="28" name="Rectangle 27"/>
+          <p:cNvSpPr/>
+          <p:nvPr/>
+        </p:nvSpPr>
+        <p:spPr>
+          <a:xfrm>
+            <a:off x="3383280" y="3831336"/>
+            <a:ext cx="7315200" cy="201168"/>
+          </a:xfrm>
+          <a:prstGeom prst="rect">
+            <a:avLst/>
+          </a:prstGeom>
+          <a:solidFill>
+            <a:srgbClr val="EAE6DA"/>
+          </a:solidFill>
+          <a:ln>
+            <a:noFill/>
+          </a:ln>
+          <a:effectLst/>
+        </p:spPr>
+        <p:style>
+          <a:lnRef idx="1">
+            <a:schemeClr val="accent1"/>
+          </a:lnRef>
+          <a:fillRef idx="3">
+            <a:schemeClr val="accent1"/>
+          </a:fillRef>
+          <a:effectRef idx="2">
+            <a:schemeClr val="accent1"/>
+          </a:effectRef>
+          <a:fontRef idx="minor">
+            <a:schemeClr val="lt1"/>
+          </a:fontRef>
+        </p:style>
+        <p:txBody>
+          <a:bodyPr rtlCol="0" anchor="ctr"/>
+          <a:lstStyle/>
+          <a:p>
+            <a:pPr algn="ctr"/>
+          </a:p>
+        </p:txBody>
+      </p:sp>
+      <p:sp>
+        <p:nvSpPr>
+          <p:cNvPr id="29" name="Rectangle 28"/>
+          <p:cNvSpPr/>
+          <p:nvPr/>
+        </p:nvSpPr>
+        <p:spPr>
+          <a:xfrm>
+            <a:off x="3383280" y="3831336"/>
+            <a:ext cx="292608" cy="201168"/>
+          </a:xfrm>
+          <a:prstGeom prst="rect">
+            <a:avLst/>
+          </a:prstGeom>
+          <a:solidFill>
+            <a:srgbClr val="5C8C86"/>
+          </a:solidFill>
+          <a:ln>
+            <a:noFill/>
+          </a:ln>
+          <a:effectLst/>
+        </p:spPr>
+        <p:style>
+          <a:lnRef idx="1">
+            <a:schemeClr val="accent1"/>
+          </a:lnRef>
+          <a:fillRef idx="3">
+            <a:schemeClr val="accent1"/>
+          </a:fillRef>
+          <a:effectRef idx="2">
+            <a:schemeClr val="accent1"/>
+          </a:effectRef>
+          <a:fontRef idx="minor">
+            <a:schemeClr val="lt1"/>
+          </a:fontRef>
+        </p:style>
+        <p:txBody>
+          <a:bodyPr rtlCol="0" anchor="ctr"/>
+          <a:lstStyle/>
+          <a:p>
+            <a:pPr algn="ctr"/>
+          </a:p>
+        </p:txBody>
+      </p:sp>
+      <p:sp>
+        <p:nvSpPr>
+          <p:cNvPr id="30" name="TextBox 29"/>
           <p:cNvSpPr txBox="1"/>
           <p:nvPr/>
         </p:nvSpPr>
         <p:spPr>
           <a:xfrm>
-            <a:off x="822960" y="3465576"/>
-            <a:ext cx="2331720" cy="365760"/>
+            <a:off x="10789920" y="3813048"/>
+            <a:ext cx="640080" cy="274320"/>
+          </a:xfrm>
+          <a:prstGeom prst="rect">
+            <a:avLst/>
+          </a:prstGeom>
+          <a:noFill/>
+        </p:spPr>
+        <p:txBody>
+          <a:bodyPr wrap="square" anchor="t" lIns="0" rIns="0" tIns="0" bIns="0">
+            <a:spAutoFit/>
+          </a:bodyPr>
+          <a:lstStyle/>
+          <a:p>
+            <a:pPr algn="l">
+              <a:lnSpc>
+                <a:spcPct val="100000"/>
+              </a:lnSpc>
+              <a:spcAft>
+                <a:spcPts val="0"/>
+              </a:spcAft>
+            </a:pPr>
+            <a:r>
+              <a:rPr sz="1150" b="1" i="0">
+                <a:solidFill>
+                  <a:srgbClr val="162844"/>
+                </a:solidFill>
+                <a:latin typeface="Calibri"/>
+              </a:rPr>
+              <a:t>4%</a:t>
+            </a:r>
+          </a:p>
+        </p:txBody>
+      </p:sp>
+      <p:sp>
+        <p:nvSpPr>
+          <p:cNvPr id="31" name="TextBox 30"/>
+          <p:cNvSpPr txBox="1"/>
+          <p:nvPr/>
+        </p:nvSpPr>
+        <p:spPr>
+          <a:xfrm>
+            <a:off x="822960" y="4306824"/>
+            <a:ext cx="2423160" cy="365760"/>
           </a:xfrm>
           <a:prstGeom prst="rect">
             <a:avLst/>
@@ -11231,21 +11793,21 @@
                 </a:solidFill>
                 <a:latin typeface="Calibri"/>
               </a:rPr>
-              <a:t>RecurrenceService</a:t>
-            </a:r>
-          </a:p>
-        </p:txBody>
-      </p:sp>
-      <p:sp>
-        <p:nvSpPr>
-          <p:cNvPr id="19" name="Rectangle 18"/>
+              <a:t>ConflictDetector</a:t>
+            </a:r>
+          </a:p>
+        </p:txBody>
+      </p:sp>
+      <p:sp>
+        <p:nvSpPr>
+          <p:cNvPr id="32" name="Rectangle 31"/>
           <p:cNvSpPr/>
           <p:nvPr/>
         </p:nvSpPr>
         <p:spPr>
           <a:xfrm>
-            <a:off x="3291840" y="3438144"/>
-            <a:ext cx="7406640" cy="310896"/>
+            <a:off x="3383280" y="4197096"/>
+            <a:ext cx="7315200" cy="201168"/>
           </a:xfrm>
           <a:prstGeom prst="rect">
             <a:avLst/>
@@ -11282,14 +11844,14 @@
       </p:sp>
       <p:sp>
         <p:nvSpPr>
-          <p:cNvPr id="20" name="Rectangle 19"/>
+          <p:cNvPr id="33" name="Rectangle 32"/>
           <p:cNvSpPr/>
           <p:nvPr/>
         </p:nvSpPr>
         <p:spPr>
           <a:xfrm>
-            <a:off x="3291840" y="3438144"/>
-            <a:ext cx="5777179" cy="310896"/>
+            <a:off x="3383280" y="4197096"/>
+            <a:ext cx="7315200" cy="201168"/>
           </a:xfrm>
           <a:prstGeom prst="rect">
             <a:avLst/>
@@ -11326,14 +11888,14 @@
       </p:sp>
       <p:sp>
         <p:nvSpPr>
-          <p:cNvPr id="21" name="TextBox 20"/>
+          <p:cNvPr id="34" name="TextBox 33"/>
           <p:cNvSpPr txBox="1"/>
           <p:nvPr/>
         </p:nvSpPr>
         <p:spPr>
           <a:xfrm>
-            <a:off x="10789920" y="3456432"/>
-            <a:ext cx="640080" cy="320040"/>
+            <a:off x="10789920" y="4178808"/>
+            <a:ext cx="640080" cy="274320"/>
           </a:xfrm>
           <a:prstGeom prst="rect">
             <a:avLst/>
@@ -11355,27 +11917,157 @@
               </a:spcAft>
             </a:pPr>
             <a:r>
-              <a:rPr sz="1250" b="1" i="0">
+              <a:rPr sz="1150" b="1" i="0">
                 <a:solidFill>
                   <a:srgbClr val="162844"/>
                 </a:solidFill>
                 <a:latin typeface="Calibri"/>
               </a:rPr>
-              <a:t>78%</a:t>
-            </a:r>
-          </a:p>
-        </p:txBody>
-      </p:sp>
-      <p:sp>
-        <p:nvSpPr>
-          <p:cNvPr id="22" name="TextBox 21"/>
+              <a:t>100%</a:t>
+            </a:r>
+          </a:p>
+        </p:txBody>
+      </p:sp>
+      <p:sp>
+        <p:nvSpPr>
+          <p:cNvPr id="35" name="Rectangle 34"/>
+          <p:cNvSpPr/>
+          <p:nvPr/>
+        </p:nvSpPr>
+        <p:spPr>
+          <a:xfrm>
+            <a:off x="3383280" y="4453128"/>
+            <a:ext cx="7315200" cy="201168"/>
+          </a:xfrm>
+          <a:prstGeom prst="rect">
+            <a:avLst/>
+          </a:prstGeom>
+          <a:solidFill>
+            <a:srgbClr val="EAE6DA"/>
+          </a:solidFill>
+          <a:ln>
+            <a:noFill/>
+          </a:ln>
+          <a:effectLst/>
+        </p:spPr>
+        <p:style>
+          <a:lnRef idx="1">
+            <a:schemeClr val="accent1"/>
+          </a:lnRef>
+          <a:fillRef idx="3">
+            <a:schemeClr val="accent1"/>
+          </a:fillRef>
+          <a:effectRef idx="2">
+            <a:schemeClr val="accent1"/>
+          </a:effectRef>
+          <a:fontRef idx="minor">
+            <a:schemeClr val="lt1"/>
+          </a:fontRef>
+        </p:style>
+        <p:txBody>
+          <a:bodyPr rtlCol="0" anchor="ctr"/>
+          <a:lstStyle/>
+          <a:p>
+            <a:pPr algn="ctr"/>
+          </a:p>
+        </p:txBody>
+      </p:sp>
+      <p:sp>
+        <p:nvSpPr>
+          <p:cNvPr id="36" name="Rectangle 35"/>
+          <p:cNvSpPr/>
+          <p:nvPr/>
+        </p:nvSpPr>
+        <p:spPr>
+          <a:xfrm>
+            <a:off x="3383280" y="4453128"/>
+            <a:ext cx="5486400" cy="201168"/>
+          </a:xfrm>
+          <a:prstGeom prst="rect">
+            <a:avLst/>
+          </a:prstGeom>
+          <a:solidFill>
+            <a:srgbClr val="5C8C86"/>
+          </a:solidFill>
+          <a:ln>
+            <a:noFill/>
+          </a:ln>
+          <a:effectLst/>
+        </p:spPr>
+        <p:style>
+          <a:lnRef idx="1">
+            <a:schemeClr val="accent1"/>
+          </a:lnRef>
+          <a:fillRef idx="3">
+            <a:schemeClr val="accent1"/>
+          </a:fillRef>
+          <a:effectRef idx="2">
+            <a:schemeClr val="accent1"/>
+          </a:effectRef>
+          <a:fontRef idx="minor">
+            <a:schemeClr val="lt1"/>
+          </a:fontRef>
+        </p:style>
+        <p:txBody>
+          <a:bodyPr rtlCol="0" anchor="ctr"/>
+          <a:lstStyle/>
+          <a:p>
+            <a:pPr algn="ctr"/>
+          </a:p>
+        </p:txBody>
+      </p:sp>
+      <p:sp>
+        <p:nvSpPr>
+          <p:cNvPr id="37" name="TextBox 36"/>
           <p:cNvSpPr txBox="1"/>
           <p:nvPr/>
         </p:nvSpPr>
         <p:spPr>
           <a:xfrm>
-            <a:off x="822960" y="3941064"/>
-            <a:ext cx="2331720" cy="365760"/>
+            <a:off x="10789920" y="4434840"/>
+            <a:ext cx="640080" cy="274320"/>
+          </a:xfrm>
+          <a:prstGeom prst="rect">
+            <a:avLst/>
+          </a:prstGeom>
+          <a:noFill/>
+        </p:spPr>
+        <p:txBody>
+          <a:bodyPr wrap="square" anchor="t" lIns="0" rIns="0" tIns="0" bIns="0">
+            <a:spAutoFit/>
+          </a:bodyPr>
+          <a:lstStyle/>
+          <a:p>
+            <a:pPr algn="l">
+              <a:lnSpc>
+                <a:spcPct val="100000"/>
+              </a:lnSpc>
+              <a:spcAft>
+                <a:spcPts val="0"/>
+              </a:spcAft>
+            </a:pPr>
+            <a:r>
+              <a:rPr sz="1150" b="1" i="0">
+                <a:solidFill>
+                  <a:srgbClr val="162844"/>
+                </a:solidFill>
+                <a:latin typeface="Calibri"/>
+              </a:rPr>
+              <a:t>75%</a:t>
+            </a:r>
+          </a:p>
+        </p:txBody>
+      </p:sp>
+      <p:sp>
+        <p:nvSpPr>
+          <p:cNvPr id="38" name="TextBox 37"/>
+          <p:cNvSpPr txBox="1"/>
+          <p:nvPr/>
+        </p:nvSpPr>
+        <p:spPr>
+          <a:xfrm>
+            <a:off x="822960" y="4928616"/>
+            <a:ext cx="2423160" cy="365760"/>
           </a:xfrm>
           <a:prstGeom prst="rect">
             <a:avLst/>
@@ -11410,14 +12102,14 @@
       </p:sp>
       <p:sp>
         <p:nvSpPr>
-          <p:cNvPr id="23" name="Rectangle 22"/>
+          <p:cNvPr id="39" name="Rectangle 38"/>
           <p:cNvSpPr/>
           <p:nvPr/>
         </p:nvSpPr>
         <p:spPr>
           <a:xfrm>
-            <a:off x="3291840" y="3913632"/>
-            <a:ext cx="7406640" cy="310896"/>
+            <a:off x="3383280" y="4818888"/>
+            <a:ext cx="7315200" cy="201168"/>
           </a:xfrm>
           <a:prstGeom prst="rect">
             <a:avLst/>
@@ -11454,20 +12146,20 @@
       </p:sp>
       <p:sp>
         <p:nvSpPr>
-          <p:cNvPr id="24" name="Rectangle 23"/>
+          <p:cNvPr id="40" name="Rectangle 39"/>
           <p:cNvSpPr/>
           <p:nvPr/>
         </p:nvSpPr>
         <p:spPr>
           <a:xfrm>
-            <a:off x="3291840" y="3913632"/>
-            <a:ext cx="6517843" cy="310896"/>
-          </a:xfrm>
-          <a:prstGeom prst="rect">
-            <a:avLst/>
-          </a:prstGeom>
-          <a:solidFill>
-            <a:srgbClr val="839B74"/>
+            <a:off x="3383280" y="4818888"/>
+            <a:ext cx="6437376" cy="201168"/>
+          </a:xfrm>
+          <a:prstGeom prst="rect">
+            <a:avLst/>
+          </a:prstGeom>
+          <a:solidFill>
+            <a:srgbClr val="C79A52"/>
           </a:solidFill>
           <a:ln>
             <a:noFill/>
@@ -11498,14 +12190,14 @@
       </p:sp>
       <p:sp>
         <p:nvSpPr>
-          <p:cNvPr id="25" name="TextBox 24"/>
+          <p:cNvPr id="41" name="TextBox 40"/>
           <p:cNvSpPr txBox="1"/>
           <p:nvPr/>
         </p:nvSpPr>
         <p:spPr>
           <a:xfrm>
-            <a:off x="10789920" y="3931920"/>
-            <a:ext cx="640080" cy="320040"/>
+            <a:off x="10789920" y="4800600"/>
+            <a:ext cx="640080" cy="274320"/>
           </a:xfrm>
           <a:prstGeom prst="rect">
             <a:avLst/>
@@ -11527,7 +12219,7 @@
               </a:spcAft>
             </a:pPr>
             <a:r>
-              <a:rPr sz="1250" b="1" i="0">
+              <a:rPr sz="1150" b="1" i="0">
                 <a:solidFill>
                   <a:srgbClr val="162844"/>
                 </a:solidFill>
@@ -11540,14 +12232,144 @@
       </p:sp>
       <p:sp>
         <p:nvSpPr>
-          <p:cNvPr id="26" name="TextBox 25"/>
+          <p:cNvPr id="42" name="Rectangle 41"/>
+          <p:cNvSpPr/>
+          <p:nvPr/>
+        </p:nvSpPr>
+        <p:spPr>
+          <a:xfrm>
+            <a:off x="3383280" y="5074920"/>
+            <a:ext cx="7315200" cy="201168"/>
+          </a:xfrm>
+          <a:prstGeom prst="rect">
+            <a:avLst/>
+          </a:prstGeom>
+          <a:solidFill>
+            <a:srgbClr val="EAE6DA"/>
+          </a:solidFill>
+          <a:ln>
+            <a:noFill/>
+          </a:ln>
+          <a:effectLst/>
+        </p:spPr>
+        <p:style>
+          <a:lnRef idx="1">
+            <a:schemeClr val="accent1"/>
+          </a:lnRef>
+          <a:fillRef idx="3">
+            <a:schemeClr val="accent1"/>
+          </a:fillRef>
+          <a:effectRef idx="2">
+            <a:schemeClr val="accent1"/>
+          </a:effectRef>
+          <a:fontRef idx="minor">
+            <a:schemeClr val="lt1"/>
+          </a:fontRef>
+        </p:style>
+        <p:txBody>
+          <a:bodyPr rtlCol="0" anchor="ctr"/>
+          <a:lstStyle/>
+          <a:p>
+            <a:pPr algn="ctr"/>
+          </a:p>
+        </p:txBody>
+      </p:sp>
+      <p:sp>
+        <p:nvSpPr>
+          <p:cNvPr id="43" name="Rectangle 42"/>
+          <p:cNvSpPr/>
+          <p:nvPr/>
+        </p:nvSpPr>
+        <p:spPr>
+          <a:xfrm>
+            <a:off x="3383280" y="5074920"/>
+            <a:ext cx="6437376" cy="201168"/>
+          </a:xfrm>
+          <a:prstGeom prst="rect">
+            <a:avLst/>
+          </a:prstGeom>
+          <a:solidFill>
+            <a:srgbClr val="5C8C86"/>
+          </a:solidFill>
+          <a:ln>
+            <a:noFill/>
+          </a:ln>
+          <a:effectLst/>
+        </p:spPr>
+        <p:style>
+          <a:lnRef idx="1">
+            <a:schemeClr val="accent1"/>
+          </a:lnRef>
+          <a:fillRef idx="3">
+            <a:schemeClr val="accent1"/>
+          </a:fillRef>
+          <a:effectRef idx="2">
+            <a:schemeClr val="accent1"/>
+          </a:effectRef>
+          <a:fontRef idx="minor">
+            <a:schemeClr val="lt1"/>
+          </a:fontRef>
+        </p:style>
+        <p:txBody>
+          <a:bodyPr rtlCol="0" anchor="ctr"/>
+          <a:lstStyle/>
+          <a:p>
+            <a:pPr algn="ctr"/>
+          </a:p>
+        </p:txBody>
+      </p:sp>
+      <p:sp>
+        <p:nvSpPr>
+          <p:cNvPr id="44" name="TextBox 43"/>
           <p:cNvSpPr txBox="1"/>
           <p:nvPr/>
         </p:nvSpPr>
         <p:spPr>
           <a:xfrm>
-            <a:off x="822960" y="4416552"/>
-            <a:ext cx="2331720" cy="365760"/>
+            <a:off x="10789920" y="5056632"/>
+            <a:ext cx="640080" cy="274320"/>
+          </a:xfrm>
+          <a:prstGeom prst="rect">
+            <a:avLst/>
+          </a:prstGeom>
+          <a:noFill/>
+        </p:spPr>
+        <p:txBody>
+          <a:bodyPr wrap="square" anchor="t" lIns="0" rIns="0" tIns="0" bIns="0">
+            <a:spAutoFit/>
+          </a:bodyPr>
+          <a:lstStyle/>
+          <a:p>
+            <a:pPr algn="l">
+              <a:lnSpc>
+                <a:spcPct val="100000"/>
+              </a:lnSpc>
+              <a:spcAft>
+                <a:spcPts val="0"/>
+              </a:spcAft>
+            </a:pPr>
+            <a:r>
+              <a:rPr sz="1150" b="1" i="0">
+                <a:solidFill>
+                  <a:srgbClr val="162844"/>
+                </a:solidFill>
+                <a:latin typeface="Calibri"/>
+              </a:rPr>
+              <a:t>88%</a:t>
+            </a:r>
+          </a:p>
+        </p:txBody>
+      </p:sp>
+      <p:sp>
+        <p:nvSpPr>
+          <p:cNvPr id="45" name="TextBox 44"/>
+          <p:cNvSpPr txBox="1"/>
+          <p:nvPr/>
+        </p:nvSpPr>
+        <p:spPr>
+          <a:xfrm>
+            <a:off x="822960" y="5550408"/>
+            <a:ext cx="2423160" cy="365760"/>
           </a:xfrm>
           <a:prstGeom prst="rect">
             <a:avLst/>
@@ -11575,21 +12397,21 @@
                 </a:solidFill>
                 <a:latin typeface="Calibri"/>
               </a:rPr>
-              <a:t>HolidayService</a:t>
-            </a:r>
-          </a:p>
-        </p:txBody>
-      </p:sp>
-      <p:sp>
-        <p:nvSpPr>
-          <p:cNvPr id="27" name="Rectangle 26"/>
+              <a:t>RecurrenceRequest (DTO)</a:t>
+            </a:r>
+          </a:p>
+        </p:txBody>
+      </p:sp>
+      <p:sp>
+        <p:nvSpPr>
+          <p:cNvPr id="46" name="Rectangle 45"/>
           <p:cNvSpPr/>
           <p:nvPr/>
         </p:nvSpPr>
         <p:spPr>
           <a:xfrm>
-            <a:off x="3291840" y="4389120"/>
-            <a:ext cx="7406640" cy="310896"/>
+            <a:off x="3383280" y="5440680"/>
+            <a:ext cx="7315200" cy="201168"/>
           </a:xfrm>
           <a:prstGeom prst="rect">
             <a:avLst/>
@@ -11626,20 +12448,20 @@
       </p:sp>
       <p:sp>
         <p:nvSpPr>
-          <p:cNvPr id="28" name="Rectangle 27"/>
+          <p:cNvPr id="47" name="Rectangle 46"/>
           <p:cNvSpPr/>
           <p:nvPr/>
         </p:nvSpPr>
         <p:spPr>
           <a:xfrm>
-            <a:off x="3291840" y="4389120"/>
-            <a:ext cx="6888175" cy="310896"/>
-          </a:xfrm>
-          <a:prstGeom prst="rect">
-            <a:avLst/>
-          </a:prstGeom>
-          <a:solidFill>
-            <a:srgbClr val="839B74"/>
+            <a:off x="3383280" y="5440680"/>
+            <a:ext cx="73152" cy="201168"/>
+          </a:xfrm>
+          <a:prstGeom prst="rect">
+            <a:avLst/>
+          </a:prstGeom>
+          <a:solidFill>
+            <a:srgbClr val="C79A52"/>
           </a:solidFill>
           <a:ln>
             <a:noFill/>
@@ -11670,14 +12492,14 @@
       </p:sp>
       <p:sp>
         <p:nvSpPr>
-          <p:cNvPr id="29" name="TextBox 28"/>
+          <p:cNvPr id="48" name="TextBox 47"/>
           <p:cNvSpPr txBox="1"/>
           <p:nvPr/>
         </p:nvSpPr>
         <p:spPr>
           <a:xfrm>
-            <a:off x="10789920" y="4407408"/>
-            <a:ext cx="640080" cy="320040"/>
+            <a:off x="10789920" y="5422392"/>
+            <a:ext cx="640080" cy="274320"/>
           </a:xfrm>
           <a:prstGeom prst="rect">
             <a:avLst/>
@@ -11699,27 +12521,199 @@
               </a:spcAft>
             </a:pPr>
             <a:r>
-              <a:rPr sz="1250" b="1" i="0">
+              <a:rPr sz="1150" b="1" i="0">
                 <a:solidFill>
                   <a:srgbClr val="162844"/>
                 </a:solidFill>
                 <a:latin typeface="Calibri"/>
               </a:rPr>
-              <a:t>93%</a:t>
-            </a:r>
-          </a:p>
-        </p:txBody>
-      </p:sp>
-      <p:sp>
-        <p:nvSpPr>
-          <p:cNvPr id="30" name="TextBox 29"/>
+              <a:t>0%</a:t>
+            </a:r>
+          </a:p>
+        </p:txBody>
+      </p:sp>
+      <p:sp>
+        <p:nvSpPr>
+          <p:cNvPr id="49" name="Rectangle 48"/>
+          <p:cNvSpPr/>
+          <p:nvPr/>
+        </p:nvSpPr>
+        <p:spPr>
+          <a:xfrm>
+            <a:off x="3383280" y="5696712"/>
+            <a:ext cx="7315200" cy="201168"/>
+          </a:xfrm>
+          <a:prstGeom prst="rect">
+            <a:avLst/>
+          </a:prstGeom>
+          <a:solidFill>
+            <a:srgbClr val="EAE6DA"/>
+          </a:solidFill>
+          <a:ln>
+            <a:noFill/>
+          </a:ln>
+          <a:effectLst/>
+        </p:spPr>
+        <p:style>
+          <a:lnRef idx="1">
+            <a:schemeClr val="accent1"/>
+          </a:lnRef>
+          <a:fillRef idx="3">
+            <a:schemeClr val="accent1"/>
+          </a:fillRef>
+          <a:effectRef idx="2">
+            <a:schemeClr val="accent1"/>
+          </a:effectRef>
+          <a:fontRef idx="minor">
+            <a:schemeClr val="lt1"/>
+          </a:fontRef>
+        </p:style>
+        <p:txBody>
+          <a:bodyPr rtlCol="0" anchor="ctr"/>
+          <a:lstStyle/>
+          <a:p>
+            <a:pPr algn="ctr"/>
+          </a:p>
+        </p:txBody>
+      </p:sp>
+      <p:sp>
+        <p:nvSpPr>
+          <p:cNvPr id="50" name="Rectangle 49"/>
+          <p:cNvSpPr/>
+          <p:nvPr/>
+        </p:nvSpPr>
+        <p:spPr>
+          <a:xfrm>
+            <a:off x="3383280" y="5696712"/>
+            <a:ext cx="73152" cy="201168"/>
+          </a:xfrm>
+          <a:prstGeom prst="rect">
+            <a:avLst/>
+          </a:prstGeom>
+          <a:solidFill>
+            <a:srgbClr val="5C8C86"/>
+          </a:solidFill>
+          <a:ln>
+            <a:noFill/>
+          </a:ln>
+          <a:effectLst/>
+        </p:spPr>
+        <p:style>
+          <a:lnRef idx="1">
+            <a:schemeClr val="accent1"/>
+          </a:lnRef>
+          <a:fillRef idx="3">
+            <a:schemeClr val="accent1"/>
+          </a:fillRef>
+          <a:effectRef idx="2">
+            <a:schemeClr val="accent1"/>
+          </a:effectRef>
+          <a:fontRef idx="minor">
+            <a:schemeClr val="lt1"/>
+          </a:fontRef>
+        </p:style>
+        <p:txBody>
+          <a:bodyPr rtlCol="0" anchor="ctr"/>
+          <a:lstStyle/>
+          <a:p>
+            <a:pPr algn="ctr"/>
+          </a:p>
+        </p:txBody>
+      </p:sp>
+      <p:sp>
+        <p:nvSpPr>
+          <p:cNvPr id="51" name="TextBox 50"/>
           <p:cNvSpPr txBox="1"/>
           <p:nvPr/>
         </p:nvSpPr>
         <p:spPr>
           <a:xfrm>
-            <a:off x="822960" y="4892040"/>
-            <a:ext cx="2331720" cy="365760"/>
+            <a:off x="10789920" y="5678424"/>
+            <a:ext cx="640080" cy="274320"/>
+          </a:xfrm>
+          <a:prstGeom prst="rect">
+            <a:avLst/>
+          </a:prstGeom>
+          <a:noFill/>
+        </p:spPr>
+        <p:txBody>
+          <a:bodyPr wrap="square" anchor="t" lIns="0" rIns="0" tIns="0" bIns="0">
+            <a:spAutoFit/>
+          </a:bodyPr>
+          <a:lstStyle/>
+          <a:p>
+            <a:pPr algn="l">
+              <a:lnSpc>
+                <a:spcPct val="100000"/>
+              </a:lnSpc>
+              <a:spcAft>
+                <a:spcPts val="0"/>
+              </a:spcAft>
+            </a:pPr>
+            <a:r>
+              <a:rPr sz="1150" b="1" i="0">
+                <a:solidFill>
+                  <a:srgbClr val="162844"/>
+                </a:solidFill>
+                <a:latin typeface="Calibri"/>
+              </a:rPr>
+              <a:t>0%</a:t>
+            </a:r>
+          </a:p>
+        </p:txBody>
+      </p:sp>
+      <p:sp>
+        <p:nvSpPr>
+          <p:cNvPr id="52" name="TextBox 51"/>
+          <p:cNvSpPr txBox="1"/>
+          <p:nvPr/>
+        </p:nvSpPr>
+        <p:spPr>
+          <a:xfrm>
+            <a:off x="822960" y="6053328"/>
+            <a:ext cx="10058400" cy="320040"/>
+          </a:xfrm>
+          <a:prstGeom prst="rect">
+            <a:avLst/>
+          </a:prstGeom>
+          <a:noFill/>
+        </p:spPr>
+        <p:txBody>
+          <a:bodyPr wrap="square" anchor="t" lIns="0" rIns="0" tIns="0" bIns="0">
+            <a:spAutoFit/>
+          </a:bodyPr>
+          <a:lstStyle/>
+          <a:p>
+            <a:pPr algn="l">
+              <a:lnSpc>
+                <a:spcPct val="100000"/>
+              </a:lnSpc>
+              <a:spcAft>
+                <a:spcPts val="0"/>
+              </a:spcAft>
+            </a:pPr>
+            <a:r>
+              <a:rPr sz="1200" b="0" i="1">
+                <a:solidFill>
+                  <a:srgbClr val="8B93A1"/>
+                </a:solidFill>
+                <a:latin typeface="Calibri"/>
+              </a:rPr>
+              <a:t>JUnit couvre la logique métier ; Cucumber couvre la couche REST — presque aucun recouvrement.</a:t>
+            </a:r>
+          </a:p>
+        </p:txBody>
+      </p:sp>
+      <p:sp>
+        <p:nvSpPr>
+          <p:cNvPr id="53" name="TextBox 52"/>
+          <p:cNvSpPr txBox="1"/>
+          <p:nvPr/>
+        </p:nvSpPr>
+        <p:spPr>
+          <a:xfrm>
+            <a:off x="11155680" y="6473952"/>
+            <a:ext cx="822960" cy="274320"/>
           </a:xfrm>
           <a:prstGeom prst="rect">
             <a:avLst/>
@@ -11741,178 +12735,6 @@
               </a:spcAft>
             </a:pPr>
             <a:r>
-              <a:rPr sz="1250" b="0" i="0">
-                <a:solidFill>
-                  <a:srgbClr val="162844"/>
-                </a:solidFill>
-                <a:latin typeface="Calibri"/>
-              </a:rPr>
-              <a:t>QuoteOfTheDayService</a:t>
-            </a:r>
-          </a:p>
-        </p:txBody>
-      </p:sp>
-      <p:sp>
-        <p:nvSpPr>
-          <p:cNvPr id="31" name="Rectangle 30"/>
-          <p:cNvSpPr/>
-          <p:nvPr/>
-        </p:nvSpPr>
-        <p:spPr>
-          <a:xfrm>
-            <a:off x="3291840" y="4864608"/>
-            <a:ext cx="7406640" cy="310896"/>
-          </a:xfrm>
-          <a:prstGeom prst="rect">
-            <a:avLst/>
-          </a:prstGeom>
-          <a:solidFill>
-            <a:srgbClr val="EAE6DA"/>
-          </a:solidFill>
-          <a:ln>
-            <a:noFill/>
-          </a:ln>
-          <a:effectLst/>
-        </p:spPr>
-        <p:style>
-          <a:lnRef idx="1">
-            <a:schemeClr val="accent1"/>
-          </a:lnRef>
-          <a:fillRef idx="3">
-            <a:schemeClr val="accent1"/>
-          </a:fillRef>
-          <a:effectRef idx="2">
-            <a:schemeClr val="accent1"/>
-          </a:effectRef>
-          <a:fontRef idx="minor">
-            <a:schemeClr val="lt1"/>
-          </a:fontRef>
-        </p:style>
-        <p:txBody>
-          <a:bodyPr rtlCol="0" anchor="ctr"/>
-          <a:lstStyle/>
-          <a:p>
-            <a:pPr algn="ctr"/>
-          </a:p>
-        </p:txBody>
-      </p:sp>
-      <p:sp>
-        <p:nvSpPr>
-          <p:cNvPr id="32" name="Rectangle 31"/>
-          <p:cNvSpPr/>
-          <p:nvPr/>
-        </p:nvSpPr>
-        <p:spPr>
-          <a:xfrm>
-            <a:off x="3291840" y="4864608"/>
-            <a:ext cx="7406640" cy="310896"/>
-          </a:xfrm>
-          <a:prstGeom prst="rect">
-            <a:avLst/>
-          </a:prstGeom>
-          <a:solidFill>
-            <a:srgbClr val="839B74"/>
-          </a:solidFill>
-          <a:ln>
-            <a:noFill/>
-          </a:ln>
-          <a:effectLst/>
-        </p:spPr>
-        <p:style>
-          <a:lnRef idx="1">
-            <a:schemeClr val="accent1"/>
-          </a:lnRef>
-          <a:fillRef idx="3">
-            <a:schemeClr val="accent1"/>
-          </a:fillRef>
-          <a:effectRef idx="2">
-            <a:schemeClr val="accent1"/>
-          </a:effectRef>
-          <a:fontRef idx="minor">
-            <a:schemeClr val="lt1"/>
-          </a:fontRef>
-        </p:style>
-        <p:txBody>
-          <a:bodyPr rtlCol="0" anchor="ctr"/>
-          <a:lstStyle/>
-          <a:p>
-            <a:pPr algn="ctr"/>
-          </a:p>
-        </p:txBody>
-      </p:sp>
-      <p:sp>
-        <p:nvSpPr>
-          <p:cNvPr id="33" name="TextBox 32"/>
-          <p:cNvSpPr txBox="1"/>
-          <p:nvPr/>
-        </p:nvSpPr>
-        <p:spPr>
-          <a:xfrm>
-            <a:off x="10789920" y="4882896"/>
-            <a:ext cx="640080" cy="320040"/>
-          </a:xfrm>
-          <a:prstGeom prst="rect">
-            <a:avLst/>
-          </a:prstGeom>
-          <a:noFill/>
-        </p:spPr>
-        <p:txBody>
-          <a:bodyPr wrap="square" anchor="t" lIns="0" rIns="0" tIns="0" bIns="0">
-            <a:spAutoFit/>
-          </a:bodyPr>
-          <a:lstStyle/>
-          <a:p>
-            <a:pPr algn="l">
-              <a:lnSpc>
-                <a:spcPct val="100000"/>
-              </a:lnSpc>
-              <a:spcAft>
-                <a:spcPts val="0"/>
-              </a:spcAft>
-            </a:pPr>
-            <a:r>
-              <a:rPr sz="1250" b="1" i="0">
-                <a:solidFill>
-                  <a:srgbClr val="162844"/>
-                </a:solidFill>
-                <a:latin typeface="Calibri"/>
-              </a:rPr>
-              <a:t>100%</a:t>
-            </a:r>
-          </a:p>
-        </p:txBody>
-      </p:sp>
-      <p:sp>
-        <p:nvSpPr>
-          <p:cNvPr id="34" name="TextBox 33"/>
-          <p:cNvSpPr txBox="1"/>
-          <p:nvPr/>
-        </p:nvSpPr>
-        <p:spPr>
-          <a:xfrm>
-            <a:off x="11155680" y="6473952"/>
-            <a:ext cx="822960" cy="274320"/>
-          </a:xfrm>
-          <a:prstGeom prst="rect">
-            <a:avLst/>
-          </a:prstGeom>
-          <a:noFill/>
-        </p:spPr>
-        <p:txBody>
-          <a:bodyPr wrap="square" anchor="t" lIns="0" rIns="0" tIns="0" bIns="0">
-            <a:spAutoFit/>
-          </a:bodyPr>
-          <a:lstStyle/>
-          <a:p>
-            <a:pPr algn="r">
-              <a:lnSpc>
-                <a:spcPct val="100000"/>
-              </a:lnSpc>
-              <a:spcAft>
-                <a:spcPts val="0"/>
-              </a:spcAft>
-            </a:pPr>
-            <a:r>
               <a:rPr sz="1000" b="0" i="0">
                 <a:solidFill>
                   <a:srgbClr val="8B93A1"/>
@@ -11926,7 +12748,7 @@
       </p:sp>
       <p:sp>
         <p:nvSpPr>
-          <p:cNvPr id="35" name="TextBox 34"/>
+          <p:cNvPr id="54" name="TextBox 53"/>
           <p:cNvSpPr txBox="1"/>
           <p:nvPr/>
         </p:nvSpPr>
@@ -12285,7 +13107,7 @@
                 </a:solidFill>
                 <a:latin typeface="Calibri"/>
               </a:rPr>
-              <a:t>Build + JUnit + Cucumber + rapport Jacoco généré automatiquement.</a:t>
+              <a:t>Build + JUnit + Cucumber + 3 rapports Jacoco générés automatiquement.</a:t>
             </a:r>
           </a:p>
         </p:txBody>
@@ -12455,7 +13277,7 @@
                 </a:solidFill>
                 <a:latin typeface="Calibri"/>
               </a:rPr>
-              <a:t>Le récap coloré, classe par classe, directement dans le terminal.</a:t>
+              <a:t>Le récap coloré JUnit / Cucumber / global, côte à côte, dans le terminal.</a:t>
             </a:r>
           </a:p>
         </p:txBody>
@@ -12625,7 +13447,7 @@
                 </a:solidFill>
                 <a:latin typeface="Calibri"/>
               </a:rPr>
-              <a:t>Le détail ligne par ligne, pour creuser une classe en particulier.</a:t>
+              <a:t>Le détail ligne par ligne — et les variantes -junit / -cucumber pour comparer.</a:t>
             </a:r>
           </a:p>
         </p:txBody>

</xml_diff>

<commit_message>
Integrer SonarQube pour visualiser la couverture Jacoco
Ajoute sonar-maven-plugin (invocation manuelle, non lie au lifecycle) qui
importe directement les rapports Jacoco XML JUnit + Cucumber et recalcule
leur union. sonarqube/docker-compose.yml permet de lancer une instance
Community locale pour la demo, sans compte SonarCloud. Integration validee
de bout en bout (77.7% de couverture globale remontee dans Sonar, coherent
avec le rapport jacoco-report fusionne).

Documentation (CLAUDE.md, DESCRIPTION.md, PROMPT.md) et presentation mises
a jour avec la procedure de validation et une nouvelle slide bonus.

Co-Authored-By: Claude Sonnet 5 <noreply@anthropic.com>
Claude-Session: https://claude.ai/code/session_01UJ8K2KSjB3mCiTjCx3LvFL
</commit_message>
<xml_diff>
--- a/presentation/couverture-code-conference.pptx
+++ b/presentation/couverture-code-conference.pptx
@@ -15,6 +15,7 @@
     <p:sldId id="263" r:id="rId14"/>
     <p:sldId id="264" r:id="rId15"/>
     <p:sldId id="265" r:id="rId16"/>
+    <p:sldId id="266" r:id="rId17"/>
   </p:sldIdLst>
   <p:sldSz cx="12191695" cy="6858000" type="screen4x3"/>
   <p:notesSz cx="6858000" cy="9144000"/>
@@ -4684,6 +4685,578 @@
       <p:grpSpPr/>
       <p:sp>
         <p:nvSpPr>
+          <p:cNvPr id="2" name="TextBox 1"/>
+          <p:cNvSpPr txBox="1"/>
+          <p:nvPr/>
+        </p:nvSpPr>
+        <p:spPr>
+          <a:xfrm>
+            <a:off x="822960" y="548640"/>
+            <a:ext cx="7315200" cy="365760"/>
+          </a:xfrm>
+          <a:prstGeom prst="rect">
+            <a:avLst/>
+          </a:prstGeom>
+          <a:noFill/>
+        </p:spPr>
+        <p:txBody>
+          <a:bodyPr wrap="square" anchor="t" lIns="0" rIns="0" tIns="0" bIns="0">
+            <a:spAutoFit/>
+          </a:bodyPr>
+          <a:lstStyle/>
+          <a:p>
+            <a:pPr algn="l">
+              <a:lnSpc>
+                <a:spcPct val="100000"/>
+              </a:lnSpc>
+              <a:spcAft>
+                <a:spcPts val="0"/>
+              </a:spcAft>
+            </a:pPr>
+            <a:r>
+              <a:rPr sz="1300" b="1" i="0">
+                <a:solidFill>
+                  <a:srgbClr val="C79A52"/>
+                </a:solidFill>
+                <a:latin typeface="Calibri"/>
+              </a:rPr>
+              <a:t>À RETENIR</a:t>
+            </a:r>
+          </a:p>
+        </p:txBody>
+      </p:sp>
+      <p:sp>
+        <p:nvSpPr>
+          <p:cNvPr id="3" name="TextBox 2"/>
+          <p:cNvSpPr txBox="1"/>
+          <p:nvPr/>
+        </p:nvSpPr>
+        <p:spPr>
+          <a:xfrm>
+            <a:off x="822960" y="868680"/>
+            <a:ext cx="10058400" cy="822960"/>
+          </a:xfrm>
+          <a:prstGeom prst="rect">
+            <a:avLst/>
+          </a:prstGeom>
+          <a:noFill/>
+        </p:spPr>
+        <p:txBody>
+          <a:bodyPr wrap="square" anchor="t" lIns="0" rIns="0" tIns="0" bIns="0">
+            <a:spAutoFit/>
+          </a:bodyPr>
+          <a:lstStyle/>
+          <a:p>
+            <a:pPr algn="l">
+              <a:lnSpc>
+                <a:spcPct val="100000"/>
+              </a:lnSpc>
+              <a:spcAft>
+                <a:spcPts val="0"/>
+              </a:spcAft>
+            </a:pPr>
+            <a:r>
+              <a:rPr sz="3200" b="1" i="0">
+                <a:solidFill>
+                  <a:srgbClr val="EFECE3"/>
+                </a:solidFill>
+                <a:latin typeface="Calibri"/>
+              </a:rPr>
+              <a:t>Ce qu'il faut retenir</a:t>
+            </a:r>
+          </a:p>
+        </p:txBody>
+      </p:sp>
+      <p:sp>
+        <p:nvSpPr>
+          <p:cNvPr id="4" name="TextBox 3"/>
+          <p:cNvSpPr txBox="1"/>
+          <p:nvPr/>
+        </p:nvSpPr>
+        <p:spPr>
+          <a:xfrm>
+            <a:off x="822960" y="2103120"/>
+            <a:ext cx="1097280" cy="1097280"/>
+          </a:xfrm>
+          <a:prstGeom prst="rect">
+            <a:avLst/>
+          </a:prstGeom>
+          <a:noFill/>
+        </p:spPr>
+        <p:txBody>
+          <a:bodyPr wrap="square" anchor="t" lIns="0" rIns="0" tIns="0" bIns="0">
+            <a:spAutoFit/>
+          </a:bodyPr>
+          <a:lstStyle/>
+          <a:p>
+            <a:pPr algn="l">
+              <a:lnSpc>
+                <a:spcPct val="100000"/>
+              </a:lnSpc>
+              <a:spcAft>
+                <a:spcPts val="0"/>
+              </a:spcAft>
+            </a:pPr>
+            <a:r>
+              <a:rPr sz="3400" b="1" i="0">
+                <a:solidFill>
+                  <a:srgbClr val="C79A52"/>
+                </a:solidFill>
+                <a:latin typeface="Calibri"/>
+              </a:rPr>
+              <a:t>01</a:t>
+            </a:r>
+          </a:p>
+        </p:txBody>
+      </p:sp>
+      <p:sp>
+        <p:nvSpPr>
+          <p:cNvPr id="5" name="TextBox 4"/>
+          <p:cNvSpPr txBox="1"/>
+          <p:nvPr/>
+        </p:nvSpPr>
+        <p:spPr>
+          <a:xfrm>
+            <a:off x="2011680" y="2148840"/>
+            <a:ext cx="8961120" cy="502920"/>
+          </a:xfrm>
+          <a:prstGeom prst="rect">
+            <a:avLst/>
+          </a:prstGeom>
+          <a:noFill/>
+        </p:spPr>
+        <p:txBody>
+          <a:bodyPr wrap="square" anchor="t" lIns="0" rIns="0" tIns="0" bIns="0">
+            <a:spAutoFit/>
+          </a:bodyPr>
+          <a:lstStyle/>
+          <a:p>
+            <a:pPr algn="l">
+              <a:lnSpc>
+                <a:spcPct val="100000"/>
+              </a:lnSpc>
+              <a:spcAft>
+                <a:spcPts val="0"/>
+              </a:spcAft>
+            </a:pPr>
+            <a:r>
+              <a:rPr sz="1800" b="1" i="0">
+                <a:solidFill>
+                  <a:srgbClr val="EFECE3"/>
+                </a:solidFill>
+                <a:latin typeface="Calibri"/>
+              </a:rPr>
+              <a:t>Un test vert ne dit pas ce qu'il a vérifié.</a:t>
+            </a:r>
+          </a:p>
+        </p:txBody>
+      </p:sp>
+      <p:sp>
+        <p:nvSpPr>
+          <p:cNvPr id="6" name="TextBox 5"/>
+          <p:cNvSpPr txBox="1"/>
+          <p:nvPr/>
+        </p:nvSpPr>
+        <p:spPr>
+          <a:xfrm>
+            <a:off x="2011680" y="2633472"/>
+            <a:ext cx="8961120" cy="457200"/>
+          </a:xfrm>
+          <a:prstGeom prst="rect">
+            <a:avLst/>
+          </a:prstGeom>
+          <a:noFill/>
+        </p:spPr>
+        <p:txBody>
+          <a:bodyPr wrap="square" anchor="t" lIns="0" rIns="0" tIns="0" bIns="0">
+            <a:spAutoFit/>
+          </a:bodyPr>
+          <a:lstStyle/>
+          <a:p>
+            <a:pPr algn="l">
+              <a:lnSpc>
+                <a:spcPct val="100000"/>
+              </a:lnSpc>
+              <a:spcAft>
+                <a:spcPts val="0"/>
+              </a:spcAft>
+            </a:pPr>
+            <a:r>
+              <a:rPr sz="1400" b="0" i="0">
+                <a:solidFill>
+                  <a:srgbClr val="8B93A1"/>
+                </a:solidFill>
+                <a:latin typeface="Calibri"/>
+              </a:rPr>
+              <a:t>La couverture, si.</a:t>
+            </a:r>
+          </a:p>
+        </p:txBody>
+      </p:sp>
+      <p:sp>
+        <p:nvSpPr>
+          <p:cNvPr id="7" name="TextBox 6"/>
+          <p:cNvSpPr txBox="1"/>
+          <p:nvPr/>
+        </p:nvSpPr>
+        <p:spPr>
+          <a:xfrm>
+            <a:off x="822960" y="3429000"/>
+            <a:ext cx="1097280" cy="1097280"/>
+          </a:xfrm>
+          <a:prstGeom prst="rect">
+            <a:avLst/>
+          </a:prstGeom>
+          <a:noFill/>
+        </p:spPr>
+        <p:txBody>
+          <a:bodyPr wrap="square" anchor="t" lIns="0" rIns="0" tIns="0" bIns="0">
+            <a:spAutoFit/>
+          </a:bodyPr>
+          <a:lstStyle/>
+          <a:p>
+            <a:pPr algn="l">
+              <a:lnSpc>
+                <a:spcPct val="100000"/>
+              </a:lnSpc>
+              <a:spcAft>
+                <a:spcPts val="0"/>
+              </a:spcAft>
+            </a:pPr>
+            <a:r>
+              <a:rPr sz="3400" b="1" i="0">
+                <a:solidFill>
+                  <a:srgbClr val="C79A52"/>
+                </a:solidFill>
+                <a:latin typeface="Calibri"/>
+              </a:rPr>
+              <a:t>02</a:t>
+            </a:r>
+          </a:p>
+        </p:txBody>
+      </p:sp>
+      <p:sp>
+        <p:nvSpPr>
+          <p:cNvPr id="8" name="TextBox 7"/>
+          <p:cNvSpPr txBox="1"/>
+          <p:nvPr/>
+        </p:nvSpPr>
+        <p:spPr>
+          <a:xfrm>
+            <a:off x="2011680" y="3474720"/>
+            <a:ext cx="8961120" cy="502920"/>
+          </a:xfrm>
+          <a:prstGeom prst="rect">
+            <a:avLst/>
+          </a:prstGeom>
+          <a:noFill/>
+        </p:spPr>
+        <p:txBody>
+          <a:bodyPr wrap="square" anchor="t" lIns="0" rIns="0" tIns="0" bIns="0">
+            <a:spAutoFit/>
+          </a:bodyPr>
+          <a:lstStyle/>
+          <a:p>
+            <a:pPr algn="l">
+              <a:lnSpc>
+                <a:spcPct val="100000"/>
+              </a:lnSpc>
+              <a:spcAft>
+                <a:spcPts val="0"/>
+              </a:spcAft>
+            </a:pPr>
+            <a:r>
+              <a:rPr sz="1800" b="1" i="0">
+                <a:solidFill>
+                  <a:srgbClr val="EFECE3"/>
+                </a:solidFill>
+                <a:latin typeface="Calibri"/>
+              </a:rPr>
+              <a:t>JUnit et Cucumber répondent à deux questions différentes.</a:t>
+            </a:r>
+          </a:p>
+        </p:txBody>
+      </p:sp>
+      <p:sp>
+        <p:nvSpPr>
+          <p:cNvPr id="9" name="TextBox 8"/>
+          <p:cNvSpPr txBox="1"/>
+          <p:nvPr/>
+        </p:nvSpPr>
+        <p:spPr>
+          <a:xfrm>
+            <a:off x="2011680" y="3959352"/>
+            <a:ext cx="8961120" cy="457200"/>
+          </a:xfrm>
+          <a:prstGeom prst="rect">
+            <a:avLst/>
+          </a:prstGeom>
+          <a:noFill/>
+        </p:spPr>
+        <p:txBody>
+          <a:bodyPr wrap="square" anchor="t" lIns="0" rIns="0" tIns="0" bIns="0">
+            <a:spAutoFit/>
+          </a:bodyPr>
+          <a:lstStyle/>
+          <a:p>
+            <a:pPr algn="l">
+              <a:lnSpc>
+                <a:spcPct val="100000"/>
+              </a:lnSpc>
+              <a:spcAft>
+                <a:spcPts val="0"/>
+              </a:spcAft>
+            </a:pPr>
+            <a:r>
+              <a:rPr sz="1400" b="0" i="0">
+                <a:solidFill>
+                  <a:srgbClr val="8B93A1"/>
+                </a:solidFill>
+                <a:latin typeface="Calibri"/>
+              </a:rPr>
+              <a:t>« Ça marche ? » contre « c'est le bon comportement ? »</a:t>
+            </a:r>
+          </a:p>
+        </p:txBody>
+      </p:sp>
+      <p:sp>
+        <p:nvSpPr>
+          <p:cNvPr id="10" name="TextBox 9"/>
+          <p:cNvSpPr txBox="1"/>
+          <p:nvPr/>
+        </p:nvSpPr>
+        <p:spPr>
+          <a:xfrm>
+            <a:off x="822960" y="4754880"/>
+            <a:ext cx="1097280" cy="1097280"/>
+          </a:xfrm>
+          <a:prstGeom prst="rect">
+            <a:avLst/>
+          </a:prstGeom>
+          <a:noFill/>
+        </p:spPr>
+        <p:txBody>
+          <a:bodyPr wrap="square" anchor="t" lIns="0" rIns="0" tIns="0" bIns="0">
+            <a:spAutoFit/>
+          </a:bodyPr>
+          <a:lstStyle/>
+          <a:p>
+            <a:pPr algn="l">
+              <a:lnSpc>
+                <a:spcPct val="100000"/>
+              </a:lnSpc>
+              <a:spcAft>
+                <a:spcPts val="0"/>
+              </a:spcAft>
+            </a:pPr>
+            <a:r>
+              <a:rPr sz="3400" b="1" i="0">
+                <a:solidFill>
+                  <a:srgbClr val="C79A52"/>
+                </a:solidFill>
+                <a:latin typeface="Calibri"/>
+              </a:rPr>
+              <a:t>03</a:t>
+            </a:r>
+          </a:p>
+        </p:txBody>
+      </p:sp>
+      <p:sp>
+        <p:nvSpPr>
+          <p:cNvPr id="11" name="TextBox 10"/>
+          <p:cNvSpPr txBox="1"/>
+          <p:nvPr/>
+        </p:nvSpPr>
+        <p:spPr>
+          <a:xfrm>
+            <a:off x="2011680" y="4800600"/>
+            <a:ext cx="8961120" cy="502920"/>
+          </a:xfrm>
+          <a:prstGeom prst="rect">
+            <a:avLst/>
+          </a:prstGeom>
+          <a:noFill/>
+        </p:spPr>
+        <p:txBody>
+          <a:bodyPr wrap="square" anchor="t" lIns="0" rIns="0" tIns="0" bIns="0">
+            <a:spAutoFit/>
+          </a:bodyPr>
+          <a:lstStyle/>
+          <a:p>
+            <a:pPr algn="l">
+              <a:lnSpc>
+                <a:spcPct val="100000"/>
+              </a:lnSpc>
+              <a:spcAft>
+                <a:spcPts val="0"/>
+              </a:spcAft>
+            </a:pPr>
+            <a:r>
+              <a:rPr sz="1800" b="1" i="0">
+                <a:solidFill>
+                  <a:srgbClr val="EFECE3"/>
+                </a:solidFill>
+                <a:latin typeface="Calibri"/>
+              </a:rPr>
+              <a:t>Le rapport de couverture n'est pas un objectif.</a:t>
+            </a:r>
+          </a:p>
+        </p:txBody>
+      </p:sp>
+      <p:sp>
+        <p:nvSpPr>
+          <p:cNvPr id="12" name="TextBox 11"/>
+          <p:cNvSpPr txBox="1"/>
+          <p:nvPr/>
+        </p:nvSpPr>
+        <p:spPr>
+          <a:xfrm>
+            <a:off x="2011680" y="5285232"/>
+            <a:ext cx="8961120" cy="457200"/>
+          </a:xfrm>
+          <a:prstGeom prst="rect">
+            <a:avLst/>
+          </a:prstGeom>
+          <a:noFill/>
+        </p:spPr>
+        <p:txBody>
+          <a:bodyPr wrap="square" anchor="t" lIns="0" rIns="0" tIns="0" bIns="0">
+            <a:spAutoFit/>
+          </a:bodyPr>
+          <a:lstStyle/>
+          <a:p>
+            <a:pPr algn="l">
+              <a:lnSpc>
+                <a:spcPct val="100000"/>
+              </a:lnSpc>
+              <a:spcAft>
+                <a:spcPts val="0"/>
+              </a:spcAft>
+            </a:pPr>
+            <a:r>
+              <a:rPr sz="1400" b="0" i="0">
+                <a:solidFill>
+                  <a:srgbClr val="8B93A1"/>
+                </a:solidFill>
+                <a:latin typeface="Calibri"/>
+              </a:rPr>
+              <a:t>C'est un radar : il montre où regarder en premier.</a:t>
+            </a:r>
+          </a:p>
+        </p:txBody>
+      </p:sp>
+      <p:sp>
+        <p:nvSpPr>
+          <p:cNvPr id="13" name="TextBox 12"/>
+          <p:cNvSpPr txBox="1"/>
+          <p:nvPr/>
+        </p:nvSpPr>
+        <p:spPr>
+          <a:xfrm>
+            <a:off x="11155680" y="6473952"/>
+            <a:ext cx="822960" cy="274320"/>
+          </a:xfrm>
+          <a:prstGeom prst="rect">
+            <a:avLst/>
+          </a:prstGeom>
+          <a:noFill/>
+        </p:spPr>
+        <p:txBody>
+          <a:bodyPr wrap="square" anchor="t" lIns="0" rIns="0" tIns="0" bIns="0">
+            <a:spAutoFit/>
+          </a:bodyPr>
+          <a:lstStyle/>
+          <a:p>
+            <a:pPr algn="r">
+              <a:lnSpc>
+                <a:spcPct val="100000"/>
+              </a:lnSpc>
+              <a:spcAft>
+                <a:spcPts val="0"/>
+              </a:spcAft>
+            </a:pPr>
+            <a:r>
+              <a:rPr sz="1000" b="0" i="0">
+                <a:solidFill>
+                  <a:srgbClr val="6E7A8E"/>
+                </a:solidFill>
+                <a:latin typeface="Calibri"/>
+              </a:rPr>
+              <a:t>10 / 11</a:t>
+            </a:r>
+          </a:p>
+        </p:txBody>
+      </p:sp>
+      <p:sp>
+        <p:nvSpPr>
+          <p:cNvPr id="14" name="TextBox 13"/>
+          <p:cNvSpPr txBox="1"/>
+          <p:nvPr/>
+        </p:nvSpPr>
+        <p:spPr>
+          <a:xfrm>
+            <a:off x="502920" y="6473952"/>
+            <a:ext cx="3657600" cy="274320"/>
+          </a:xfrm>
+          <a:prstGeom prst="rect">
+            <a:avLst/>
+          </a:prstGeom>
+          <a:noFill/>
+        </p:spPr>
+        <p:txBody>
+          <a:bodyPr wrap="square" anchor="t" lIns="0" rIns="0" tIns="0" bIns="0">
+            <a:spAutoFit/>
+          </a:bodyPr>
+          <a:lstStyle/>
+          <a:p>
+            <a:pPr algn="l">
+              <a:lnSpc>
+                <a:spcPct val="100000"/>
+              </a:lnSpc>
+              <a:spcAft>
+                <a:spcPts val="0"/>
+              </a:spcAft>
+            </a:pPr>
+            <a:r>
+              <a:rPr sz="800" b="0" i="0">
+                <a:solidFill>
+                  <a:srgbClr val="6E7A8E"/>
+                </a:solidFill>
+                <a:latin typeface="Calibri"/>
+              </a:rPr>
+              <a:t>COUVERTURE DE CODE — QUARKUS · JUNIT · CUCUMBER · JACOCO</a:t>
+            </a:r>
+          </a:p>
+        </p:txBody>
+      </p:sp>
+    </p:spTree>
+  </p:cSld>
+  <p:clrMapOvr>
+    <a:masterClrMapping/>
+  </p:clrMapOvr>
+</p:sld>
+</file>
+
+<file path=ppt/slides/slide11.xml><?xml version="1.0" encoding="utf-8"?>
+<p:sld xmlns:a="http://schemas.openxmlformats.org/drawingml/2006/main" xmlns:p="http://schemas.openxmlformats.org/presentationml/2006/main" xmlns:r="http://schemas.openxmlformats.org/officeDocument/2006/relationships">
+  <p:cSld>
+    <p:bg>
+      <p:bgPr>
+        <a:solidFill>
+          <a:srgbClr val="0B1D36"/>
+        </a:solidFill>
+        <a:effectLst/>
+      </p:bgPr>
+    </p:bg>
+    <p:spTree>
+      <p:nvGrpSpPr>
+        <p:cNvPr id="1" name=""/>
+        <p:cNvGrpSpPr/>
+        <p:nvPr/>
+      </p:nvGrpSpPr>
+      <p:grpSpPr/>
+      <p:sp>
+        <p:nvSpPr>
           <p:cNvPr id="2" name="Oval 1"/>
           <p:cNvSpPr/>
           <p:nvPr/>
@@ -6961,7 +7534,7 @@
                 </a:solidFill>
                 <a:latin typeface="Calibri"/>
               </a:rPr>
-              <a:t>02 / 10</a:t>
+              <a:t>02 / 11</a:t>
             </a:r>
           </a:p>
         </p:txBody>
@@ -7963,7 +8536,7 @@
                 </a:solidFill>
                 <a:latin typeface="Calibri"/>
               </a:rPr>
-              <a:t>03 / 10</a:t>
+              <a:t>03 / 11</a:t>
             </a:r>
           </a:p>
         </p:txBody>
@@ -9399,7 +9972,7 @@
                 </a:solidFill>
                 <a:latin typeface="Calibri"/>
               </a:rPr>
-              <a:t>04 / 10</a:t>
+              <a:t>04 / 11</a:t>
             </a:r>
           </a:p>
         </p:txBody>
@@ -9898,7 +10471,7 @@
                 </a:solidFill>
                 <a:latin typeface="Calibri"/>
               </a:rPr>
-              <a:t>05 / 10</a:t>
+              <a:t>05 / 11</a:t>
             </a:r>
           </a:p>
         </p:txBody>
@@ -10435,7 +11008,7 @@
                 </a:solidFill>
                 <a:latin typeface="Calibri"/>
               </a:rPr>
-              <a:t>06 / 10</a:t>
+              <a:t>06 / 11</a:t>
             </a:r>
           </a:p>
         </p:txBody>
@@ -12741,7 +13314,7 @@
                 </a:solidFill>
                 <a:latin typeface="Calibri"/>
               </a:rPr>
-              <a:t>07 / 10</a:t>
+              <a:t>07 / 11</a:t>
             </a:r>
           </a:p>
         </p:txBody>
@@ -13489,7 +14062,7 @@
                 </a:solidFill>
                 <a:latin typeface="Calibri"/>
               </a:rPr>
-              <a:t>08 / 10</a:t>
+              <a:t>08 / 11</a:t>
             </a:r>
           </a:p>
         </p:txBody>
@@ -13599,7 +14172,7 @@
                 </a:solidFill>
                 <a:latin typeface="Calibri"/>
               </a:rPr>
-              <a:t>À RETENIR</a:t>
+              <a:t>BONUS</a:t>
             </a:r>
           </a:p>
         </p:txBody>
@@ -13635,13 +14208,13 @@
               </a:spcAft>
             </a:pPr>
             <a:r>
-              <a:rPr sz="3200" b="1" i="0">
+              <a:rPr sz="3000" b="1" i="0">
                 <a:solidFill>
                   <a:srgbClr val="EFECE3"/>
                 </a:solidFill>
                 <a:latin typeface="Calibri"/>
               </a:rPr>
-              <a:t>Ce qu'il faut retenir</a:t>
+              <a:t>Et dans un vrai dashboard ?</a:t>
             </a:r>
           </a:p>
         </p:txBody>
@@ -13654,8 +14227,8 @@
         </p:nvSpPr>
         <p:spPr>
           <a:xfrm>
-            <a:off x="822960" y="2103120"/>
-            <a:ext cx="1097280" cy="1097280"/>
+            <a:off x="822960" y="1536192"/>
+            <a:ext cx="9875520" cy="457200"/>
           </a:xfrm>
           <a:prstGeom prst="rect">
             <a:avLst/>
@@ -13677,27 +14250,543 @@
               </a:spcAft>
             </a:pPr>
             <a:r>
-              <a:rPr sz="3400" b="1" i="0">
-                <a:solidFill>
-                  <a:srgbClr val="C79A52"/>
+              <a:rPr sz="1400" b="0" i="0">
+                <a:solidFill>
+                  <a:srgbClr val="C8CFDA"/>
                 </a:solidFill>
                 <a:latin typeface="Calibri"/>
               </a:rPr>
-              <a:t>01</a:t>
-            </a:r>
-          </a:p>
-        </p:txBody>
-      </p:sp>
-      <p:sp>
-        <p:nvSpPr>
-          <p:cNvPr id="5" name="TextBox 4"/>
+              <a:t>Les deux mêmes rapports Jacoco XML, importés tels quels dans SonarQube.</a:t>
+            </a:r>
+          </a:p>
+        </p:txBody>
+      </p:sp>
+      <p:sp>
+        <p:nvSpPr>
+          <p:cNvPr id="5" name="Rectangle 4"/>
+          <p:cNvSpPr/>
+          <p:nvPr/>
+        </p:nvSpPr>
+        <p:spPr>
+          <a:xfrm>
+            <a:off x="822960" y="2286000"/>
+            <a:ext cx="3310128" cy="1554480"/>
+          </a:xfrm>
+          <a:prstGeom prst="rect">
+            <a:avLst/>
+          </a:prstGeom>
+          <a:solidFill>
+            <a:srgbClr val="183359"/>
+          </a:solidFill>
+          <a:ln>
+            <a:noFill/>
+          </a:ln>
+          <a:effectLst/>
+        </p:spPr>
+        <p:style>
+          <a:lnRef idx="1">
+            <a:schemeClr val="accent1"/>
+          </a:lnRef>
+          <a:fillRef idx="3">
+            <a:schemeClr val="accent1"/>
+          </a:fillRef>
+          <a:effectRef idx="2">
+            <a:schemeClr val="accent1"/>
+          </a:effectRef>
+          <a:fontRef idx="minor">
+            <a:schemeClr val="lt1"/>
+          </a:fontRef>
+        </p:style>
+        <p:txBody>
+          <a:bodyPr rtlCol="0" anchor="ctr"/>
+          <a:lstStyle/>
+          <a:p>
+            <a:pPr algn="ctr"/>
+          </a:p>
+        </p:txBody>
+      </p:sp>
+      <p:sp>
+        <p:nvSpPr>
+          <p:cNvPr id="6" name="Rectangle 5"/>
+          <p:cNvSpPr/>
+          <p:nvPr/>
+        </p:nvSpPr>
+        <p:spPr>
+          <a:xfrm>
+            <a:off x="822960" y="2286000"/>
+            <a:ext cx="3310128" cy="64008"/>
+          </a:xfrm>
+          <a:prstGeom prst="rect">
+            <a:avLst/>
+          </a:prstGeom>
+          <a:solidFill>
+            <a:srgbClr val="C79A52"/>
+          </a:solidFill>
+          <a:ln>
+            <a:noFill/>
+          </a:ln>
+          <a:effectLst/>
+        </p:spPr>
+        <p:style>
+          <a:lnRef idx="1">
+            <a:schemeClr val="accent1"/>
+          </a:lnRef>
+          <a:fillRef idx="3">
+            <a:schemeClr val="accent1"/>
+          </a:fillRef>
+          <a:effectRef idx="2">
+            <a:schemeClr val="accent1"/>
+          </a:effectRef>
+          <a:fontRef idx="minor">
+            <a:schemeClr val="lt1"/>
+          </a:fontRef>
+        </p:style>
+        <p:txBody>
+          <a:bodyPr rtlCol="0" anchor="ctr"/>
+          <a:lstStyle/>
+          <a:p>
+            <a:pPr algn="ctr"/>
+          </a:p>
+        </p:txBody>
+      </p:sp>
+      <p:sp>
+        <p:nvSpPr>
+          <p:cNvPr id="7" name="TextBox 6"/>
           <p:cNvSpPr txBox="1"/>
           <p:nvPr/>
         </p:nvSpPr>
         <p:spPr>
           <a:xfrm>
-            <a:off x="2011680" y="2148840"/>
-            <a:ext cx="8961120" cy="502920"/>
+            <a:off x="822960" y="2542032"/>
+            <a:ext cx="3310128" cy="685800"/>
+          </a:xfrm>
+          <a:prstGeom prst="rect">
+            <a:avLst/>
+          </a:prstGeom>
+          <a:noFill/>
+        </p:spPr>
+        <p:txBody>
+          <a:bodyPr wrap="square" anchor="t" lIns="0" rIns="0" tIns="0" bIns="0">
+            <a:spAutoFit/>
+          </a:bodyPr>
+          <a:lstStyle/>
+          <a:p>
+            <a:pPr algn="ctr">
+              <a:lnSpc>
+                <a:spcPct val="100000"/>
+              </a:lnSpc>
+              <a:spcAft>
+                <a:spcPts val="0"/>
+              </a:spcAft>
+            </a:pPr>
+            <a:r>
+              <a:rPr sz="4000" b="1" i="0">
+                <a:solidFill>
+                  <a:srgbClr val="C79A52"/>
+                </a:solidFill>
+                <a:latin typeface="Calibri"/>
+              </a:rPr>
+              <a:t>77,7 %</a:t>
+            </a:r>
+          </a:p>
+        </p:txBody>
+      </p:sp>
+      <p:sp>
+        <p:nvSpPr>
+          <p:cNvPr id="8" name="TextBox 7"/>
+          <p:cNvSpPr txBox="1"/>
+          <p:nvPr/>
+        </p:nvSpPr>
+        <p:spPr>
+          <a:xfrm>
+            <a:off x="822960" y="3246120"/>
+            <a:ext cx="3310128" cy="365760"/>
+          </a:xfrm>
+          <a:prstGeom prst="rect">
+            <a:avLst/>
+          </a:prstGeom>
+          <a:noFill/>
+        </p:spPr>
+        <p:txBody>
+          <a:bodyPr wrap="square" anchor="t" lIns="0" rIns="0" tIns="0" bIns="0">
+            <a:spAutoFit/>
+          </a:bodyPr>
+          <a:lstStyle/>
+          <a:p>
+            <a:pPr algn="ctr">
+              <a:lnSpc>
+                <a:spcPct val="100000"/>
+              </a:lnSpc>
+              <a:spcAft>
+                <a:spcPts val="0"/>
+              </a:spcAft>
+            </a:pPr>
+            <a:r>
+              <a:rPr sz="1300" b="0" i="0">
+                <a:solidFill>
+                  <a:srgbClr val="8B93A1"/>
+                </a:solidFill>
+                <a:latin typeface="Calibri"/>
+              </a:rPr>
+              <a:t>couverture globale</a:t>
+            </a:r>
+          </a:p>
+        </p:txBody>
+      </p:sp>
+      <p:sp>
+        <p:nvSpPr>
+          <p:cNvPr id="9" name="Rectangle 8"/>
+          <p:cNvSpPr/>
+          <p:nvPr/>
+        </p:nvSpPr>
+        <p:spPr>
+          <a:xfrm>
+            <a:off x="4389120" y="2286000"/>
+            <a:ext cx="3310128" cy="1554480"/>
+          </a:xfrm>
+          <a:prstGeom prst="rect">
+            <a:avLst/>
+          </a:prstGeom>
+          <a:solidFill>
+            <a:srgbClr val="183359"/>
+          </a:solidFill>
+          <a:ln>
+            <a:noFill/>
+          </a:ln>
+          <a:effectLst/>
+        </p:spPr>
+        <p:style>
+          <a:lnRef idx="1">
+            <a:schemeClr val="accent1"/>
+          </a:lnRef>
+          <a:fillRef idx="3">
+            <a:schemeClr val="accent1"/>
+          </a:fillRef>
+          <a:effectRef idx="2">
+            <a:schemeClr val="accent1"/>
+          </a:effectRef>
+          <a:fontRef idx="minor">
+            <a:schemeClr val="lt1"/>
+          </a:fontRef>
+        </p:style>
+        <p:txBody>
+          <a:bodyPr rtlCol="0" anchor="ctr"/>
+          <a:lstStyle/>
+          <a:p>
+            <a:pPr algn="ctr"/>
+          </a:p>
+        </p:txBody>
+      </p:sp>
+      <p:sp>
+        <p:nvSpPr>
+          <p:cNvPr id="10" name="Rectangle 9"/>
+          <p:cNvSpPr/>
+          <p:nvPr/>
+        </p:nvSpPr>
+        <p:spPr>
+          <a:xfrm>
+            <a:off x="4389120" y="2286000"/>
+            <a:ext cx="3310128" cy="64008"/>
+          </a:xfrm>
+          <a:prstGeom prst="rect">
+            <a:avLst/>
+          </a:prstGeom>
+          <a:solidFill>
+            <a:srgbClr val="C79A52"/>
+          </a:solidFill>
+          <a:ln>
+            <a:noFill/>
+          </a:ln>
+          <a:effectLst/>
+        </p:spPr>
+        <p:style>
+          <a:lnRef idx="1">
+            <a:schemeClr val="accent1"/>
+          </a:lnRef>
+          <a:fillRef idx="3">
+            <a:schemeClr val="accent1"/>
+          </a:fillRef>
+          <a:effectRef idx="2">
+            <a:schemeClr val="accent1"/>
+          </a:effectRef>
+          <a:fontRef idx="minor">
+            <a:schemeClr val="lt1"/>
+          </a:fontRef>
+        </p:style>
+        <p:txBody>
+          <a:bodyPr rtlCol="0" anchor="ctr"/>
+          <a:lstStyle/>
+          <a:p>
+            <a:pPr algn="ctr"/>
+          </a:p>
+        </p:txBody>
+      </p:sp>
+      <p:sp>
+        <p:nvSpPr>
+          <p:cNvPr id="11" name="TextBox 10"/>
+          <p:cNvSpPr txBox="1"/>
+          <p:nvPr/>
+        </p:nvSpPr>
+        <p:spPr>
+          <a:xfrm>
+            <a:off x="4389120" y="2542032"/>
+            <a:ext cx="3310128" cy="685800"/>
+          </a:xfrm>
+          <a:prstGeom prst="rect">
+            <a:avLst/>
+          </a:prstGeom>
+          <a:noFill/>
+        </p:spPr>
+        <p:txBody>
+          <a:bodyPr wrap="square" anchor="t" lIns="0" rIns="0" tIns="0" bIns="0">
+            <a:spAutoFit/>
+          </a:bodyPr>
+          <a:lstStyle/>
+          <a:p>
+            <a:pPr algn="ctr">
+              <a:lnSpc>
+                <a:spcPct val="100000"/>
+              </a:lnSpc>
+              <a:spcAft>
+                <a:spcPts val="0"/>
+              </a:spcAft>
+            </a:pPr>
+            <a:r>
+              <a:rPr sz="4000" b="1" i="0">
+                <a:solidFill>
+                  <a:srgbClr val="C79A52"/>
+                </a:solidFill>
+                <a:latin typeface="Calibri"/>
+              </a:rPr>
+              <a:t>82 %</a:t>
+            </a:r>
+          </a:p>
+        </p:txBody>
+      </p:sp>
+      <p:sp>
+        <p:nvSpPr>
+          <p:cNvPr id="12" name="TextBox 11"/>
+          <p:cNvSpPr txBox="1"/>
+          <p:nvPr/>
+        </p:nvSpPr>
+        <p:spPr>
+          <a:xfrm>
+            <a:off x="4389120" y="3246120"/>
+            <a:ext cx="3310128" cy="365760"/>
+          </a:xfrm>
+          <a:prstGeom prst="rect">
+            <a:avLst/>
+          </a:prstGeom>
+          <a:noFill/>
+        </p:spPr>
+        <p:txBody>
+          <a:bodyPr wrap="square" anchor="t" lIns="0" rIns="0" tIns="0" bIns="0">
+            <a:spAutoFit/>
+          </a:bodyPr>
+          <a:lstStyle/>
+          <a:p>
+            <a:pPr algn="ctr">
+              <a:lnSpc>
+                <a:spcPct val="100000"/>
+              </a:lnSpc>
+              <a:spcAft>
+                <a:spcPts val="0"/>
+              </a:spcAft>
+            </a:pPr>
+            <a:r>
+              <a:rPr sz="1300" b="0" i="0">
+                <a:solidFill>
+                  <a:srgbClr val="8B93A1"/>
+                </a:solidFill>
+                <a:latin typeface="Calibri"/>
+              </a:rPr>
+              <a:t>lignes</a:t>
+            </a:r>
+          </a:p>
+        </p:txBody>
+      </p:sp>
+      <p:sp>
+        <p:nvSpPr>
+          <p:cNvPr id="13" name="Rectangle 12"/>
+          <p:cNvSpPr/>
+          <p:nvPr/>
+        </p:nvSpPr>
+        <p:spPr>
+          <a:xfrm>
+            <a:off x="7955280" y="2286000"/>
+            <a:ext cx="3310128" cy="1554480"/>
+          </a:xfrm>
+          <a:prstGeom prst="rect">
+            <a:avLst/>
+          </a:prstGeom>
+          <a:solidFill>
+            <a:srgbClr val="183359"/>
+          </a:solidFill>
+          <a:ln>
+            <a:noFill/>
+          </a:ln>
+          <a:effectLst/>
+        </p:spPr>
+        <p:style>
+          <a:lnRef idx="1">
+            <a:schemeClr val="accent1"/>
+          </a:lnRef>
+          <a:fillRef idx="3">
+            <a:schemeClr val="accent1"/>
+          </a:fillRef>
+          <a:effectRef idx="2">
+            <a:schemeClr val="accent1"/>
+          </a:effectRef>
+          <a:fontRef idx="minor">
+            <a:schemeClr val="lt1"/>
+          </a:fontRef>
+        </p:style>
+        <p:txBody>
+          <a:bodyPr rtlCol="0" anchor="ctr"/>
+          <a:lstStyle/>
+          <a:p>
+            <a:pPr algn="ctr"/>
+          </a:p>
+        </p:txBody>
+      </p:sp>
+      <p:sp>
+        <p:nvSpPr>
+          <p:cNvPr id="14" name="Rectangle 13"/>
+          <p:cNvSpPr/>
+          <p:nvPr/>
+        </p:nvSpPr>
+        <p:spPr>
+          <a:xfrm>
+            <a:off x="7955280" y="2286000"/>
+            <a:ext cx="3310128" cy="64008"/>
+          </a:xfrm>
+          <a:prstGeom prst="rect">
+            <a:avLst/>
+          </a:prstGeom>
+          <a:solidFill>
+            <a:srgbClr val="C79A52"/>
+          </a:solidFill>
+          <a:ln>
+            <a:noFill/>
+          </a:ln>
+          <a:effectLst/>
+        </p:spPr>
+        <p:style>
+          <a:lnRef idx="1">
+            <a:schemeClr val="accent1"/>
+          </a:lnRef>
+          <a:fillRef idx="3">
+            <a:schemeClr val="accent1"/>
+          </a:fillRef>
+          <a:effectRef idx="2">
+            <a:schemeClr val="accent1"/>
+          </a:effectRef>
+          <a:fontRef idx="minor">
+            <a:schemeClr val="lt1"/>
+          </a:fontRef>
+        </p:style>
+        <p:txBody>
+          <a:bodyPr rtlCol="0" anchor="ctr"/>
+          <a:lstStyle/>
+          <a:p>
+            <a:pPr algn="ctr"/>
+          </a:p>
+        </p:txBody>
+      </p:sp>
+      <p:sp>
+        <p:nvSpPr>
+          <p:cNvPr id="15" name="TextBox 14"/>
+          <p:cNvSpPr txBox="1"/>
+          <p:nvPr/>
+        </p:nvSpPr>
+        <p:spPr>
+          <a:xfrm>
+            <a:off x="7955280" y="2542032"/>
+            <a:ext cx="3310128" cy="685800"/>
+          </a:xfrm>
+          <a:prstGeom prst="rect">
+            <a:avLst/>
+          </a:prstGeom>
+          <a:noFill/>
+        </p:spPr>
+        <p:txBody>
+          <a:bodyPr wrap="square" anchor="t" lIns="0" rIns="0" tIns="0" bIns="0">
+            <a:spAutoFit/>
+          </a:bodyPr>
+          <a:lstStyle/>
+          <a:p>
+            <a:pPr algn="ctr">
+              <a:lnSpc>
+                <a:spcPct val="100000"/>
+              </a:lnSpc>
+              <a:spcAft>
+                <a:spcPts val="0"/>
+              </a:spcAft>
+            </a:pPr>
+            <a:r>
+              <a:rPr sz="4000" b="1" i="0">
+                <a:solidFill>
+                  <a:srgbClr val="C79A52"/>
+                </a:solidFill>
+                <a:latin typeface="Calibri"/>
+              </a:rPr>
+              <a:t>65 %</a:t>
+            </a:r>
+          </a:p>
+        </p:txBody>
+      </p:sp>
+      <p:sp>
+        <p:nvSpPr>
+          <p:cNvPr id="16" name="TextBox 15"/>
+          <p:cNvSpPr txBox="1"/>
+          <p:nvPr/>
+        </p:nvSpPr>
+        <p:spPr>
+          <a:xfrm>
+            <a:off x="7955280" y="3246120"/>
+            <a:ext cx="3310128" cy="365760"/>
+          </a:xfrm>
+          <a:prstGeom prst="rect">
+            <a:avLst/>
+          </a:prstGeom>
+          <a:noFill/>
+        </p:spPr>
+        <p:txBody>
+          <a:bodyPr wrap="square" anchor="t" lIns="0" rIns="0" tIns="0" bIns="0">
+            <a:spAutoFit/>
+          </a:bodyPr>
+          <a:lstStyle/>
+          <a:p>
+            <a:pPr algn="ctr">
+              <a:lnSpc>
+                <a:spcPct val="100000"/>
+              </a:lnSpc>
+              <a:spcAft>
+                <a:spcPts val="0"/>
+              </a:spcAft>
+            </a:pPr>
+            <a:r>
+              <a:rPr sz="1300" b="0" i="0">
+                <a:solidFill>
+                  <a:srgbClr val="8B93A1"/>
+                </a:solidFill>
+                <a:latin typeface="Calibri"/>
+              </a:rPr>
+              <a:t>branches</a:t>
+            </a:r>
+          </a:p>
+        </p:txBody>
+      </p:sp>
+      <p:sp>
+        <p:nvSpPr>
+          <p:cNvPr id="17" name="TextBox 16"/>
+          <p:cNvSpPr txBox="1"/>
+          <p:nvPr/>
+        </p:nvSpPr>
+        <p:spPr>
+          <a:xfrm>
+            <a:off x="822960" y="4160520"/>
+            <a:ext cx="9875520" cy="320040"/>
           </a:xfrm>
           <a:prstGeom prst="rect">
             <a:avLst/>
@@ -13719,27 +14808,132 @@
               </a:spcAft>
             </a:pPr>
             <a:r>
-              <a:rPr sz="1800" b="1" i="0">
-                <a:solidFill>
-                  <a:srgbClr val="EFECE3"/>
+              <a:rPr sz="1200" b="0" i="1">
+                <a:solidFill>
+                  <a:srgbClr val="8B93A1"/>
                 </a:solidFill>
                 <a:latin typeface="Calibri"/>
               </a:rPr>
-              <a:t>Un test vert ne dit pas ce qu'il a vérifié.</a:t>
-            </a:r>
-          </a:p>
-        </p:txBody>
-      </p:sp>
-      <p:sp>
-        <p:nvSpPr>
-          <p:cNvPr id="6" name="TextBox 5"/>
+              <a:t>Mesure réelle, obtenue en lançant l'analyse sur ce projet — pas une maquette.</a:t>
+            </a:r>
+          </a:p>
+        </p:txBody>
+      </p:sp>
+      <p:sp>
+        <p:nvSpPr>
+          <p:cNvPr id="18" name="Rectangle 17"/>
+          <p:cNvSpPr/>
+          <p:nvPr/>
+        </p:nvSpPr>
+        <p:spPr>
+          <a:xfrm>
+            <a:off x="822960" y="4617720"/>
+            <a:ext cx="10515600" cy="1051560"/>
+          </a:xfrm>
+          <a:prstGeom prst="rect">
+            <a:avLst/>
+          </a:prstGeom>
+          <a:solidFill>
+            <a:srgbClr val="183359"/>
+          </a:solidFill>
+          <a:ln>
+            <a:noFill/>
+          </a:ln>
+          <a:effectLst/>
+        </p:spPr>
+        <p:style>
+          <a:lnRef idx="1">
+            <a:schemeClr val="accent1"/>
+          </a:lnRef>
+          <a:fillRef idx="3">
+            <a:schemeClr val="accent1"/>
+          </a:fillRef>
+          <a:effectRef idx="2">
+            <a:schemeClr val="accent1"/>
+          </a:effectRef>
+          <a:fontRef idx="minor">
+            <a:schemeClr val="lt1"/>
+          </a:fontRef>
+        </p:style>
+        <p:txBody>
+          <a:bodyPr rtlCol="0" anchor="ctr"/>
+          <a:lstStyle/>
+          <a:p>
+            <a:pPr algn="ctr"/>
+          </a:p>
+        </p:txBody>
+      </p:sp>
+      <p:sp>
+        <p:nvSpPr>
+          <p:cNvPr id="19" name="TextBox 18"/>
           <p:cNvSpPr txBox="1"/>
           <p:nvPr/>
         </p:nvSpPr>
         <p:spPr>
           <a:xfrm>
-            <a:off x="2011680" y="2633472"/>
-            <a:ext cx="8961120" cy="457200"/>
+            <a:off x="1097280" y="4828032"/>
+            <a:ext cx="9966960" cy="640080"/>
+          </a:xfrm>
+          <a:prstGeom prst="rect">
+            <a:avLst/>
+          </a:prstGeom>
+          <a:noFill/>
+        </p:spPr>
+        <p:txBody>
+          <a:bodyPr wrap="square" anchor="t" lIns="0" rIns="0" tIns="0" bIns="0">
+            <a:spAutoFit/>
+          </a:bodyPr>
+          <a:lstStyle/>
+          <a:p>
+            <a:pPr algn="l">
+              <a:lnSpc>
+                <a:spcPct val="130000"/>
+              </a:lnSpc>
+              <a:spcAft>
+                <a:spcPts val="0"/>
+              </a:spcAft>
+            </a:pPr>
+            <a:r>
+              <a:rPr sz="1450" b="0" i="0">
+                <a:solidFill>
+                  <a:srgbClr val="E3E8F0"/>
+                </a:solidFill>
+                <a:latin typeface="Consolas"/>
+              </a:rPr>
+              <a:t>docker compose -f sonarqube/docker-compose.yml up -d</a:t>
+            </a:r>
+          </a:p>
+          <a:p>
+            <a:pPr algn="l">
+              <a:lnSpc>
+                <a:spcPct val="130000"/>
+              </a:lnSpc>
+              <a:spcAft>
+                <a:spcPts val="0"/>
+              </a:spcAft>
+            </a:pPr>
+            <a:r>
+              <a:rPr sz="1450" b="0" i="0">
+                <a:solidFill>
+                  <a:srgbClr val="E3E8F0"/>
+                </a:solidFill>
+                <a:latin typeface="Consolas"/>
+              </a:rPr>
+              <a:t>./mvnw test sonar:sonar -Dsonar.token=&lt;ton_token&gt;</a:t>
+            </a:r>
+          </a:p>
+        </p:txBody>
+      </p:sp>
+      <p:sp>
+        <p:nvSpPr>
+          <p:cNvPr id="20" name="TextBox 19"/>
+          <p:cNvSpPr txBox="1"/>
+          <p:nvPr/>
+        </p:nvSpPr>
+        <p:spPr>
+          <a:xfrm>
+            <a:off x="822960" y="5897880"/>
+            <a:ext cx="9875520" cy="365760"/>
           </a:xfrm>
           <a:prstGeom prst="rect">
             <a:avLst/>
@@ -13761,272 +14955,20 @@
               </a:spcAft>
             </a:pPr>
             <a:r>
-              <a:rPr sz="1400" b="0" i="0">
+              <a:rPr sz="1250" b="0" i="0">
                 <a:solidFill>
                   <a:srgbClr val="8B93A1"/>
                 </a:solidFill>
                 <a:latin typeface="Calibri"/>
               </a:rPr>
-              <a:t>La couverture, si.</a:t>
-            </a:r>
-          </a:p>
-        </p:txBody>
-      </p:sp>
-      <p:sp>
-        <p:nvSpPr>
-          <p:cNvPr id="7" name="TextBox 6"/>
-          <p:cNvSpPr txBox="1"/>
-          <p:nvPr/>
-        </p:nvSpPr>
-        <p:spPr>
-          <a:xfrm>
-            <a:off x="822960" y="3429000"/>
-            <a:ext cx="1097280" cy="1097280"/>
-          </a:xfrm>
-          <a:prstGeom prst="rect">
-            <a:avLst/>
-          </a:prstGeom>
-          <a:noFill/>
-        </p:spPr>
-        <p:txBody>
-          <a:bodyPr wrap="square" anchor="t" lIns="0" rIns="0" tIns="0" bIns="0">
-            <a:spAutoFit/>
-          </a:bodyPr>
-          <a:lstStyle/>
-          <a:p>
-            <a:pPr algn="l">
-              <a:lnSpc>
-                <a:spcPct val="100000"/>
-              </a:lnSpc>
-              <a:spcAft>
-                <a:spcPts val="0"/>
-              </a:spcAft>
-            </a:pPr>
-            <a:r>
-              <a:rPr sz="3400" b="1" i="0">
-                <a:solidFill>
-                  <a:srgbClr val="C79A52"/>
-                </a:solidFill>
-                <a:latin typeface="Calibri"/>
-              </a:rPr>
-              <a:t>02</a:t>
-            </a:r>
-          </a:p>
-        </p:txBody>
-      </p:sp>
-      <p:sp>
-        <p:nvSpPr>
-          <p:cNvPr id="8" name="TextBox 7"/>
-          <p:cNvSpPr txBox="1"/>
-          <p:nvPr/>
-        </p:nvSpPr>
-        <p:spPr>
-          <a:xfrm>
-            <a:off x="2011680" y="3474720"/>
-            <a:ext cx="8961120" cy="502920"/>
-          </a:xfrm>
-          <a:prstGeom prst="rect">
-            <a:avLst/>
-          </a:prstGeom>
-          <a:noFill/>
-        </p:spPr>
-        <p:txBody>
-          <a:bodyPr wrap="square" anchor="t" lIns="0" rIns="0" tIns="0" bIns="0">
-            <a:spAutoFit/>
-          </a:bodyPr>
-          <a:lstStyle/>
-          <a:p>
-            <a:pPr algn="l">
-              <a:lnSpc>
-                <a:spcPct val="100000"/>
-              </a:lnSpc>
-              <a:spcAft>
-                <a:spcPts val="0"/>
-              </a:spcAft>
-            </a:pPr>
-            <a:r>
-              <a:rPr sz="1800" b="1" i="0">
-                <a:solidFill>
-                  <a:srgbClr val="EFECE3"/>
-                </a:solidFill>
-                <a:latin typeface="Calibri"/>
-              </a:rPr>
-              <a:t>JUnit et Cucumber répondent à deux questions différentes.</a:t>
-            </a:r>
-          </a:p>
-        </p:txBody>
-      </p:sp>
-      <p:sp>
-        <p:nvSpPr>
-          <p:cNvPr id="9" name="TextBox 8"/>
-          <p:cNvSpPr txBox="1"/>
-          <p:nvPr/>
-        </p:nvSpPr>
-        <p:spPr>
-          <a:xfrm>
-            <a:off x="2011680" y="3959352"/>
-            <a:ext cx="8961120" cy="457200"/>
-          </a:xfrm>
-          <a:prstGeom prst="rect">
-            <a:avLst/>
-          </a:prstGeom>
-          <a:noFill/>
-        </p:spPr>
-        <p:txBody>
-          <a:bodyPr wrap="square" anchor="t" lIns="0" rIns="0" tIns="0" bIns="0">
-            <a:spAutoFit/>
-          </a:bodyPr>
-          <a:lstStyle/>
-          <a:p>
-            <a:pPr algn="l">
-              <a:lnSpc>
-                <a:spcPct val="100000"/>
-              </a:lnSpc>
-              <a:spcAft>
-                <a:spcPts val="0"/>
-              </a:spcAft>
-            </a:pPr>
-            <a:r>
-              <a:rPr sz="1400" b="0" i="0">
-                <a:solidFill>
-                  <a:srgbClr val="8B93A1"/>
-                </a:solidFill>
-                <a:latin typeface="Calibri"/>
-              </a:rPr>
-              <a:t>« Ça marche ? » contre « c'est le bon comportement ? »</a:t>
-            </a:r>
-          </a:p>
-        </p:txBody>
-      </p:sp>
-      <p:sp>
-        <p:nvSpPr>
-          <p:cNvPr id="10" name="TextBox 9"/>
-          <p:cNvSpPr txBox="1"/>
-          <p:nvPr/>
-        </p:nvSpPr>
-        <p:spPr>
-          <a:xfrm>
-            <a:off x="822960" y="4754880"/>
-            <a:ext cx="1097280" cy="1097280"/>
-          </a:xfrm>
-          <a:prstGeom prst="rect">
-            <a:avLst/>
-          </a:prstGeom>
-          <a:noFill/>
-        </p:spPr>
-        <p:txBody>
-          <a:bodyPr wrap="square" anchor="t" lIns="0" rIns="0" tIns="0" bIns="0">
-            <a:spAutoFit/>
-          </a:bodyPr>
-          <a:lstStyle/>
-          <a:p>
-            <a:pPr algn="l">
-              <a:lnSpc>
-                <a:spcPct val="100000"/>
-              </a:lnSpc>
-              <a:spcAft>
-                <a:spcPts val="0"/>
-              </a:spcAft>
-            </a:pPr>
-            <a:r>
-              <a:rPr sz="3400" b="1" i="0">
-                <a:solidFill>
-                  <a:srgbClr val="C79A52"/>
-                </a:solidFill>
-                <a:latin typeface="Calibri"/>
-              </a:rPr>
-              <a:t>03</a:t>
-            </a:r>
-          </a:p>
-        </p:txBody>
-      </p:sp>
-      <p:sp>
-        <p:nvSpPr>
-          <p:cNvPr id="11" name="TextBox 10"/>
-          <p:cNvSpPr txBox="1"/>
-          <p:nvPr/>
-        </p:nvSpPr>
-        <p:spPr>
-          <a:xfrm>
-            <a:off x="2011680" y="4800600"/>
-            <a:ext cx="8961120" cy="502920"/>
-          </a:xfrm>
-          <a:prstGeom prst="rect">
-            <a:avLst/>
-          </a:prstGeom>
-          <a:noFill/>
-        </p:spPr>
-        <p:txBody>
-          <a:bodyPr wrap="square" anchor="t" lIns="0" rIns="0" tIns="0" bIns="0">
-            <a:spAutoFit/>
-          </a:bodyPr>
-          <a:lstStyle/>
-          <a:p>
-            <a:pPr algn="l">
-              <a:lnSpc>
-                <a:spcPct val="100000"/>
-              </a:lnSpc>
-              <a:spcAft>
-                <a:spcPts val="0"/>
-              </a:spcAft>
-            </a:pPr>
-            <a:r>
-              <a:rPr sz="1800" b="1" i="0">
-                <a:solidFill>
-                  <a:srgbClr val="EFECE3"/>
-                </a:solidFill>
-                <a:latin typeface="Calibri"/>
-              </a:rPr>
-              <a:t>Le rapport de couverture n'est pas un objectif.</a:t>
-            </a:r>
-          </a:p>
-        </p:txBody>
-      </p:sp>
-      <p:sp>
-        <p:nvSpPr>
-          <p:cNvPr id="12" name="TextBox 11"/>
-          <p:cNvSpPr txBox="1"/>
-          <p:nvPr/>
-        </p:nvSpPr>
-        <p:spPr>
-          <a:xfrm>
-            <a:off x="2011680" y="5285232"/>
-            <a:ext cx="8961120" cy="457200"/>
-          </a:xfrm>
-          <a:prstGeom prst="rect">
-            <a:avLst/>
-          </a:prstGeom>
-          <a:noFill/>
-        </p:spPr>
-        <p:txBody>
-          <a:bodyPr wrap="square" anchor="t" lIns="0" rIns="0" tIns="0" bIns="0">
-            <a:spAutoFit/>
-          </a:bodyPr>
-          <a:lstStyle/>
-          <a:p>
-            <a:pPr algn="l">
-              <a:lnSpc>
-                <a:spcPct val="100000"/>
-              </a:lnSpc>
-              <a:spcAft>
-                <a:spcPts val="0"/>
-              </a:spcAft>
-            </a:pPr>
-            <a:r>
-              <a:rPr sz="1400" b="0" i="0">
-                <a:solidFill>
-                  <a:srgbClr val="8B93A1"/>
-                </a:solidFill>
-                <a:latin typeface="Calibri"/>
-              </a:rPr>
-              <a:t>C'est un radar : il montre où regarder en premier.</a:t>
-            </a:r>
-          </a:p>
-        </p:txBody>
-      </p:sp>
-      <p:sp>
-        <p:nvSpPr>
-          <p:cNvPr id="13" name="TextBox 12"/>
+              <a:t>SonarQube Community en local — aucun compte SonarCloud, aucune dépendance réseau pendant le talk.</a:t>
+            </a:r>
+          </a:p>
+        </p:txBody>
+      </p:sp>
+      <p:sp>
+        <p:nvSpPr>
+          <p:cNvPr id="21" name="TextBox 20"/>
           <p:cNvSpPr txBox="1"/>
           <p:nvPr/>
         </p:nvSpPr>
@@ -14061,14 +15003,14 @@
                 </a:solidFill>
                 <a:latin typeface="Calibri"/>
               </a:rPr>
-              <a:t>09 / 10</a:t>
-            </a:r>
-          </a:p>
-        </p:txBody>
-      </p:sp>
-      <p:sp>
-        <p:nvSpPr>
-          <p:cNvPr id="14" name="TextBox 13"/>
+              <a:t>09 / 11</a:t>
+            </a:r>
+          </a:p>
+        </p:txBody>
+      </p:sp>
+      <p:sp>
+        <p:nvSpPr>
+          <p:cNvPr id="22" name="TextBox 21"/>
           <p:cNvSpPr txBox="1"/>
           <p:nvPr/>
         </p:nvSpPr>

</xml_diff>

<commit_message>
Ajouter le README public, humour visible sur les slides, PROMPT.md clarifié
- README.md : présentation du dépôt pour GitHub (démarrage rapide,
  structure, convention des classes sous-testées).
- generate_pptx.py / pptx officiel : passe d'humour et de dynamisme sur
  les slides (vannes visibles à l'écran, tampons/badges, transitions),
  pas seulement dans SCRIPT.md.
- CLAUDE.md / SCRIPT.md : clarifient que PROMPT.md est un journal privé,
  non versionné (cohérent avec sa suppression du suivi git), et mettent à
  jour le texte de la slide "Pour aller plus loin" en conséquence.
</commit_message>
<xml_diff>
--- a/presentation/couverture-code-conference.pptx
+++ b/presentation/couverture-code-conference.pptx
@@ -4555,7 +4555,7 @@
                 <a:solidFill>
                   <a:srgbClr val="C79A52"/>
                 </a:solidFill>
-                <a:latin typeface="Calibri"/>
+                <a:latin typeface="Helvetica Neue"/>
               </a:rPr>
               <a:t>CONFÉRENCE TECHNIQUE</a:t>
             </a:r>
@@ -4597,7 +4597,7 @@
                 <a:solidFill>
                   <a:srgbClr val="EFECE3"/>
                 </a:solidFill>
-                <a:latin typeface="Calibri"/>
+                <a:latin typeface="Helvetica Neue"/>
               </a:rPr>
               <a:t>La couverture de code,</a:t>
             </a:r>
@@ -4616,7 +4616,7 @@
                 <a:solidFill>
                   <a:srgbClr val="EFECE3"/>
                 </a:solidFill>
-                <a:latin typeface="Calibri"/>
+                <a:latin typeface="Helvetica Neue"/>
               </a:rPr>
               <a:t>sans blabla</a:t>
             </a:r>
@@ -4658,7 +4658,7 @@
                 <a:solidFill>
                   <a:srgbClr val="C79A52"/>
                 </a:solidFill>
-                <a:latin typeface="Calibri"/>
+                <a:latin typeface="Helvetica Neue"/>
               </a:rPr>
               <a:t>Quarkus  ·  JUnit  ·  Cucumber  ·  Jacoco  ·  (un peu de Sonar en bonus)</a:t>
             </a:r>
@@ -4700,7 +4700,7 @@
                 <a:solidFill>
                   <a:srgbClr val="C8CFDA"/>
                 </a:solidFill>
-                <a:latin typeface="Calibri"/>
+                <a:latin typeface="Helvetica Neue"/>
               </a:rPr>
               <a:t>Où l'on découvre que « 100 % de couverture » ne veut pas dire « 0 bug ».</a:t>
             </a:r>
@@ -4742,7 +4742,7 @@
                 <a:solidFill>
                   <a:srgbClr val="8B93A1"/>
                 </a:solidFill>
-                <a:latin typeface="Calibri"/>
+                <a:latin typeface="Helvetica Neue"/>
               </a:rPr>
               <a:t>Ton nom — Date de la conférence</a:t>
             </a:r>
@@ -4860,9 +4860,9 @@
             <a:r>
               <a:rPr sz="1300" b="1" i="0">
                 <a:solidFill>
-                  <a:srgbClr val="5C8C86"/>
-                </a:solidFill>
-                <a:latin typeface="Calibri"/>
+                  <a:srgbClr val="355C57"/>
+                </a:solidFill>
+                <a:latin typeface="Helvetica Neue"/>
               </a:rPr>
               <a:t>ZOOM — CUCUMBER</a:t>
             </a:r>
@@ -4904,7 +4904,7 @@
                 <a:solidFill>
                   <a:srgbClr val="162844"/>
                 </a:solidFill>
-                <a:latin typeface="Calibri"/>
+                <a:latin typeface="Helvetica Neue"/>
               </a:rPr>
               <a:t>Le grand angle</a:t>
             </a:r>
@@ -4946,7 +4946,7 @@
                 <a:solidFill>
                   <a:srgbClr val="333A47"/>
                 </a:solidFill>
-                <a:latin typeface="Calibri"/>
+                <a:latin typeface="Helvetica Neue"/>
               </a:rPr>
               <a:t>Cucumber teste le comportement observable, de bout en bout, en français</a:t>
             </a:r>
@@ -4965,7 +4965,7 @@
                 <a:solidFill>
                   <a:srgbClr val="333A47"/>
                 </a:solidFill>
-                <a:latin typeface="Calibri"/>
+                <a:latin typeface="Helvetica Neue"/>
               </a:rPr>
               <a:t>lisible. Le même texte sert de spec fonctionnelle ET de test automatisé.</a:t>
             </a:r>
@@ -5097,7 +5097,7 @@
                 <a:solidFill>
                   <a:srgbClr val="162844"/>
                 </a:solidFill>
-                <a:latin typeface="Calibri"/>
+                <a:latin typeface="Helvetica Neue"/>
               </a:rPr>
               <a:t>Lisible</a:t>
             </a:r>
@@ -5139,7 +5139,7 @@
                 <a:solidFill>
                   <a:srgbClr val="333A47"/>
                 </a:solidFill>
-                <a:latin typeface="Calibri"/>
+                <a:latin typeface="Helvetica Neue"/>
               </a:rPr>
               <a:t>Même un product owner peut le relire (et le corriger).</a:t>
             </a:r>
@@ -5271,7 +5271,7 @@
                 <a:solidFill>
                   <a:srgbClr val="162844"/>
                 </a:solidFill>
-                <a:latin typeface="Calibri"/>
+                <a:latin typeface="Helvetica Neue"/>
               </a:rPr>
               <a:t>Bout en bout</a:t>
             </a:r>
@@ -5313,7 +5313,7 @@
                 <a:solidFill>
                   <a:srgbClr val="333A47"/>
                 </a:solidFill>
-                <a:latin typeface="Calibri"/>
+                <a:latin typeface="Helvetica Neue"/>
               </a:rPr>
               <a:t>Passe par la vraie API REST, pas un mock.</a:t>
             </a:r>
@@ -5445,7 +5445,7 @@
                 <a:solidFill>
                   <a:srgbClr val="162844"/>
                 </a:solidFill>
-                <a:latin typeface="Calibri"/>
+                <a:latin typeface="Helvetica Neue"/>
               </a:rPr>
               <a:t>Fonctionnel</a:t>
             </a:r>
@@ -5487,7 +5487,7 @@
                 <a:solidFill>
                   <a:srgbClr val="333A47"/>
                 </a:solidFill>
-                <a:latin typeface="Calibri"/>
+                <a:latin typeface="Helvetica Neue"/>
               </a:rPr>
               <a:t>Décrit ce que fait le produit, pas comment.</a:t>
             </a:r>
@@ -5529,7 +5529,7 @@
                 <a:solidFill>
                   <a:srgbClr val="333A47"/>
                 </a:solidFill>
-                <a:latin typeface="Calibri"/>
+                <a:latin typeface="Helvetica Neue"/>
               </a:rPr>
               <a:t>Dans notre agenda malin : la création d'événement, la détection de conflit,</a:t>
             </a:r>
@@ -5548,7 +5548,7 @@
                 <a:solidFill>
                   <a:srgbClr val="333A47"/>
                 </a:solidFill>
-                <a:latin typeface="Calibri"/>
+                <a:latin typeface="Helvetica Neue"/>
               </a:rPr>
               <a:t>le signalement d'un jour férié — trois scénarios, en français.</a:t>
             </a:r>
@@ -5588,9 +5588,9 @@
             <a:r>
               <a:rPr sz="1000" b="0" i="0">
                 <a:solidFill>
-                  <a:srgbClr val="8B93A1"/>
-                </a:solidFill>
-                <a:latin typeface="Calibri"/>
+                  <a:srgbClr val="5E6674"/>
+                </a:solidFill>
+                <a:latin typeface="Helvetica Neue"/>
               </a:rPr>
               <a:t>10 / 28</a:t>
             </a:r>
@@ -5630,9 +5630,9 @@
             <a:r>
               <a:rPr sz="800" b="0" i="0">
                 <a:solidFill>
-                  <a:srgbClr val="8B93A1"/>
-                </a:solidFill>
-                <a:latin typeface="Calibri"/>
+                  <a:srgbClr val="5E6674"/>
+                </a:solidFill>
+                <a:latin typeface="Helvetica Neue"/>
               </a:rPr>
               <a:t>COUVERTURE DE CODE — QUARKUS · JUNIT · CUCUMBER · JACOCO</a:t>
             </a:r>
@@ -5750,9 +5750,9 @@
             <a:r>
               <a:rPr sz="1300" b="1" i="0">
                 <a:solidFill>
-                  <a:srgbClr val="5C8C86"/>
-                </a:solidFill>
-                <a:latin typeface="Calibri"/>
+                  <a:srgbClr val="355C57"/>
+                </a:solidFill>
+                <a:latin typeface="Helvetica Neue"/>
               </a:rPr>
               <a:t>CUCUMBER — EN ACTION</a:t>
             </a:r>
@@ -5794,7 +5794,7 @@
                 <a:solidFill>
                   <a:srgbClr val="162844"/>
                 </a:solidFill>
-                <a:latin typeface="Calibri"/>
+                <a:latin typeface="Helvetica Neue"/>
               </a:rPr>
               <a:t>Le scénario que tout le monde comprend</a:t>
             </a:r>
@@ -5881,7 +5881,7 @@
                 <a:solidFill>
                   <a:srgbClr val="E3E8F0"/>
                 </a:solidFill>
-                <a:latin typeface="Consolas"/>
+                <a:latin typeface="Menlo"/>
               </a:rPr>
               <a:t>Scénario: Refus d'un événement qui chevauche un</a:t>
             </a:r>
@@ -5900,7 +5900,7 @@
                 <a:solidFill>
                   <a:srgbClr val="E3E8F0"/>
                 </a:solidFill>
-                <a:latin typeface="Consolas"/>
+                <a:latin typeface="Menlo"/>
               </a:rPr>
               <a:t>          événement existant</a:t>
             </a:r>
@@ -5918,7 +5918,7 @@
               <a:solidFill>
                 <a:srgbClr val="E3E8F0"/>
               </a:solidFill>
-              <a:latin typeface="Consolas"/>
+              <a:latin typeface="Menlo"/>
             </a:endParaRPr>
           </a:p>
           <a:p>
@@ -5935,7 +5935,7 @@
                 <a:solidFill>
                   <a:srgbClr val="E3E8F0"/>
                 </a:solidFill>
-                <a:latin typeface="Consolas"/>
+                <a:latin typeface="Menlo"/>
               </a:rPr>
               <a:t>  Étant donné que j'ai déjà l'événement "Comité de</a:t>
             </a:r>
@@ -5954,7 +5954,7 @@
                 <a:solidFill>
                   <a:srgbClr val="E3E8F0"/>
                 </a:solidFill>
-                <a:latin typeface="Consolas"/>
+                <a:latin typeface="Menlo"/>
               </a:rPr>
               <a:t>  pilotage" de "14:00" à "15:00" le "2026-09-15"</a:t>
             </a:r>
@@ -5973,7 +5973,7 @@
                 <a:solidFill>
                   <a:srgbClr val="E3E8F0"/>
                 </a:solidFill>
-                <a:latin typeface="Consolas"/>
+                <a:latin typeface="Menlo"/>
               </a:rPr>
               <a:t>  Quand je crée l'événement "Revue de code" de</a:t>
             </a:r>
@@ -5992,7 +5992,7 @@
                 <a:solidFill>
                   <a:srgbClr val="E3E8F0"/>
                 </a:solidFill>
-                <a:latin typeface="Consolas"/>
+                <a:latin typeface="Menlo"/>
               </a:rPr>
               <a:t>  "14:30" à "15:30" le "2026-09-15"</a:t>
             </a:r>
@@ -6011,7 +6011,7 @@
                 <a:solidFill>
                   <a:srgbClr val="E3E8F0"/>
                 </a:solidFill>
-                <a:latin typeface="Consolas"/>
+                <a:latin typeface="Menlo"/>
               </a:rPr>
               <a:t>  Alors la création est refusée pour cause de</a:t>
             </a:r>
@@ -6030,7 +6030,7 @@
                 <a:solidFill>
                   <a:srgbClr val="E3E8F0"/>
                 </a:solidFill>
-                <a:latin typeface="Consolas"/>
+                <a:latin typeface="Menlo"/>
               </a:rPr>
               <a:t>  conflit d'horaire</a:t>
             </a:r>
@@ -6072,7 +6072,7 @@
                 <a:solidFill>
                   <a:srgbClr val="333A47"/>
                 </a:solidFill>
-                <a:latin typeface="Calibri"/>
+                <a:latin typeface="Helvetica Neue"/>
               </a:rPr>
               <a:t>Ce même texte sert de spécification fonctionnelle et de test d'intégration,</a:t>
             </a:r>
@@ -6091,7 +6091,7 @@
                 <a:solidFill>
                   <a:srgbClr val="333A47"/>
                 </a:solidFill>
-                <a:latin typeface="Calibri"/>
+                <a:latin typeface="Helvetica Neue"/>
               </a:rPr>
               <a:t>exécuté en vrai contre l'API REST via RestAssured.</a:t>
             </a:r>
@@ -6131,9 +6131,9 @@
             <a:r>
               <a:rPr sz="1000" b="0" i="0">
                 <a:solidFill>
-                  <a:srgbClr val="8B93A1"/>
-                </a:solidFill>
-                <a:latin typeface="Calibri"/>
+                  <a:srgbClr val="5E6674"/>
+                </a:solidFill>
+                <a:latin typeface="Helvetica Neue"/>
               </a:rPr>
               <a:t>11 / 28</a:t>
             </a:r>
@@ -6173,9 +6173,9 @@
             <a:r>
               <a:rPr sz="800" b="0" i="0">
                 <a:solidFill>
-                  <a:srgbClr val="8B93A1"/>
-                </a:solidFill>
-                <a:latin typeface="Calibri"/>
+                  <a:srgbClr val="5E6674"/>
+                </a:solidFill>
+                <a:latin typeface="Helvetica Neue"/>
               </a:rPr>
               <a:t>COUVERTURE DE CODE — QUARKUS · JUNIT · CUCUMBER · JACOCO</a:t>
             </a:r>
@@ -6293,9 +6293,9 @@
             <a:r>
               <a:rPr sz="1300" b="1" i="0">
                 <a:solidFill>
-                  <a:srgbClr val="C79A52"/>
-                </a:solidFill>
-                <a:latin typeface="Calibri"/>
+                  <a:srgbClr val="8A6530"/>
+                </a:solidFill>
+                <a:latin typeface="Helvetica Neue"/>
               </a:rPr>
               <a:t>LE MATCH</a:t>
             </a:r>
@@ -6337,7 +6337,7 @@
                 <a:solidFill>
                   <a:srgbClr val="162844"/>
                 </a:solidFill>
-                <a:latin typeface="Calibri"/>
+                <a:latin typeface="Helvetica Neue"/>
               </a:rPr>
               <a:t>JUnit vs Cucumber : qui gagne ?</a:t>
             </a:r>
@@ -6469,7 +6469,7 @@
                 <a:solidFill>
                   <a:srgbClr val="162844"/>
                 </a:solidFill>
-                <a:latin typeface="Calibri"/>
+                <a:latin typeface="Helvetica Neue"/>
               </a:rPr>
               <a:t>JUnit</a:t>
             </a:r>
@@ -6511,7 +6511,7 @@
                 <a:solidFill>
                   <a:srgbClr val="333A47"/>
                 </a:solidFill>
-                <a:latin typeface="Calibri"/>
+                <a:latin typeface="Helvetica Neue"/>
               </a:rPr>
               <a:t>— Rapide</a:t>
             </a:r>
@@ -6553,7 +6553,7 @@
                 <a:solidFill>
                   <a:srgbClr val="333A47"/>
                 </a:solidFill>
-                <a:latin typeface="Calibri"/>
+                <a:latin typeface="Helvetica Neue"/>
               </a:rPr>
               <a:t>— Isolé</a:t>
             </a:r>
@@ -6595,7 +6595,7 @@
                 <a:solidFill>
                   <a:srgbClr val="333A47"/>
                 </a:solidFill>
-                <a:latin typeface="Calibri"/>
+                <a:latin typeface="Helvetica Neue"/>
               </a:rPr>
               <a:t>— Technique</a:t>
             </a:r>
@@ -6637,7 +6637,7 @@
                 <a:solidFill>
                   <a:srgbClr val="333A47"/>
                 </a:solidFill>
-                <a:latin typeface="Calibri"/>
+                <a:latin typeface="Helvetica Neue"/>
               </a:rPr>
               <a:t>— Pour les devs</a:t>
             </a:r>
@@ -6769,7 +6769,7 @@
                 <a:solidFill>
                   <a:srgbClr val="162844"/>
                 </a:solidFill>
-                <a:latin typeface="Calibri"/>
+                <a:latin typeface="Helvetica Neue"/>
               </a:rPr>
               <a:t>Cucumber</a:t>
             </a:r>
@@ -6811,7 +6811,7 @@
                 <a:solidFill>
                   <a:srgbClr val="333A47"/>
                 </a:solidFill>
-                <a:latin typeface="Calibri"/>
+                <a:latin typeface="Helvetica Neue"/>
               </a:rPr>
               <a:t>— Lisible</a:t>
             </a:r>
@@ -6853,7 +6853,7 @@
                 <a:solidFill>
                   <a:srgbClr val="333A47"/>
                 </a:solidFill>
-                <a:latin typeface="Calibri"/>
+                <a:latin typeface="Helvetica Neue"/>
               </a:rPr>
               <a:t>— Bout en bout</a:t>
             </a:r>
@@ -6895,7 +6895,7 @@
                 <a:solidFill>
                   <a:srgbClr val="333A47"/>
                 </a:solidFill>
-                <a:latin typeface="Calibri"/>
+                <a:latin typeface="Helvetica Neue"/>
               </a:rPr>
               <a:t>— Fonctionnel</a:t>
             </a:r>
@@ -6937,7 +6937,7 @@
                 <a:solidFill>
                   <a:srgbClr val="333A47"/>
                 </a:solidFill>
-                <a:latin typeface="Calibri"/>
+                <a:latin typeface="Helvetica Neue"/>
               </a:rPr>
               <a:t>— Pour tout le monde</a:t>
             </a:r>
@@ -6977,9 +6977,9 @@
             <a:r>
               <a:rPr sz="1400" b="1" i="1">
                 <a:solidFill>
-                  <a:srgbClr val="C79A52"/>
-                </a:solidFill>
-                <a:latin typeface="Calibri"/>
+                  <a:srgbClr val="8A6530"/>
+                </a:solidFill>
+                <a:latin typeface="Helvetica Neue"/>
               </a:rPr>
               <a:t>Spoiler : il n'y a pas de gagnant. Le seul qui gagne, c'est le code — testé sous deux angles.</a:t>
             </a:r>
@@ -7019,9 +7019,9 @@
             <a:r>
               <a:rPr sz="1000" b="0" i="0">
                 <a:solidFill>
-                  <a:srgbClr val="8B93A1"/>
-                </a:solidFill>
-                <a:latin typeface="Calibri"/>
+                  <a:srgbClr val="5E6674"/>
+                </a:solidFill>
+                <a:latin typeface="Helvetica Neue"/>
               </a:rPr>
               <a:t>12 / 28</a:t>
             </a:r>
@@ -7061,9 +7061,9 @@
             <a:r>
               <a:rPr sz="800" b="0" i="0">
                 <a:solidFill>
-                  <a:srgbClr val="8B93A1"/>
-                </a:solidFill>
-                <a:latin typeface="Calibri"/>
+                  <a:srgbClr val="5E6674"/>
+                </a:solidFill>
+                <a:latin typeface="Helvetica Neue"/>
               </a:rPr>
               <a:t>COUVERTURE DE CODE — QUARKUS · JUNIT · CUCUMBER · JACOCO</a:t>
             </a:r>
@@ -8455,7 +8455,52 @@
       </p:sp>
       <p:sp>
         <p:nvSpPr>
-          <p:cNvPr id="32" name="TextBox 31"/>
+          <p:cNvPr id="32" name="Oval 31"/>
+          <p:cNvSpPr/>
+          <p:nvPr/>
+        </p:nvSpPr>
+        <p:spPr>
+          <a:xfrm>
+            <a:off x="5995263" y="2286000"/>
+            <a:ext cx="201168" cy="201168"/>
+          </a:xfrm>
+          <a:prstGeom prst="ellipse">
+            <a:avLst/>
+          </a:prstGeom>
+          <a:solidFill>
+            <a:srgbClr val="BF6F5D"/>
+          </a:solidFill>
+          <a:ln>
+            <a:noFill/>
+          </a:ln>
+          <a:effectLst/>
+        </p:spPr>
+        <p:style>
+          <a:lnRef idx="1">
+            <a:schemeClr val="accent1"/>
+          </a:lnRef>
+          <a:fillRef idx="3">
+            <a:schemeClr val="accent1"/>
+          </a:fillRef>
+          <a:effectRef idx="2">
+            <a:schemeClr val="accent1"/>
+          </a:effectRef>
+          <a:fontRef idx="minor">
+            <a:schemeClr val="lt1"/>
+          </a:fontRef>
+        </p:style>
+        <p:txBody>
+          <a:bodyPr rtlCol="0" anchor="ctr"/>
+          <a:lstStyle/>
+          <a:p>
+            <a:pPr algn="ctr"/>
+            <a:endParaRPr/>
+          </a:p>
+        </p:txBody>
+      </p:sp>
+      <p:sp>
+        <p:nvSpPr>
+          <p:cNvPr id="33" name="TextBox 32"/>
           <p:cNvSpPr txBox="1"/>
           <p:nvPr/>
         </p:nvSpPr>
@@ -8488,16 +8533,16 @@
                 <a:solidFill>
                   <a:srgbClr val="EFECE3"/>
                 </a:solidFill>
-                <a:latin typeface="Calibri"/>
-              </a:rPr>
-              <a:t>🎬  EN DIRECT</a:t>
-            </a:r>
-          </a:p>
-        </p:txBody>
-      </p:sp>
-      <p:sp>
-        <p:nvSpPr>
-          <p:cNvPr id="33" name="TextBox 32"/>
+                <a:latin typeface="Helvetica Neue"/>
+              </a:rPr>
+              <a:t>EN DIRECT</a:t>
+            </a:r>
+          </a:p>
+        </p:txBody>
+      </p:sp>
+      <p:sp>
+        <p:nvSpPr>
+          <p:cNvPr id="34" name="TextBox 33"/>
           <p:cNvSpPr txBox="1"/>
           <p:nvPr/>
         </p:nvSpPr>
@@ -8530,7 +8575,7 @@
                 <a:solidFill>
                   <a:srgbClr val="C79A52"/>
                 </a:solidFill>
-                <a:latin typeface="Calibri"/>
+                <a:latin typeface="Helvetica Neue"/>
               </a:rPr>
               <a:t>(fermez Slack. ça va aller vite, mais pas invisible)</a:t>
             </a:r>
@@ -8539,7 +8584,7 @@
       </p:sp>
       <p:sp>
         <p:nvSpPr>
-          <p:cNvPr id="34" name="TextBox 33"/>
+          <p:cNvPr id="35" name="TextBox 34"/>
           <p:cNvSpPr txBox="1"/>
           <p:nvPr/>
         </p:nvSpPr>
@@ -8570,9 +8615,9 @@
             <a:r>
               <a:rPr sz="1000" b="0" i="0">
                 <a:solidFill>
-                  <a:srgbClr val="6E7A8E"/>
-                </a:solidFill>
-                <a:latin typeface="Calibri"/>
+                  <a:srgbClr val="8B93A1"/>
+                </a:solidFill>
+                <a:latin typeface="Helvetica Neue"/>
               </a:rPr>
               <a:t>13 / 28</a:t>
             </a:r>
@@ -8581,7 +8626,7 @@
       </p:sp>
       <p:sp>
         <p:nvSpPr>
-          <p:cNvPr id="35" name="TextBox 34"/>
+          <p:cNvPr id="36" name="TextBox 35"/>
           <p:cNvSpPr txBox="1"/>
           <p:nvPr/>
         </p:nvSpPr>
@@ -8612,9 +8657,9 @@
             <a:r>
               <a:rPr sz="800" b="0" i="0">
                 <a:solidFill>
-                  <a:srgbClr val="6E7A8E"/>
-                </a:solidFill>
-                <a:latin typeface="Calibri"/>
+                  <a:srgbClr val="8B93A1"/>
+                </a:solidFill>
+                <a:latin typeface="Helvetica Neue"/>
               </a:rPr>
               <a:t>COUVERTURE DE CODE — QUARKUS · JUNIT · CUCUMBER · JACOCO</a:t>
             </a:r>
@@ -8732,9 +8777,9 @@
             <a:r>
               <a:rPr sz="1300" b="1" i="0">
                 <a:solidFill>
-                  <a:srgbClr val="BF6F5D"/>
-                </a:solidFill>
-                <a:latin typeface="Calibri"/>
+                  <a:srgbClr val="8F4536"/>
+                </a:solidFill>
+                <a:latin typeface="Helvetica Neue"/>
               </a:rPr>
               <a:t>ZOOM — JACOCO</a:t>
             </a:r>
@@ -8776,7 +8821,7 @@
                 <a:solidFill>
                   <a:srgbClr val="162844"/>
                 </a:solidFill>
-                <a:latin typeface="Calibri"/>
+                <a:latin typeface="Helvetica Neue"/>
               </a:rPr>
               <a:t>Un agent qui espionne le bytecode (légalement)</a:t>
             </a:r>
@@ -8863,7 +8908,7 @@
                 <a:solidFill>
                   <a:srgbClr val="C79A52"/>
                 </a:solidFill>
-                <a:latin typeface="Calibri"/>
+                <a:latin typeface="Helvetica Neue"/>
               </a:rPr>
               <a:t>1</a:t>
             </a:r>
@@ -8905,7 +8950,7 @@
                 <a:solidFill>
                   <a:srgbClr val="162844"/>
                 </a:solidFill>
-                <a:latin typeface="Calibri"/>
+                <a:latin typeface="Helvetica Neue"/>
               </a:rPr>
               <a:t>Au démarrage de la JVM</a:t>
             </a:r>
@@ -8947,7 +8992,7 @@
                 <a:solidFill>
                   <a:srgbClr val="333A47"/>
                 </a:solidFill>
-                <a:latin typeface="Calibri"/>
+                <a:latin typeface="Helvetica Neue"/>
               </a:rPr>
               <a:t>Un agent Java (-javaagent) s'attache et instrumente chaque classe chargée.</a:t>
             </a:r>
@@ -9034,7 +9079,7 @@
                 <a:solidFill>
                   <a:srgbClr val="C79A52"/>
                 </a:solidFill>
-                <a:latin typeface="Calibri"/>
+                <a:latin typeface="Helvetica Neue"/>
               </a:rPr>
               <a:t>2</a:t>
             </a:r>
@@ -9076,7 +9121,7 @@
                 <a:solidFill>
                   <a:srgbClr val="162844"/>
                 </a:solidFill>
-                <a:latin typeface="Calibri"/>
+                <a:latin typeface="Helvetica Neue"/>
               </a:rPr>
               <a:t>Pendant les tests</a:t>
             </a:r>
@@ -9118,7 +9163,7 @@
                 <a:solidFill>
                   <a:srgbClr val="333A47"/>
                 </a:solidFill>
-                <a:latin typeface="Calibri"/>
+                <a:latin typeface="Helvetica Neue"/>
               </a:rPr>
               <a:t>Chaque ligne, chaque branche exécutée est comptée — en silence, sans ralentir grand-chose.</a:t>
             </a:r>
@@ -9205,7 +9250,7 @@
                 <a:solidFill>
                   <a:srgbClr val="C79A52"/>
                 </a:solidFill>
-                <a:latin typeface="Calibri"/>
+                <a:latin typeface="Helvetica Neue"/>
               </a:rPr>
               <a:t>3</a:t>
             </a:r>
@@ -9247,7 +9292,7 @@
                 <a:solidFill>
                   <a:srgbClr val="162844"/>
                 </a:solidFill>
-                <a:latin typeface="Calibri"/>
+                <a:latin typeface="Helvetica Neue"/>
               </a:rPr>
               <a:t>À l'arrêt de la JVM</a:t>
             </a:r>
@@ -9289,7 +9334,7 @@
                 <a:solidFill>
                   <a:srgbClr val="333A47"/>
                 </a:solidFill>
-                <a:latin typeface="Calibri"/>
+                <a:latin typeface="Helvetica Neue"/>
               </a:rPr>
               <a:t>Tout est vidé dans un fichier .exec. Puis jacoco-maven-plugin le transforme en rapport HTML/XML/CSV.</a:t>
             </a:r>
@@ -9329,9 +9374,9 @@
             <a:r>
               <a:rPr sz="1350" b="0" i="1">
                 <a:solidFill>
-                  <a:srgbClr val="BF6F5D"/>
-                </a:solidFill>
-                <a:latin typeface="Calibri"/>
+                  <a:srgbClr val="8F4536"/>
+                </a:solidFill>
+                <a:latin typeface="Helvetica Neue"/>
               </a:rPr>
               <a:t>Non, ce n'est pas de l'espionnage industriel. C'est juste un agent très curieux.</a:t>
             </a:r>
@@ -9371,9 +9416,9 @@
             <a:r>
               <a:rPr sz="1000" b="0" i="0">
                 <a:solidFill>
-                  <a:srgbClr val="8B93A1"/>
-                </a:solidFill>
-                <a:latin typeface="Calibri"/>
+                  <a:srgbClr val="5E6674"/>
+                </a:solidFill>
+                <a:latin typeface="Helvetica Neue"/>
               </a:rPr>
               <a:t>14 / 28</a:t>
             </a:r>
@@ -9413,9 +9458,9 @@
             <a:r>
               <a:rPr sz="800" b="0" i="0">
                 <a:solidFill>
-                  <a:srgbClr val="8B93A1"/>
-                </a:solidFill>
-                <a:latin typeface="Calibri"/>
+                  <a:srgbClr val="5E6674"/>
+                </a:solidFill>
+                <a:latin typeface="Helvetica Neue"/>
               </a:rPr>
               <a:t>COUVERTURE DE CODE — QUARKUS · JUNIT · CUCUMBER · JACOCO</a:t>
             </a:r>
@@ -9533,9 +9578,9 @@
             <a:r>
               <a:rPr sz="1300" b="1" i="0">
                 <a:solidFill>
-                  <a:srgbClr val="BF6F5D"/>
-                </a:solidFill>
-                <a:latin typeface="Calibri"/>
+                  <a:srgbClr val="8F4536"/>
+                </a:solidFill>
+                <a:latin typeface="Helvetica Neue"/>
               </a:rPr>
               <a:t>JACOCO — LE RAPPORT</a:t>
             </a:r>
@@ -9577,7 +9622,7 @@
                 <a:solidFill>
                   <a:srgbClr val="162844"/>
                 </a:solidFill>
-                <a:latin typeface="Calibri"/>
+                <a:latin typeface="Helvetica Neue"/>
               </a:rPr>
               <a:t>Pas une maquette. Le vrai rapport.</a:t>
             </a:r>
@@ -9686,9 +9731,9 @@
             <a:r>
               <a:rPr sz="1300" b="0" i="1">
                 <a:solidFill>
-                  <a:srgbClr val="8B93A1"/>
-                </a:solidFill>
-                <a:latin typeface="Calibri"/>
+                  <a:srgbClr val="5E6674"/>
+                </a:solidFill>
+                <a:latin typeface="Helvetica Neue"/>
               </a:rPr>
               <a:t>Capture d'écran réelle de target/jacoco-report/index.html sur ce projet, à l'instant T.</a:t>
             </a:r>
@@ -9728,9 +9773,9 @@
             <a:r>
               <a:rPr sz="1000" b="0" i="0">
                 <a:solidFill>
-                  <a:srgbClr val="8B93A1"/>
-                </a:solidFill>
-                <a:latin typeface="Calibri"/>
+                  <a:srgbClr val="5E6674"/>
+                </a:solidFill>
+                <a:latin typeface="Helvetica Neue"/>
               </a:rPr>
               <a:t>15 / 28</a:t>
             </a:r>
@@ -9770,9 +9815,9 @@
             <a:r>
               <a:rPr sz="800" b="0" i="0">
                 <a:solidFill>
-                  <a:srgbClr val="8B93A1"/>
-                </a:solidFill>
-                <a:latin typeface="Calibri"/>
+                  <a:srgbClr val="5E6674"/>
+                </a:solidFill>
+                <a:latin typeface="Helvetica Neue"/>
               </a:rPr>
               <a:t>COUVERTURE DE CODE — QUARKUS · JUNIT · CUCUMBER · JACOCO</a:t>
             </a:r>
@@ -9890,9 +9935,9 @@
             <a:r>
               <a:rPr sz="1300" b="1" i="0">
                 <a:solidFill>
-                  <a:srgbClr val="BF6F5D"/>
-                </a:solidFill>
-                <a:latin typeface="Calibri"/>
+                  <a:srgbClr val="8F4536"/>
+                </a:solidFill>
+                <a:latin typeface="Helvetica Neue"/>
               </a:rPr>
               <a:t>JACOCO — LA PREUVE</a:t>
             </a:r>
@@ -9934,7 +9979,7 @@
                 <a:solidFill>
                   <a:srgbClr val="162844"/>
                 </a:solidFill>
-                <a:latin typeface="Calibri"/>
+                <a:latin typeface="Helvetica Neue"/>
               </a:rPr>
               <a:t>La branche MENSUELLE, prise en flagrant délit</a:t>
             </a:r>
@@ -10043,9 +10088,9 @@
             <a:r>
               <a:rPr sz="1000" b="0" i="0">
                 <a:solidFill>
-                  <a:srgbClr val="8B93A1"/>
-                </a:solidFill>
-                <a:latin typeface="Calibri"/>
+                  <a:srgbClr val="5E6674"/>
+                </a:solidFill>
+                <a:latin typeface="Helvetica Neue"/>
               </a:rPr>
               <a:t>16 / 28</a:t>
             </a:r>
@@ -10085,9 +10130,9 @@
             <a:r>
               <a:rPr sz="800" b="0" i="0">
                 <a:solidFill>
-                  <a:srgbClr val="8B93A1"/>
-                </a:solidFill>
-                <a:latin typeface="Calibri"/>
+                  <a:srgbClr val="5E6674"/>
+                </a:solidFill>
+                <a:latin typeface="Helvetica Neue"/>
               </a:rPr>
               <a:t>COUVERTURE DE CODE — QUARKUS · JUNIT · CUCUMBER · JACOCO</a:t>
             </a:r>
@@ -10205,9 +10250,9 @@
             <a:r>
               <a:rPr sz="1300" b="1" i="0">
                 <a:solidFill>
-                  <a:srgbClr val="BF6F5D"/>
-                </a:solidFill>
-                <a:latin typeface="Calibri"/>
+                  <a:srgbClr val="8F4536"/>
+                </a:solidFill>
+                <a:latin typeface="Helvetica Neue"/>
               </a:rPr>
               <a:t>JACOCO</a:t>
             </a:r>
@@ -10249,7 +10294,7 @@
                 <a:solidFill>
                   <a:srgbClr val="162844"/>
                 </a:solidFill>
-                <a:latin typeface="Calibri"/>
+                <a:latin typeface="Helvetica Neue"/>
               </a:rPr>
               <a:t>Ce que les tests ont vraiment touché</a:t>
             </a:r>
@@ -10289,9 +10334,9 @@
             <a:r>
               <a:rPr sz="1300" b="0" i="1">
                 <a:solidFill>
-                  <a:srgbClr val="8B93A1"/>
-                </a:solidFill>
-                <a:latin typeface="Calibri"/>
+                  <a:srgbClr val="5E6674"/>
+                </a:solidFill>
+                <a:latin typeface="Helvetica Neue"/>
               </a:rPr>
               <a:t>Mesure réelle, extraite du build — couverture de lignes, JUnit contre Cucumber</a:t>
             </a:r>
@@ -10313,7 +10358,7 @@
             <a:avLst/>
           </a:prstGeom>
           <a:solidFill>
-            <a:srgbClr val="C79A52"/>
+            <a:srgbClr val="8A6530"/>
           </a:solidFill>
           <a:ln>
             <a:noFill/>
@@ -10378,7 +10423,7 @@
                 <a:solidFill>
                   <a:srgbClr val="162844"/>
                 </a:solidFill>
-                <a:latin typeface="Calibri"/>
+                <a:latin typeface="Helvetica Neue"/>
               </a:rPr>
               <a:t>JUnit (unitaire)</a:t>
             </a:r>
@@ -10465,7 +10510,7 @@
                 <a:solidFill>
                   <a:srgbClr val="162844"/>
                 </a:solidFill>
-                <a:latin typeface="Calibri"/>
+                <a:latin typeface="Helvetica Neue"/>
               </a:rPr>
               <a:t>Cucumber (intégration)</a:t>
             </a:r>
@@ -10507,7 +10552,7 @@
                 <a:solidFill>
                   <a:srgbClr val="162844"/>
                 </a:solidFill>
-                <a:latin typeface="Calibri"/>
+                <a:latin typeface="Helvetica Neue"/>
               </a:rPr>
               <a:t>CalendarResource</a:t>
             </a:r>
@@ -10574,7 +10619,7 @@
             <a:avLst/>
           </a:prstGeom>
           <a:solidFill>
-            <a:srgbClr val="C79A52"/>
+            <a:srgbClr val="8A6530"/>
           </a:solidFill>
           <a:ln>
             <a:noFill/>
@@ -10639,7 +10684,7 @@
                 <a:solidFill>
                   <a:srgbClr val="162844"/>
                 </a:solidFill>
-                <a:latin typeface="Calibri"/>
+                <a:latin typeface="Helvetica Neue"/>
               </a:rPr>
               <a:t>0%</a:t>
             </a:r>
@@ -10771,7 +10816,7 @@
                 <a:solidFill>
                   <a:srgbClr val="162844"/>
                 </a:solidFill>
-                <a:latin typeface="Calibri"/>
+                <a:latin typeface="Helvetica Neue"/>
               </a:rPr>
               <a:t>58%</a:t>
             </a:r>
@@ -10813,7 +10858,7 @@
                 <a:solidFill>
                   <a:srgbClr val="162844"/>
                 </a:solidFill>
-                <a:latin typeface="Calibri"/>
+                <a:latin typeface="Helvetica Neue"/>
               </a:rPr>
               <a:t>HolidayService</a:t>
             </a:r>
@@ -10880,7 +10925,7 @@
             <a:avLst/>
           </a:prstGeom>
           <a:solidFill>
-            <a:srgbClr val="C79A52"/>
+            <a:srgbClr val="8A6530"/>
           </a:solidFill>
           <a:ln>
             <a:noFill/>
@@ -10945,7 +10990,7 @@
                 <a:solidFill>
                   <a:srgbClr val="162844"/>
                 </a:solidFill>
-                <a:latin typeface="Calibri"/>
+                <a:latin typeface="Helvetica Neue"/>
               </a:rPr>
               <a:t>0%</a:t>
             </a:r>
@@ -11077,7 +11122,7 @@
                 <a:solidFill>
                   <a:srgbClr val="162844"/>
                 </a:solidFill>
-                <a:latin typeface="Calibri"/>
+                <a:latin typeface="Helvetica Neue"/>
               </a:rPr>
               <a:t>93%</a:t>
             </a:r>
@@ -11119,7 +11164,7 @@
                 <a:solidFill>
                   <a:srgbClr val="162844"/>
                 </a:solidFill>
-                <a:latin typeface="Calibri"/>
+                <a:latin typeface="Helvetica Neue"/>
               </a:rPr>
               <a:t>RecurrenceService</a:t>
             </a:r>
@@ -11186,7 +11231,7 @@
             <a:avLst/>
           </a:prstGeom>
           <a:solidFill>
-            <a:srgbClr val="C79A52"/>
+            <a:srgbClr val="8A6530"/>
           </a:solidFill>
           <a:ln>
             <a:noFill/>
@@ -11251,7 +11296,7 @@
                 <a:solidFill>
                   <a:srgbClr val="162844"/>
                 </a:solidFill>
-                <a:latin typeface="Calibri"/>
+                <a:latin typeface="Helvetica Neue"/>
               </a:rPr>
               <a:t>78%</a:t>
             </a:r>
@@ -11383,7 +11428,7 @@
                 <a:solidFill>
                   <a:srgbClr val="162844"/>
                 </a:solidFill>
-                <a:latin typeface="Calibri"/>
+                <a:latin typeface="Helvetica Neue"/>
               </a:rPr>
               <a:t>4%</a:t>
             </a:r>
@@ -11425,7 +11470,7 @@
                 <a:solidFill>
                   <a:srgbClr val="162844"/>
                 </a:solidFill>
-                <a:latin typeface="Calibri"/>
+                <a:latin typeface="Helvetica Neue"/>
               </a:rPr>
               <a:t>ConflictDetector</a:t>
             </a:r>
@@ -11492,7 +11537,7 @@
             <a:avLst/>
           </a:prstGeom>
           <a:solidFill>
-            <a:srgbClr val="C79A52"/>
+            <a:srgbClr val="8A6530"/>
           </a:solidFill>
           <a:ln>
             <a:noFill/>
@@ -11557,7 +11602,7 @@
                 <a:solidFill>
                   <a:srgbClr val="162844"/>
                 </a:solidFill>
-                <a:latin typeface="Calibri"/>
+                <a:latin typeface="Helvetica Neue"/>
               </a:rPr>
               <a:t>100%</a:t>
             </a:r>
@@ -11689,7 +11734,7 @@
                 <a:solidFill>
                   <a:srgbClr val="162844"/>
                 </a:solidFill>
-                <a:latin typeface="Calibri"/>
+                <a:latin typeface="Helvetica Neue"/>
               </a:rPr>
               <a:t>75%</a:t>
             </a:r>
@@ -11731,7 +11776,7 @@
                 <a:solidFill>
                   <a:srgbClr val="162844"/>
                 </a:solidFill>
-                <a:latin typeface="Calibri"/>
+                <a:latin typeface="Helvetica Neue"/>
               </a:rPr>
               <a:t>EventService</a:t>
             </a:r>
@@ -11798,7 +11843,7 @@
             <a:avLst/>
           </a:prstGeom>
           <a:solidFill>
-            <a:srgbClr val="C79A52"/>
+            <a:srgbClr val="8A6530"/>
           </a:solidFill>
           <a:ln>
             <a:noFill/>
@@ -11863,7 +11908,7 @@
                 <a:solidFill>
                   <a:srgbClr val="162844"/>
                 </a:solidFill>
-                <a:latin typeface="Calibri"/>
+                <a:latin typeface="Helvetica Neue"/>
               </a:rPr>
               <a:t>88%</a:t>
             </a:r>
@@ -11995,7 +12040,7 @@
                 <a:solidFill>
                   <a:srgbClr val="162844"/>
                 </a:solidFill>
-                <a:latin typeface="Calibri"/>
+                <a:latin typeface="Helvetica Neue"/>
               </a:rPr>
               <a:t>88%</a:t>
             </a:r>
@@ -12037,7 +12082,7 @@
                 <a:solidFill>
                   <a:srgbClr val="162844"/>
                 </a:solidFill>
-                <a:latin typeface="Calibri"/>
+                <a:latin typeface="Helvetica Neue"/>
               </a:rPr>
               <a:t>RecurrenceRequest (DTO)</a:t>
             </a:r>
@@ -12104,7 +12149,7 @@
             <a:avLst/>
           </a:prstGeom>
           <a:solidFill>
-            <a:srgbClr val="C79A52"/>
+            <a:srgbClr val="8A6530"/>
           </a:solidFill>
           <a:ln>
             <a:noFill/>
@@ -12169,7 +12214,7 @@
                 <a:solidFill>
                   <a:srgbClr val="162844"/>
                 </a:solidFill>
-                <a:latin typeface="Calibri"/>
+                <a:latin typeface="Helvetica Neue"/>
               </a:rPr>
               <a:t>0%</a:t>
             </a:r>
@@ -12301,7 +12346,7 @@
                 <a:solidFill>
                   <a:srgbClr val="162844"/>
                 </a:solidFill>
-                <a:latin typeface="Calibri"/>
+                <a:latin typeface="Helvetica Neue"/>
               </a:rPr>
               <a:t>0%</a:t>
             </a:r>
@@ -12341,9 +12386,9 @@
             <a:r>
               <a:rPr sz="1200" b="0" i="1">
                 <a:solidFill>
-                  <a:srgbClr val="8B93A1"/>
-                </a:solidFill>
-                <a:latin typeface="Calibri"/>
+                  <a:srgbClr val="5E6674"/>
+                </a:solidFill>
+                <a:latin typeface="Helvetica Neue"/>
               </a:rPr>
               <a:t>JUnit couvre la logique métier ; Cucumber couvre la couche REST — presque aucun recouvrement.</a:t>
             </a:r>
@@ -12383,9 +12428,9 @@
             <a:r>
               <a:rPr sz="1000" b="0" i="0">
                 <a:solidFill>
-                  <a:srgbClr val="8B93A1"/>
-                </a:solidFill>
-                <a:latin typeface="Calibri"/>
+                  <a:srgbClr val="5E6674"/>
+                </a:solidFill>
+                <a:latin typeface="Helvetica Neue"/>
               </a:rPr>
               <a:t>17 / 28</a:t>
             </a:r>
@@ -12425,9 +12470,9 @@
             <a:r>
               <a:rPr sz="800" b="0" i="0">
                 <a:solidFill>
-                  <a:srgbClr val="8B93A1"/>
-                </a:solidFill>
-                <a:latin typeface="Calibri"/>
+                  <a:srgbClr val="5E6674"/>
+                </a:solidFill>
+                <a:latin typeface="Helvetica Neue"/>
               </a:rPr>
               <a:t>COUVERTURE DE CODE — QUARKUS · JUNIT · CUCUMBER · JACOCO</a:t>
             </a:r>
@@ -12502,7 +12547,7 @@
                 <a:solidFill>
                   <a:srgbClr val="C79A52"/>
                 </a:solidFill>
-                <a:latin typeface="Calibri"/>
+                <a:latin typeface="Helvetica Neue"/>
               </a:rPr>
               <a:t>SANS OUVRIR DE NAVIGATEUR</a:t>
             </a:r>
@@ -12544,7 +12589,7 @@
                 <a:solidFill>
                   <a:srgbClr val="EFECE3"/>
                 </a:solidFill>
-                <a:latin typeface="Calibri"/>
+                <a:latin typeface="Helvetica Neue"/>
               </a:rPr>
               <a:t>Le récap, direct dans le terminal</a:t>
             </a:r>
@@ -12653,9 +12698,9 @@
             <a:r>
               <a:rPr sz="1000" b="0" i="0">
                 <a:solidFill>
-                  <a:srgbClr val="6E7A8E"/>
-                </a:solidFill>
-                <a:latin typeface="Calibri"/>
+                  <a:srgbClr val="8B93A1"/>
+                </a:solidFill>
+                <a:latin typeface="Helvetica Neue"/>
               </a:rPr>
               <a:t>18 / 28</a:t>
             </a:r>
@@ -12695,9 +12740,9 @@
             <a:r>
               <a:rPr sz="800" b="0" i="0">
                 <a:solidFill>
-                  <a:srgbClr val="6E7A8E"/>
-                </a:solidFill>
-                <a:latin typeface="Calibri"/>
+                  <a:srgbClr val="8B93A1"/>
+                </a:solidFill>
+                <a:latin typeface="Helvetica Neue"/>
               </a:rPr>
               <a:t>COUVERTURE DE CODE — QUARKUS · JUNIT · CUCUMBER · JACOCO</a:t>
             </a:r>
@@ -12815,9 +12860,9 @@
             <a:r>
               <a:rPr sz="1300" b="1" i="0">
                 <a:solidFill>
-                  <a:srgbClr val="C79A52"/>
-                </a:solidFill>
-                <a:latin typeface="Calibri"/>
+                  <a:srgbClr val="8A6530"/>
+                </a:solidFill>
+                <a:latin typeface="Helvetica Neue"/>
               </a:rPr>
               <a:t>EN DIRECT</a:t>
             </a:r>
@@ -12859,7 +12904,7 @@
                 <a:solidFill>
                   <a:srgbClr val="162844"/>
                 </a:solidFill>
-                <a:latin typeface="Calibri"/>
+                <a:latin typeface="Helvetica Neue"/>
               </a:rPr>
               <a:t>Trois commandes, un radar complet</a:t>
             </a:r>
@@ -12946,7 +12991,7 @@
                 <a:solidFill>
                   <a:srgbClr val="C79A52"/>
                 </a:solidFill>
-                <a:latin typeface="Calibri"/>
+                <a:latin typeface="Helvetica Neue"/>
               </a:rPr>
               <a:t>1</a:t>
             </a:r>
@@ -12988,7 +13033,7 @@
                 <a:solidFill>
                   <a:srgbClr val="162844"/>
                 </a:solidFill>
-                <a:latin typeface="Consolas"/>
+                <a:latin typeface="Menlo"/>
               </a:rPr>
               <a:t>./mvnw test</a:t>
             </a:r>
@@ -13030,7 +13075,7 @@
                 <a:solidFill>
                   <a:srgbClr val="333A47"/>
                 </a:solidFill>
-                <a:latin typeface="Calibri"/>
+                <a:latin typeface="Helvetica Neue"/>
               </a:rPr>
               <a:t>Build + JUnit + Cucumber + 3 rapports Jacoco générés automatiquement.</a:t>
             </a:r>
@@ -13117,7 +13162,7 @@
                 <a:solidFill>
                   <a:srgbClr val="C79A52"/>
                 </a:solidFill>
-                <a:latin typeface="Calibri"/>
+                <a:latin typeface="Helvetica Neue"/>
               </a:rPr>
               <a:t>2</a:t>
             </a:r>
@@ -13159,7 +13204,7 @@
                 <a:solidFill>
                   <a:srgbClr val="162844"/>
                 </a:solidFill>
-                <a:latin typeface="Consolas"/>
+                <a:latin typeface="Menlo"/>
               </a:rPr>
               <a:t>./scripts/coverage-summary.sh</a:t>
             </a:r>
@@ -13201,7 +13246,7 @@
                 <a:solidFill>
                   <a:srgbClr val="333A47"/>
                 </a:solidFill>
-                <a:latin typeface="Calibri"/>
+                <a:latin typeface="Helvetica Neue"/>
               </a:rPr>
               <a:t>Le récap coloré JUnit / Cucumber / global, côte à côte, dans le terminal.</a:t>
             </a:r>
@@ -13288,7 +13333,7 @@
                 <a:solidFill>
                   <a:srgbClr val="C79A52"/>
                 </a:solidFill>
-                <a:latin typeface="Calibri"/>
+                <a:latin typeface="Helvetica Neue"/>
               </a:rPr>
               <a:t>3</a:t>
             </a:r>
@@ -13330,7 +13375,7 @@
                 <a:solidFill>
                   <a:srgbClr val="162844"/>
                 </a:solidFill>
-                <a:latin typeface="Consolas"/>
+                <a:latin typeface="Menlo"/>
               </a:rPr>
               <a:t>open target/jacoco-report/index.html</a:t>
             </a:r>
@@ -13372,7 +13417,7 @@
                 <a:solidFill>
                   <a:srgbClr val="333A47"/>
                 </a:solidFill>
-                <a:latin typeface="Calibri"/>
+                <a:latin typeface="Helvetica Neue"/>
               </a:rPr>
               <a:t>Le détail ligne par ligne — et les variantes -junit / -cucumber pour comparer.</a:t>
             </a:r>
@@ -13412,9 +13457,9 @@
             <a:r>
               <a:rPr sz="1000" b="0" i="0">
                 <a:solidFill>
-                  <a:srgbClr val="8B93A1"/>
-                </a:solidFill>
-                <a:latin typeface="Calibri"/>
+                  <a:srgbClr val="5E6674"/>
+                </a:solidFill>
+                <a:latin typeface="Helvetica Neue"/>
               </a:rPr>
               <a:t>19 / 28</a:t>
             </a:r>
@@ -13454,9 +13499,9 @@
             <a:r>
               <a:rPr sz="800" b="0" i="0">
                 <a:solidFill>
-                  <a:srgbClr val="8B93A1"/>
-                </a:solidFill>
-                <a:latin typeface="Calibri"/>
+                  <a:srgbClr val="5E6674"/>
+                </a:solidFill>
+                <a:latin typeface="Helvetica Neue"/>
               </a:rPr>
               <a:t>COUVERTURE DE CODE — QUARKUS · JUNIT · CUCUMBER · JACOCO</a:t>
             </a:r>
@@ -13574,9 +13619,9 @@
             <a:r>
               <a:rPr sz="1300" b="1" i="0">
                 <a:solidFill>
-                  <a:srgbClr val="C79A52"/>
-                </a:solidFill>
-                <a:latin typeface="Calibri"/>
+                  <a:srgbClr val="8A6530"/>
+                </a:solidFill>
+                <a:latin typeface="Helvetica Neue"/>
               </a:rPr>
               <a:t>AVANT DE COMMENCER</a:t>
             </a:r>
@@ -13618,7 +13663,7 @@
                 <a:solidFill>
                   <a:srgbClr val="162844"/>
                 </a:solidFill>
-                <a:latin typeface="Calibri"/>
+                <a:latin typeface="Helvetica Neue"/>
               </a:rPr>
               <a:t>Qui suis-je ?</a:t>
             </a:r>
@@ -13750,7 +13795,7 @@
                 <a:solidFill>
                   <a:srgbClr val="162844"/>
                 </a:solidFill>
-                <a:latin typeface="Calibri"/>
+                <a:latin typeface="Helvetica Neue"/>
               </a:rPr>
               <a:t>Développeur Java</a:t>
             </a:r>
@@ -13792,7 +13837,7 @@
                 <a:solidFill>
                   <a:srgbClr val="333A47"/>
                 </a:solidFill>
-                <a:latin typeface="Calibri"/>
+                <a:latin typeface="Helvetica Neue"/>
               </a:rPr>
               <a:t>Suffisamment d'années pour avoir déjà tout cassé au moins une fois.</a:t>
             </a:r>
@@ -13924,7 +13969,7 @@
                 <a:solidFill>
                   <a:srgbClr val="162844"/>
                 </a:solidFill>
-                <a:latin typeface="Calibri"/>
+                <a:latin typeface="Helvetica Neue"/>
               </a:rPr>
               <a:t>Écrit des tests</a:t>
             </a:r>
@@ -13966,7 +14011,7 @@
                 <a:solidFill>
                   <a:srgbClr val="333A47"/>
                 </a:solidFill>
-                <a:latin typeface="Calibri"/>
+                <a:latin typeface="Helvetica Neue"/>
               </a:rPr>
               <a:t>Un ratio tests / code que je ne montrerai à personne aujourd'hui.</a:t>
             </a:r>
@@ -14098,7 +14143,7 @@
                 <a:solidFill>
                   <a:srgbClr val="162844"/>
                 </a:solidFill>
-                <a:latin typeface="Calibri"/>
+                <a:latin typeface="Helvetica Neue"/>
               </a:rPr>
               <a:t>Ici pour une raison précise</a:t>
             </a:r>
@@ -14140,7 +14185,7 @@
                 <a:solidFill>
                   <a:srgbClr val="333A47"/>
                 </a:solidFill>
-                <a:latin typeface="Calibri"/>
+                <a:latin typeface="Helvetica Neue"/>
               </a:rPr>
               <a:t>Vous convaincre de regarder VOTRE rapport de couverture. Le vrai. Pas celui que vous imaginez.</a:t>
             </a:r>
@@ -14180,9 +14225,9 @@
             <a:r>
               <a:rPr sz="1100" b="0" i="1">
                 <a:solidFill>
-                  <a:srgbClr val="8B93A1"/>
-                </a:solidFill>
-                <a:latin typeface="Calibri"/>
+                  <a:srgbClr val="5E6674"/>
+                </a:solidFill>
+                <a:latin typeface="Helvetica Neue"/>
               </a:rPr>
               <a:t>(personnalisez cette slide avec votre vraie bio avant le jour J)</a:t>
             </a:r>
@@ -14222,9 +14267,9 @@
             <a:r>
               <a:rPr sz="1000" b="0" i="0">
                 <a:solidFill>
-                  <a:srgbClr val="8B93A1"/>
-                </a:solidFill>
-                <a:latin typeface="Calibri"/>
+                  <a:srgbClr val="5E6674"/>
+                </a:solidFill>
+                <a:latin typeface="Helvetica Neue"/>
               </a:rPr>
               <a:t>02 / 28</a:t>
             </a:r>
@@ -14264,9 +14309,9 @@
             <a:r>
               <a:rPr sz="800" b="0" i="0">
                 <a:solidFill>
-                  <a:srgbClr val="8B93A1"/>
-                </a:solidFill>
-                <a:latin typeface="Calibri"/>
+                  <a:srgbClr val="5E6674"/>
+                </a:solidFill>
+                <a:latin typeface="Helvetica Neue"/>
               </a:rPr>
               <a:t>COUVERTURE DE CODE — QUARKUS · JUNIT · CUCUMBER · JACOCO</a:t>
             </a:r>
@@ -14341,7 +14386,7 @@
                 <a:solidFill>
                   <a:srgbClr val="C79A52"/>
                 </a:solidFill>
-                <a:latin typeface="Calibri"/>
+                <a:latin typeface="Helvetica Neue"/>
               </a:rPr>
               <a:t>BONUS</a:t>
             </a:r>
@@ -14383,7 +14428,7 @@
                 <a:solidFill>
                   <a:srgbClr val="EFECE3"/>
                 </a:solidFill>
-                <a:latin typeface="Calibri"/>
+                <a:latin typeface="Helvetica Neue"/>
               </a:rPr>
               <a:t>Et dans un vrai dashboard ?</a:t>
             </a:r>
@@ -14425,7 +14470,7 @@
                 <a:solidFill>
                   <a:srgbClr val="C8CFDA"/>
                 </a:solidFill>
-                <a:latin typeface="Calibri"/>
+                <a:latin typeface="Helvetica Neue"/>
               </a:rPr>
               <a:t>Les deux mêmes rapports Jacoco XML, importés tels quels dans SonarQube.</a:t>
             </a:r>
@@ -14557,7 +14602,7 @@
                 <a:solidFill>
                   <a:srgbClr val="C79A52"/>
                 </a:solidFill>
-                <a:latin typeface="Calibri"/>
+                <a:latin typeface="Helvetica Neue"/>
               </a:rPr>
               <a:t>77,7 %</a:t>
             </a:r>
@@ -14597,9 +14642,9 @@
             <a:r>
               <a:rPr sz="1300" b="0" i="0">
                 <a:solidFill>
-                  <a:srgbClr val="8B93A1"/>
-                </a:solidFill>
-                <a:latin typeface="Calibri"/>
+                  <a:srgbClr val="9BA3B1"/>
+                </a:solidFill>
+                <a:latin typeface="Helvetica Neue"/>
               </a:rPr>
               <a:t>couverture globale</a:t>
             </a:r>
@@ -14731,7 +14776,7 @@
                 <a:solidFill>
                   <a:srgbClr val="C79A52"/>
                 </a:solidFill>
-                <a:latin typeface="Calibri"/>
+                <a:latin typeface="Helvetica Neue"/>
               </a:rPr>
               <a:t>82 %</a:t>
             </a:r>
@@ -14771,9 +14816,9 @@
             <a:r>
               <a:rPr sz="1300" b="0" i="0">
                 <a:solidFill>
-                  <a:srgbClr val="8B93A1"/>
-                </a:solidFill>
-                <a:latin typeface="Calibri"/>
+                  <a:srgbClr val="9BA3B1"/>
+                </a:solidFill>
+                <a:latin typeface="Helvetica Neue"/>
               </a:rPr>
               <a:t>lignes</a:t>
             </a:r>
@@ -14905,7 +14950,7 @@
                 <a:solidFill>
                   <a:srgbClr val="C79A52"/>
                 </a:solidFill>
-                <a:latin typeface="Calibri"/>
+                <a:latin typeface="Helvetica Neue"/>
               </a:rPr>
               <a:t>65 %</a:t>
             </a:r>
@@ -14945,9 +14990,9 @@
             <a:r>
               <a:rPr sz="1300" b="0" i="0">
                 <a:solidFill>
-                  <a:srgbClr val="8B93A1"/>
-                </a:solidFill>
-                <a:latin typeface="Calibri"/>
+                  <a:srgbClr val="9BA3B1"/>
+                </a:solidFill>
+                <a:latin typeface="Helvetica Neue"/>
               </a:rPr>
               <a:t>branches</a:t>
             </a:r>
@@ -14989,7 +15034,7 @@
                 <a:solidFill>
                   <a:srgbClr val="8B93A1"/>
                 </a:solidFill>
-                <a:latin typeface="Calibri"/>
+                <a:latin typeface="Helvetica Neue"/>
               </a:rPr>
               <a:t>Mesure réelle, obtenue en lançant l'analyse sur ce projet — pas une maquette.</a:t>
             </a:r>
@@ -15076,7 +15121,7 @@
                 <a:solidFill>
                   <a:srgbClr val="E3E8F0"/>
                 </a:solidFill>
-                <a:latin typeface="Consolas"/>
+                <a:latin typeface="Menlo"/>
               </a:rPr>
               <a:t>docker compose -f sonarqube/docker-compose.yml up -d</a:t>
             </a:r>
@@ -15095,7 +15140,7 @@
                 <a:solidFill>
                   <a:srgbClr val="E3E8F0"/>
                 </a:solidFill>
-                <a:latin typeface="Consolas"/>
+                <a:latin typeface="Menlo"/>
               </a:rPr>
               <a:t>./mvnw test sonar:sonar -Dsonar.token=&lt;ton_token&gt;</a:t>
             </a:r>
@@ -15137,7 +15182,7 @@
                 <a:solidFill>
                   <a:srgbClr val="8B93A1"/>
                 </a:solidFill>
-                <a:latin typeface="Calibri"/>
+                <a:latin typeface="Helvetica Neue"/>
               </a:rPr>
               <a:t>SonarQube Community en local — aucun compte SonarCloud, aucune dépendance réseau pendant le talk.</a:t>
             </a:r>
@@ -15177,9 +15222,9 @@
             <a:r>
               <a:rPr sz="1000" b="0" i="0">
                 <a:solidFill>
-                  <a:srgbClr val="6E7A8E"/>
-                </a:solidFill>
-                <a:latin typeface="Calibri"/>
+                  <a:srgbClr val="8B93A1"/>
+                </a:solidFill>
+                <a:latin typeface="Helvetica Neue"/>
               </a:rPr>
               <a:t>20 / 28</a:t>
             </a:r>
@@ -15219,9 +15264,9 @@
             <a:r>
               <a:rPr sz="800" b="0" i="0">
                 <a:solidFill>
-                  <a:srgbClr val="6E7A8E"/>
-                </a:solidFill>
-                <a:latin typeface="Calibri"/>
+                  <a:srgbClr val="8B93A1"/>
+                </a:solidFill>
+                <a:latin typeface="Helvetica Neue"/>
               </a:rPr>
               <a:t>COUVERTURE DE CODE — QUARKUS · JUNIT · CUCUMBER · JACOCO</a:t>
             </a:r>
@@ -15339,9 +15384,9 @@
             <a:r>
               <a:rPr sz="1300" b="1" i="0">
                 <a:solidFill>
-                  <a:srgbClr val="C79A52"/>
-                </a:solidFill>
-                <a:latin typeface="Calibri"/>
+                  <a:srgbClr val="8A6530"/>
+                </a:solidFill>
+                <a:latin typeface="Helvetica Neue"/>
               </a:rPr>
               <a:t>SONARQUBE — DASHBOARD</a:t>
             </a:r>
@@ -15383,7 +15428,7 @@
                 <a:solidFill>
                   <a:srgbClr val="162844"/>
                 </a:solidFill>
-                <a:latin typeface="Calibri"/>
+                <a:latin typeface="Helvetica Neue"/>
               </a:rPr>
               <a:t>Coverage 77,7 %, en vrai, dans l'interface</a:t>
             </a:r>
@@ -15492,9 +15537,9 @@
             <a:r>
               <a:rPr sz="1000" b="0" i="0">
                 <a:solidFill>
-                  <a:srgbClr val="8B93A1"/>
-                </a:solidFill>
-                <a:latin typeface="Calibri"/>
+                  <a:srgbClr val="5E6674"/>
+                </a:solidFill>
+                <a:latin typeface="Helvetica Neue"/>
               </a:rPr>
               <a:t>21 / 28</a:t>
             </a:r>
@@ -15534,9 +15579,9 @@
             <a:r>
               <a:rPr sz="800" b="0" i="0">
                 <a:solidFill>
-                  <a:srgbClr val="8B93A1"/>
-                </a:solidFill>
-                <a:latin typeface="Calibri"/>
+                  <a:srgbClr val="5E6674"/>
+                </a:solidFill>
+                <a:latin typeface="Helvetica Neue"/>
               </a:rPr>
               <a:t>COUVERTURE DE CODE — QUARKUS · JUNIT · CUCUMBER · JACOCO</a:t>
             </a:r>
@@ -15654,9 +15699,9 @@
             <a:r>
               <a:rPr sz="1300" b="1" i="0">
                 <a:solidFill>
-                  <a:srgbClr val="C79A52"/>
-                </a:solidFill>
-                <a:latin typeface="Calibri"/>
+                  <a:srgbClr val="8A6530"/>
+                </a:solidFill>
+                <a:latin typeface="Helvetica Neue"/>
               </a:rPr>
               <a:t>SONARQUBE — MESURES</a:t>
             </a:r>
@@ -15698,7 +15743,7 @@
                 <a:solidFill>
                   <a:srgbClr val="162844"/>
                 </a:solidFill>
-                <a:latin typeface="Calibri"/>
+                <a:latin typeface="Helvetica Neue"/>
               </a:rPr>
               <a:t>Le détail, fichier par fichier</a:t>
             </a:r>
@@ -15807,9 +15852,9 @@
             <a:r>
               <a:rPr sz="1000" b="0" i="0">
                 <a:solidFill>
-                  <a:srgbClr val="8B93A1"/>
-                </a:solidFill>
-                <a:latin typeface="Calibri"/>
+                  <a:srgbClr val="5E6674"/>
+                </a:solidFill>
+                <a:latin typeface="Helvetica Neue"/>
               </a:rPr>
               <a:t>22 / 28</a:t>
             </a:r>
@@ -15849,9 +15894,9 @@
             <a:r>
               <a:rPr sz="800" b="0" i="0">
                 <a:solidFill>
-                  <a:srgbClr val="8B93A1"/>
-                </a:solidFill>
-                <a:latin typeface="Calibri"/>
+                  <a:srgbClr val="5E6674"/>
+                </a:solidFill>
+                <a:latin typeface="Helvetica Neue"/>
               </a:rPr>
               <a:t>COUVERTURE DE CODE — QUARKUS · JUNIT · CUCUMBER · JACOCO</a:t>
             </a:r>
@@ -15969,9 +16014,9 @@
             <a:r>
               <a:rPr sz="1300" b="1" i="0">
                 <a:solidFill>
-                  <a:srgbClr val="C79A52"/>
-                </a:solidFill>
-                <a:latin typeface="Calibri"/>
+                  <a:srgbClr val="8A6530"/>
+                </a:solidFill>
+                <a:latin typeface="Helvetica Neue"/>
               </a:rPr>
               <a:t>SONARQUBE — LA PREUVE, ENCORE</a:t>
             </a:r>
@@ -16013,7 +16058,7 @@
                 <a:solidFill>
                   <a:srgbClr val="162844"/>
                 </a:solidFill>
-                <a:latin typeface="Calibri"/>
+                <a:latin typeface="Helvetica Neue"/>
               </a:rPr>
               <a:t>Même branche rouge, autre outil</a:t>
             </a:r>
@@ -16122,9 +16167,9 @@
             <a:r>
               <a:rPr sz="1000" b="0" i="0">
                 <a:solidFill>
-                  <a:srgbClr val="8B93A1"/>
-                </a:solidFill>
-                <a:latin typeface="Calibri"/>
+                  <a:srgbClr val="5E6674"/>
+                </a:solidFill>
+                <a:latin typeface="Helvetica Neue"/>
               </a:rPr>
               <a:t>23 / 28</a:t>
             </a:r>
@@ -16164,9 +16209,9 @@
             <a:r>
               <a:rPr sz="800" b="0" i="0">
                 <a:solidFill>
-                  <a:srgbClr val="8B93A1"/>
-                </a:solidFill>
-                <a:latin typeface="Calibri"/>
+                  <a:srgbClr val="5E6674"/>
+                </a:solidFill>
+                <a:latin typeface="Helvetica Neue"/>
               </a:rPr>
               <a:t>COUVERTURE DE CODE — QUARKUS · JUNIT · CUCUMBER · JACOCO</a:t>
             </a:r>
@@ -16284,9 +16329,9 @@
             <a:r>
               <a:rPr sz="1300" b="1" i="0">
                 <a:solidFill>
-                  <a:srgbClr val="BF6F5D"/>
-                </a:solidFill>
-                <a:latin typeface="Calibri"/>
+                  <a:srgbClr val="8F4536"/>
+                </a:solidFill>
+                <a:latin typeface="Helvetica Neue"/>
               </a:rPr>
               <a:t>PETIT INTERLUDE</a:t>
             </a:r>
@@ -16328,7 +16373,7 @@
                 <a:solidFill>
                   <a:srgbClr val="162844"/>
                 </a:solidFill>
-                <a:latin typeface="Calibri"/>
+                <a:latin typeface="Helvetica Neue"/>
               </a:rPr>
               <a:t>Le best-of des excuses pour ne pas tester</a:t>
             </a:r>
@@ -16368,9 +16413,9 @@
             <a:r>
               <a:rPr sz="1800" b="1" i="0">
                 <a:solidFill>
-                  <a:srgbClr val="BF6F5D"/>
-                </a:solidFill>
-                <a:latin typeface="Calibri"/>
+                  <a:srgbClr val="8F4536"/>
+                </a:solidFill>
+                <a:latin typeface="Helvetica Neue"/>
               </a:rPr>
               <a:t>01</a:t>
             </a:r>
@@ -16412,7 +16457,7 @@
                 <a:solidFill>
                   <a:srgbClr val="162844"/>
                 </a:solidFill>
-                <a:latin typeface="Calibri"/>
+                <a:latin typeface="Helvetica Neue"/>
               </a:rPr>
               <a:t>« Ça marche sur ma machine. »</a:t>
             </a:r>
@@ -16452,9 +16497,9 @@
             <a:r>
               <a:rPr sz="1800" b="1" i="0">
                 <a:solidFill>
-                  <a:srgbClr val="BF6F5D"/>
-                </a:solidFill>
-                <a:latin typeface="Calibri"/>
+                  <a:srgbClr val="8F4536"/>
+                </a:solidFill>
+                <a:latin typeface="Helvetica Neue"/>
               </a:rPr>
               <a:t>02</a:t>
             </a:r>
@@ -16496,7 +16541,7 @@
                 <a:solidFill>
                   <a:srgbClr val="162844"/>
                 </a:solidFill>
-                <a:latin typeface="Calibri"/>
+                <a:latin typeface="Helvetica Neue"/>
               </a:rPr>
               <a:t>« On testera après le sprint. » (le sprint suivant aussi)</a:t>
             </a:r>
@@ -16536,9 +16581,9 @@
             <a:r>
               <a:rPr sz="1800" b="1" i="0">
                 <a:solidFill>
-                  <a:srgbClr val="BF6F5D"/>
-                </a:solidFill>
-                <a:latin typeface="Calibri"/>
+                  <a:srgbClr val="8F4536"/>
+                </a:solidFill>
+                <a:latin typeface="Helvetica Neue"/>
               </a:rPr>
               <a:t>03</a:t>
             </a:r>
@@ -16580,7 +16625,7 @@
                 <a:solidFill>
                   <a:srgbClr val="162844"/>
                 </a:solidFill>
-                <a:latin typeface="Calibri"/>
+                <a:latin typeface="Helvetica Neue"/>
               </a:rPr>
               <a:t>« C'est trop simple pour bugger. »</a:t>
             </a:r>
@@ -16620,9 +16665,9 @@
             <a:r>
               <a:rPr sz="1800" b="1" i="0">
                 <a:solidFill>
-                  <a:srgbClr val="BF6F5D"/>
-                </a:solidFill>
-                <a:latin typeface="Calibri"/>
+                  <a:srgbClr val="8F4536"/>
+                </a:solidFill>
+                <a:latin typeface="Helvetica Neue"/>
               </a:rPr>
               <a:t>04</a:t>
             </a:r>
@@ -16638,7 +16683,7 @@
         <p:spPr>
           <a:xfrm>
             <a:off x="1463040" y="3931920"/>
-            <a:ext cx="9144000" cy="457200"/>
+            <a:ext cx="9144000" cy="261610"/>
           </a:xfrm>
           <a:prstGeom prst="rect">
             <a:avLst/>
@@ -16660,13 +16705,31 @@
               </a:spcAft>
             </a:pPr>
             <a:r>
-              <a:rPr sz="1700" b="0" i="0">
+              <a:rPr sz="1700" b="0" i="0" dirty="0">
                 <a:solidFill>
                   <a:srgbClr val="162844"/>
                 </a:solidFill>
-                <a:latin typeface="Calibri"/>
-              </a:rPr>
-              <a:t>« Le stagiaire a dit que ça passait. »</a:t>
+                <a:latin typeface="Helvetica Neue"/>
+              </a:rPr>
+              <a:t>« </a:t>
+            </a:r>
+            <a:r>
+              <a:rPr lang="fr-FR" sz="1700" b="0" i="0" dirty="0">
+                <a:solidFill>
+                  <a:srgbClr val="162844"/>
+                </a:solidFill>
+                <a:latin typeface="Helvetica Neue"/>
+              </a:rPr>
+              <a:t>Le test passe normalement</a:t>
+            </a:r>
+            <a:r>
+              <a:rPr sz="1700" b="0" i="0" dirty="0">
+                <a:solidFill>
+                  <a:srgbClr val="162844"/>
+                </a:solidFill>
+                <a:latin typeface="Helvetica Neue"/>
+              </a:rPr>
+              <a:t> »</a:t>
             </a:r>
           </a:p>
         </p:txBody>
@@ -16704,9 +16767,9 @@
             <a:r>
               <a:rPr sz="1800" b="1" i="0">
                 <a:solidFill>
-                  <a:srgbClr val="BF6F5D"/>
-                </a:solidFill>
-                <a:latin typeface="Calibri"/>
+                  <a:srgbClr val="8F4536"/>
+                </a:solidFill>
+                <a:latin typeface="Helvetica Neue"/>
               </a:rPr>
               <a:t>05</a:t>
             </a:r>
@@ -16748,7 +16811,7 @@
                 <a:solidFill>
                   <a:srgbClr val="162844"/>
                 </a:solidFill>
-                <a:latin typeface="Calibri"/>
+                <a:latin typeface="Helvetica Neue"/>
               </a:rPr>
               <a:t>« 100 % de couverture, on n'a plus besoin de relire. »</a:t>
             </a:r>
@@ -16788,9 +16851,9 @@
             <a:r>
               <a:rPr sz="1450" b="1" i="1">
                 <a:solidFill>
-                  <a:srgbClr val="BF6F5D"/>
-                </a:solidFill>
-                <a:latin typeface="Calibri"/>
+                  <a:srgbClr val="8F4536"/>
+                </a:solidFill>
+                <a:latin typeface="Helvetica Neue"/>
               </a:rPr>
               <a:t>Spoiler : aucune de ces phrases n'a jamais empêché un incendie en prod.</a:t>
             </a:r>
@@ -16830,9 +16893,9 @@
             <a:r>
               <a:rPr sz="1000" b="0" i="0">
                 <a:solidFill>
-                  <a:srgbClr val="8B93A1"/>
-                </a:solidFill>
-                <a:latin typeface="Calibri"/>
+                  <a:srgbClr val="5E6674"/>
+                </a:solidFill>
+                <a:latin typeface="Helvetica Neue"/>
               </a:rPr>
               <a:t>24 / 28</a:t>
             </a:r>
@@ -16872,9 +16935,9 @@
             <a:r>
               <a:rPr sz="800" b="0" i="0">
                 <a:solidFill>
-                  <a:srgbClr val="8B93A1"/>
-                </a:solidFill>
-                <a:latin typeface="Calibri"/>
+                  <a:srgbClr val="5E6674"/>
+                </a:solidFill>
+                <a:latin typeface="Helvetica Neue"/>
               </a:rPr>
               <a:t>COUVERTURE DE CODE — QUARKUS · JUNIT · CUCUMBER · JACOCO</a:t>
             </a:r>
@@ -16949,7 +17012,7 @@
                 <a:solidFill>
                   <a:srgbClr val="C79A52"/>
                 </a:solidFill>
-                <a:latin typeface="Calibri"/>
+                <a:latin typeface="Helvetica Neue"/>
               </a:rPr>
               <a:t>RETOUR D'EXPÉRIENCE</a:t>
             </a:r>
@@ -16991,7 +17054,7 @@
                 <a:solidFill>
                   <a:srgbClr val="EFECE3"/>
                 </a:solidFill>
-                <a:latin typeface="Calibri"/>
+                <a:latin typeface="Helvetica Neue"/>
               </a:rPr>
               <a:t>Deux pièges qu'on a vraiment eus en préparant cette conf</a:t>
             </a:r>
@@ -17123,7 +17186,7 @@
                 <a:solidFill>
                   <a:srgbClr val="EFECE3"/>
                 </a:solidFill>
-                <a:latin typeface="Calibri"/>
+                <a:latin typeface="Helvetica Neue"/>
               </a:rPr>
               <a:t>Le QuarkusClassLoader fantôme</a:t>
             </a:r>
@@ -17163,9 +17226,9 @@
             <a:r>
               <a:rPr sz="1300" b="0" i="0">
                 <a:solidFill>
-                  <a:srgbClr val="8B93A1"/>
-                </a:solidFill>
-                <a:latin typeface="Calibri"/>
+                  <a:srgbClr val="9BA3B1"/>
+                </a:solidFill>
+                <a:latin typeface="Helvetica Neue"/>
               </a:rPr>
               <a:t>Deux exécutions Surefire, deux agents Jacoco... et pourtant tout à 0 %. Coupable : l'extension quarkus-jacoco mesure le code CDI toute seule, dans son coin, sans prévenir personne.</a:t>
             </a:r>
@@ -17297,7 +17360,7 @@
                 <a:solidFill>
                   <a:srgbClr val="EFECE3"/>
                 </a:solidFill>
-                <a:latin typeface="Calibri"/>
+                <a:latin typeface="Helvetica Neue"/>
               </a:rPr>
               <a:t>L'accent qui a cassé Gherkin</a:t>
             </a:r>
@@ -17337,9 +17400,9 @@
             <a:r>
               <a:rPr sz="1300" b="0" i="0">
                 <a:solidFill>
-                  <a:srgbClr val="8B93A1"/>
-                </a:solidFill>
-                <a:latin typeface="Calibri"/>
+                  <a:srgbClr val="9BA3B1"/>
+                </a:solidFill>
+                <a:latin typeface="Helvetica Neue"/>
               </a:rPr>
               <a:t>« Fonctionnalite » sans accent ne veut RIEN dire pour un parseur Gherkin en français. Une lettre manquante, un stacktrace de 100 lignes.</a:t>
             </a:r>
@@ -17381,7 +17444,7 @@
                 <a:solidFill>
                   <a:srgbClr val="C79A52"/>
                 </a:solidFill>
-                <a:latin typeface="Calibri"/>
+                <a:latin typeface="Helvetica Neue"/>
               </a:rPr>
               <a:t>Bref : même en préparant une conf sur les tests, on s'est fait avoir. C'est le principe.</a:t>
             </a:r>
@@ -17421,9 +17484,9 @@
             <a:r>
               <a:rPr sz="1000" b="0" i="0">
                 <a:solidFill>
-                  <a:srgbClr val="6E7A8E"/>
-                </a:solidFill>
-                <a:latin typeface="Calibri"/>
+                  <a:srgbClr val="8B93A1"/>
+                </a:solidFill>
+                <a:latin typeface="Helvetica Neue"/>
               </a:rPr>
               <a:t>25 / 28</a:t>
             </a:r>
@@ -17463,9 +17526,9 @@
             <a:r>
               <a:rPr sz="800" b="0" i="0">
                 <a:solidFill>
-                  <a:srgbClr val="6E7A8E"/>
-                </a:solidFill>
-                <a:latin typeface="Calibri"/>
+                  <a:srgbClr val="8B93A1"/>
+                </a:solidFill>
+                <a:latin typeface="Helvetica Neue"/>
               </a:rPr>
               <a:t>COUVERTURE DE CODE — QUARKUS · JUNIT · CUCUMBER · JACOCO</a:t>
             </a:r>
@@ -17540,7 +17603,7 @@
                 <a:solidFill>
                   <a:srgbClr val="C79A52"/>
                 </a:solidFill>
-                <a:latin typeface="Calibri"/>
+                <a:latin typeface="Helvetica Neue"/>
               </a:rPr>
               <a:t>À RETENIR</a:t>
             </a:r>
@@ -17582,7 +17645,7 @@
                 <a:solidFill>
                   <a:srgbClr val="EFECE3"/>
                 </a:solidFill>
-                <a:latin typeface="Calibri"/>
+                <a:latin typeface="Helvetica Neue"/>
               </a:rPr>
               <a:t>Ce qu'il faut retenir</a:t>
             </a:r>
@@ -17624,7 +17687,7 @@
                 <a:solidFill>
                   <a:srgbClr val="C79A52"/>
                 </a:solidFill>
-                <a:latin typeface="Calibri"/>
+                <a:latin typeface="Helvetica Neue"/>
               </a:rPr>
               <a:t>01</a:t>
             </a:r>
@@ -17666,7 +17729,7 @@
                 <a:solidFill>
                   <a:srgbClr val="EFECE3"/>
                 </a:solidFill>
-                <a:latin typeface="Calibri"/>
+                <a:latin typeface="Helvetica Neue"/>
               </a:rPr>
               <a:t>Un test vert ne dit pas ce qu'il a vérifié.</a:t>
             </a:r>
@@ -17708,7 +17771,7 @@
                 <a:solidFill>
                   <a:srgbClr val="8B93A1"/>
                 </a:solidFill>
-                <a:latin typeface="Calibri"/>
+                <a:latin typeface="Helvetica Neue"/>
               </a:rPr>
               <a:t>La couverture, si.</a:t>
             </a:r>
@@ -17750,7 +17813,7 @@
                 <a:solidFill>
                   <a:srgbClr val="C79A52"/>
                 </a:solidFill>
-                <a:latin typeface="Calibri"/>
+                <a:latin typeface="Helvetica Neue"/>
               </a:rPr>
               <a:t>02</a:t>
             </a:r>
@@ -17792,7 +17855,7 @@
                 <a:solidFill>
                   <a:srgbClr val="EFECE3"/>
                 </a:solidFill>
-                <a:latin typeface="Calibri"/>
+                <a:latin typeface="Helvetica Neue"/>
               </a:rPr>
               <a:t>JUnit et Cucumber répondent à deux questions différentes.</a:t>
             </a:r>
@@ -17834,7 +17897,7 @@
                 <a:solidFill>
                   <a:srgbClr val="8B93A1"/>
                 </a:solidFill>
-                <a:latin typeface="Calibri"/>
+                <a:latin typeface="Helvetica Neue"/>
               </a:rPr>
               <a:t>« Ça marche ? » contre « c'est le bon comportement ? »</a:t>
             </a:r>
@@ -17876,7 +17939,7 @@
                 <a:solidFill>
                   <a:srgbClr val="C79A52"/>
                 </a:solidFill>
-                <a:latin typeface="Calibri"/>
+                <a:latin typeface="Helvetica Neue"/>
               </a:rPr>
               <a:t>03</a:t>
             </a:r>
@@ -17918,7 +17981,7 @@
                 <a:solidFill>
                   <a:srgbClr val="EFECE3"/>
                 </a:solidFill>
-                <a:latin typeface="Calibri"/>
+                <a:latin typeface="Helvetica Neue"/>
               </a:rPr>
               <a:t>Le rapport de couverture n'est pas un objectif.</a:t>
             </a:r>
@@ -17960,7 +18023,7 @@
                 <a:solidFill>
                   <a:srgbClr val="8B93A1"/>
                 </a:solidFill>
-                <a:latin typeface="Calibri"/>
+                <a:latin typeface="Helvetica Neue"/>
               </a:rPr>
               <a:t>C'est un radar : il montre où regarder en premier.</a:t>
             </a:r>
@@ -18002,7 +18065,7 @@
                 <a:solidFill>
                   <a:srgbClr val="C79A52"/>
                 </a:solidFill>
-                <a:latin typeface="Calibri"/>
+                <a:latin typeface="Helvetica Neue"/>
               </a:rPr>
               <a:t>04</a:t>
             </a:r>
@@ -18044,7 +18107,7 @@
                 <a:solidFill>
                   <a:srgbClr val="EFECE3"/>
                 </a:solidFill>
-                <a:latin typeface="Calibri"/>
+                <a:latin typeface="Helvetica Neue"/>
               </a:rPr>
               <a:t>Un outil ne remplace pas la question qu'on ne s'est pas posée.</a:t>
             </a:r>
@@ -18086,7 +18149,7 @@
                 <a:solidFill>
                   <a:srgbClr val="8B93A1"/>
                 </a:solidFill>
-                <a:latin typeface="Calibri"/>
+                <a:latin typeface="Helvetica Neue"/>
               </a:rPr>
               <a:t>Ni Jacoco, ni Sonar, ni celui d'après.</a:t>
             </a:r>
@@ -18126,9 +18189,9 @@
             <a:r>
               <a:rPr sz="1000" b="0" i="0">
                 <a:solidFill>
-                  <a:srgbClr val="6E7A8E"/>
-                </a:solidFill>
-                <a:latin typeface="Calibri"/>
+                  <a:srgbClr val="8B93A1"/>
+                </a:solidFill>
+                <a:latin typeface="Helvetica Neue"/>
               </a:rPr>
               <a:t>26 / 28</a:t>
             </a:r>
@@ -18168,9 +18231,9 @@
             <a:r>
               <a:rPr sz="800" b="0" i="0">
                 <a:solidFill>
-                  <a:srgbClr val="6E7A8E"/>
-                </a:solidFill>
-                <a:latin typeface="Calibri"/>
+                  <a:srgbClr val="8B93A1"/>
+                </a:solidFill>
+                <a:latin typeface="Helvetica Neue"/>
               </a:rPr>
               <a:t>COUVERTURE DE CODE — QUARKUS · JUNIT · CUCUMBER · JACOCO</a:t>
             </a:r>
@@ -18288,9 +18351,9 @@
             <a:r>
               <a:rPr sz="1300" b="1" i="0">
                 <a:solidFill>
-                  <a:srgbClr val="C79A52"/>
-                </a:solidFill>
-                <a:latin typeface="Calibri"/>
+                  <a:srgbClr val="8A6530"/>
+                </a:solidFill>
+                <a:latin typeface="Helvetica Neue"/>
               </a:rPr>
               <a:t>POUR LA SUITE</a:t>
             </a:r>
@@ -18332,7 +18395,7 @@
                 <a:solidFill>
                   <a:srgbClr val="162844"/>
                 </a:solidFill>
-                <a:latin typeface="Calibri"/>
+                <a:latin typeface="Helvetica Neue"/>
               </a:rPr>
               <a:t>Si vous voulez creuser</a:t>
             </a:r>
@@ -18419,7 +18482,7 @@
                 <a:solidFill>
                   <a:srgbClr val="162844"/>
                 </a:solidFill>
-                <a:latin typeface="Calibri"/>
+                <a:latin typeface="Helvetica Neue"/>
               </a:rPr>
               <a:t>Le dépôt de ce projet</a:t>
             </a:r>
@@ -18461,7 +18524,7 @@
                 <a:solidFill>
                   <a:srgbClr val="333A47"/>
                 </a:solidFill>
-                <a:latin typeface="Consolas"/>
+                <a:latin typeface="Menlo"/>
               </a:rPr>
               <a:t>github.com/sidevconcept/couverture-junit-cucumber-jacoco</a:t>
             </a:r>
@@ -18548,7 +18611,7 @@
                 <a:solidFill>
                   <a:srgbClr val="162844"/>
                 </a:solidFill>
-                <a:latin typeface="Calibri"/>
+                <a:latin typeface="Helvetica Neue"/>
               </a:rPr>
               <a:t>Guide Quarkus + Jacoco</a:t>
             </a:r>
@@ -18590,7 +18653,7 @@
                 <a:solidFill>
                   <a:srgbClr val="333A47"/>
                 </a:solidFill>
-                <a:latin typeface="Consolas"/>
+                <a:latin typeface="Menlo"/>
               </a:rPr>
               <a:t>quarkus.io/guides/tests-with-coverage</a:t>
             </a:r>
@@ -18677,7 +18740,7 @@
                 <a:solidFill>
                   <a:srgbClr val="162844"/>
                 </a:solidFill>
-                <a:latin typeface="Calibri"/>
+                <a:latin typeface="Helvetica Neue"/>
               </a:rPr>
               <a:t>Extension Cucumber pour Quarkus</a:t>
             </a:r>
@@ -18719,7 +18782,7 @@
                 <a:solidFill>
                   <a:srgbClr val="333A47"/>
                 </a:solidFill>
-                <a:latin typeface="Consolas"/>
+                <a:latin typeface="Menlo"/>
               </a:rPr>
               <a:t>docs.quarkiverse.io/quarkus-cucumber</a:t>
             </a:r>
@@ -18806,7 +18869,7 @@
                 <a:solidFill>
                   <a:srgbClr val="162844"/>
                 </a:solidFill>
-                <a:latin typeface="Calibri"/>
+                <a:latin typeface="Helvetica Neue"/>
               </a:rPr>
               <a:t>SonarQube Community</a:t>
             </a:r>
@@ -18848,7 +18911,7 @@
                 <a:solidFill>
                   <a:srgbClr val="333A47"/>
                 </a:solidFill>
-                <a:latin typeface="Consolas"/>
+                <a:latin typeface="Menlo"/>
               </a:rPr>
               <a:t>docs.sonarsource.com</a:t>
             </a:r>
@@ -18888,9 +18951,9 @@
             <a:r>
               <a:rPr sz="1000" b="0" i="0">
                 <a:solidFill>
-                  <a:srgbClr val="8B93A1"/>
-                </a:solidFill>
-                <a:latin typeface="Calibri"/>
+                  <a:srgbClr val="5E6674"/>
+                </a:solidFill>
+                <a:latin typeface="Helvetica Neue"/>
               </a:rPr>
               <a:t>27 / 28</a:t>
             </a:r>
@@ -18930,9 +18993,9 @@
             <a:r>
               <a:rPr sz="800" b="0" i="0">
                 <a:solidFill>
-                  <a:srgbClr val="8B93A1"/>
-                </a:solidFill>
-                <a:latin typeface="Calibri"/>
+                  <a:srgbClr val="5E6674"/>
+                </a:solidFill>
+                <a:latin typeface="Helvetica Neue"/>
               </a:rPr>
               <a:t>COUVERTURE DE CODE — QUARKUS · JUNIT · CUCUMBER · JACOCO</a:t>
             </a:r>
@@ -19784,553 +19847,13 @@
       </p:sp>
       <p:sp>
         <p:nvSpPr>
-          <p:cNvPr id="20" name="Oval 19"/>
-          <p:cNvSpPr/>
-          <p:nvPr/>
-        </p:nvSpPr>
-        <p:spPr>
-          <a:xfrm>
-            <a:off x="640080" y="5724144"/>
-            <a:ext cx="82296" cy="82296"/>
-          </a:xfrm>
-          <a:prstGeom prst="ellipse">
-            <a:avLst/>
-          </a:prstGeom>
-          <a:solidFill>
-            <a:srgbClr val="C79A52"/>
-          </a:solidFill>
-          <a:ln>
-            <a:noFill/>
-          </a:ln>
-          <a:effectLst/>
-        </p:spPr>
-        <p:style>
-          <a:lnRef idx="1">
-            <a:schemeClr val="accent1"/>
-          </a:lnRef>
-          <a:fillRef idx="3">
-            <a:schemeClr val="accent1"/>
-          </a:fillRef>
-          <a:effectRef idx="2">
-            <a:schemeClr val="accent1"/>
-          </a:effectRef>
-          <a:fontRef idx="minor">
-            <a:schemeClr val="lt1"/>
-          </a:fontRef>
-        </p:style>
-        <p:txBody>
-          <a:bodyPr rtlCol="0" anchor="ctr"/>
-          <a:lstStyle/>
-          <a:p>
-            <a:pPr algn="ctr"/>
-            <a:endParaRPr/>
-          </a:p>
-        </p:txBody>
-      </p:sp>
-      <p:sp>
-        <p:nvSpPr>
-          <p:cNvPr id="21" name="Oval 20"/>
-          <p:cNvSpPr/>
-          <p:nvPr/>
-        </p:nvSpPr>
-        <p:spPr>
-          <a:xfrm>
-            <a:off x="932688" y="5724144"/>
-            <a:ext cx="82296" cy="82296"/>
-          </a:xfrm>
-          <a:prstGeom prst="ellipse">
-            <a:avLst/>
-          </a:prstGeom>
-          <a:solidFill>
-            <a:srgbClr val="C79A52"/>
-          </a:solidFill>
-          <a:ln>
-            <a:noFill/>
-          </a:ln>
-          <a:effectLst/>
-        </p:spPr>
-        <p:style>
-          <a:lnRef idx="1">
-            <a:schemeClr val="accent1"/>
-          </a:lnRef>
-          <a:fillRef idx="3">
-            <a:schemeClr val="accent1"/>
-          </a:fillRef>
-          <a:effectRef idx="2">
-            <a:schemeClr val="accent1"/>
-          </a:effectRef>
-          <a:fontRef idx="minor">
-            <a:schemeClr val="lt1"/>
-          </a:fontRef>
-        </p:style>
-        <p:txBody>
-          <a:bodyPr rtlCol="0" anchor="ctr"/>
-          <a:lstStyle/>
-          <a:p>
-            <a:pPr algn="ctr"/>
-            <a:endParaRPr/>
-          </a:p>
-        </p:txBody>
-      </p:sp>
-      <p:sp>
-        <p:nvSpPr>
-          <p:cNvPr id="22" name="Oval 21"/>
-          <p:cNvSpPr/>
-          <p:nvPr/>
-        </p:nvSpPr>
-        <p:spPr>
-          <a:xfrm>
-            <a:off x="1225296" y="5724144"/>
-            <a:ext cx="82296" cy="82296"/>
-          </a:xfrm>
-          <a:prstGeom prst="ellipse">
-            <a:avLst/>
-          </a:prstGeom>
-          <a:solidFill>
-            <a:srgbClr val="C79A52"/>
-          </a:solidFill>
-          <a:ln>
-            <a:noFill/>
-          </a:ln>
-          <a:effectLst/>
-        </p:spPr>
-        <p:style>
-          <a:lnRef idx="1">
-            <a:schemeClr val="accent1"/>
-          </a:lnRef>
-          <a:fillRef idx="3">
-            <a:schemeClr val="accent1"/>
-          </a:fillRef>
-          <a:effectRef idx="2">
-            <a:schemeClr val="accent1"/>
-          </a:effectRef>
-          <a:fontRef idx="minor">
-            <a:schemeClr val="lt1"/>
-          </a:fontRef>
-        </p:style>
-        <p:txBody>
-          <a:bodyPr rtlCol="0" anchor="ctr"/>
-          <a:lstStyle/>
-          <a:p>
-            <a:pPr algn="ctr"/>
-            <a:endParaRPr/>
-          </a:p>
-        </p:txBody>
-      </p:sp>
-      <p:sp>
-        <p:nvSpPr>
-          <p:cNvPr id="23" name="Oval 22"/>
-          <p:cNvSpPr/>
-          <p:nvPr/>
-        </p:nvSpPr>
-        <p:spPr>
-          <a:xfrm>
-            <a:off x="1517904" y="5724144"/>
-            <a:ext cx="82296" cy="82296"/>
-          </a:xfrm>
-          <a:prstGeom prst="ellipse">
-            <a:avLst/>
-          </a:prstGeom>
-          <a:solidFill>
-            <a:srgbClr val="C79A52"/>
-          </a:solidFill>
-          <a:ln>
-            <a:noFill/>
-          </a:ln>
-          <a:effectLst/>
-        </p:spPr>
-        <p:style>
-          <a:lnRef idx="1">
-            <a:schemeClr val="accent1"/>
-          </a:lnRef>
-          <a:fillRef idx="3">
-            <a:schemeClr val="accent1"/>
-          </a:fillRef>
-          <a:effectRef idx="2">
-            <a:schemeClr val="accent1"/>
-          </a:effectRef>
-          <a:fontRef idx="minor">
-            <a:schemeClr val="lt1"/>
-          </a:fontRef>
-        </p:style>
-        <p:txBody>
-          <a:bodyPr rtlCol="0" anchor="ctr"/>
-          <a:lstStyle/>
-          <a:p>
-            <a:pPr algn="ctr"/>
-            <a:endParaRPr/>
-          </a:p>
-        </p:txBody>
-      </p:sp>
-      <p:sp>
-        <p:nvSpPr>
-          <p:cNvPr id="24" name="Oval 23"/>
-          <p:cNvSpPr/>
-          <p:nvPr/>
-        </p:nvSpPr>
-        <p:spPr>
-          <a:xfrm>
-            <a:off x="1810512" y="5724144"/>
-            <a:ext cx="82296" cy="82296"/>
-          </a:xfrm>
-          <a:prstGeom prst="ellipse">
-            <a:avLst/>
-          </a:prstGeom>
-          <a:solidFill>
-            <a:srgbClr val="C79A52"/>
-          </a:solidFill>
-          <a:ln>
-            <a:noFill/>
-          </a:ln>
-          <a:effectLst/>
-        </p:spPr>
-        <p:style>
-          <a:lnRef idx="1">
-            <a:schemeClr val="accent1"/>
-          </a:lnRef>
-          <a:fillRef idx="3">
-            <a:schemeClr val="accent1"/>
-          </a:fillRef>
-          <a:effectRef idx="2">
-            <a:schemeClr val="accent1"/>
-          </a:effectRef>
-          <a:fontRef idx="minor">
-            <a:schemeClr val="lt1"/>
-          </a:fontRef>
-        </p:style>
-        <p:txBody>
-          <a:bodyPr rtlCol="0" anchor="ctr"/>
-          <a:lstStyle/>
-          <a:p>
-            <a:pPr algn="ctr"/>
-            <a:endParaRPr/>
-          </a:p>
-        </p:txBody>
-      </p:sp>
-      <p:sp>
-        <p:nvSpPr>
-          <p:cNvPr id="25" name="Oval 24"/>
-          <p:cNvSpPr/>
-          <p:nvPr/>
-        </p:nvSpPr>
-        <p:spPr>
-          <a:xfrm>
-            <a:off x="2103120" y="5724144"/>
-            <a:ext cx="82296" cy="82296"/>
-          </a:xfrm>
-          <a:prstGeom prst="ellipse">
-            <a:avLst/>
-          </a:prstGeom>
-          <a:solidFill>
-            <a:srgbClr val="C79A52"/>
-          </a:solidFill>
-          <a:ln>
-            <a:noFill/>
-          </a:ln>
-          <a:effectLst/>
-        </p:spPr>
-        <p:style>
-          <a:lnRef idx="1">
-            <a:schemeClr val="accent1"/>
-          </a:lnRef>
-          <a:fillRef idx="3">
-            <a:schemeClr val="accent1"/>
-          </a:fillRef>
-          <a:effectRef idx="2">
-            <a:schemeClr val="accent1"/>
-          </a:effectRef>
-          <a:fontRef idx="minor">
-            <a:schemeClr val="lt1"/>
-          </a:fontRef>
-        </p:style>
-        <p:txBody>
-          <a:bodyPr rtlCol="0" anchor="ctr"/>
-          <a:lstStyle/>
-          <a:p>
-            <a:pPr algn="ctr"/>
-            <a:endParaRPr/>
-          </a:p>
-        </p:txBody>
-      </p:sp>
-      <p:sp>
-        <p:nvSpPr>
-          <p:cNvPr id="26" name="Oval 25"/>
-          <p:cNvSpPr/>
-          <p:nvPr/>
-        </p:nvSpPr>
-        <p:spPr>
-          <a:xfrm>
-            <a:off x="640080" y="6016752"/>
-            <a:ext cx="82296" cy="82296"/>
-          </a:xfrm>
-          <a:prstGeom prst="ellipse">
-            <a:avLst/>
-          </a:prstGeom>
-          <a:solidFill>
-            <a:srgbClr val="C79A52"/>
-          </a:solidFill>
-          <a:ln>
-            <a:noFill/>
-          </a:ln>
-          <a:effectLst/>
-        </p:spPr>
-        <p:style>
-          <a:lnRef idx="1">
-            <a:schemeClr val="accent1"/>
-          </a:lnRef>
-          <a:fillRef idx="3">
-            <a:schemeClr val="accent1"/>
-          </a:fillRef>
-          <a:effectRef idx="2">
-            <a:schemeClr val="accent1"/>
-          </a:effectRef>
-          <a:fontRef idx="minor">
-            <a:schemeClr val="lt1"/>
-          </a:fontRef>
-        </p:style>
-        <p:txBody>
-          <a:bodyPr rtlCol="0" anchor="ctr"/>
-          <a:lstStyle/>
-          <a:p>
-            <a:pPr algn="ctr"/>
-            <a:endParaRPr/>
-          </a:p>
-        </p:txBody>
-      </p:sp>
-      <p:sp>
-        <p:nvSpPr>
-          <p:cNvPr id="27" name="Oval 26"/>
-          <p:cNvSpPr/>
-          <p:nvPr/>
-        </p:nvSpPr>
-        <p:spPr>
-          <a:xfrm>
-            <a:off x="932688" y="6016752"/>
-            <a:ext cx="82296" cy="82296"/>
-          </a:xfrm>
-          <a:prstGeom prst="ellipse">
-            <a:avLst/>
-          </a:prstGeom>
-          <a:solidFill>
-            <a:srgbClr val="C79A52"/>
-          </a:solidFill>
-          <a:ln>
-            <a:noFill/>
-          </a:ln>
-          <a:effectLst/>
-        </p:spPr>
-        <p:style>
-          <a:lnRef idx="1">
-            <a:schemeClr val="accent1"/>
-          </a:lnRef>
-          <a:fillRef idx="3">
-            <a:schemeClr val="accent1"/>
-          </a:fillRef>
-          <a:effectRef idx="2">
-            <a:schemeClr val="accent1"/>
-          </a:effectRef>
-          <a:fontRef idx="minor">
-            <a:schemeClr val="lt1"/>
-          </a:fontRef>
-        </p:style>
-        <p:txBody>
-          <a:bodyPr rtlCol="0" anchor="ctr"/>
-          <a:lstStyle/>
-          <a:p>
-            <a:pPr algn="ctr"/>
-            <a:endParaRPr/>
-          </a:p>
-        </p:txBody>
-      </p:sp>
-      <p:sp>
-        <p:nvSpPr>
-          <p:cNvPr id="28" name="Oval 27"/>
-          <p:cNvSpPr/>
-          <p:nvPr/>
-        </p:nvSpPr>
-        <p:spPr>
-          <a:xfrm>
-            <a:off x="1225296" y="6016752"/>
-            <a:ext cx="82296" cy="82296"/>
-          </a:xfrm>
-          <a:prstGeom prst="ellipse">
-            <a:avLst/>
-          </a:prstGeom>
-          <a:solidFill>
-            <a:srgbClr val="C79A52"/>
-          </a:solidFill>
-          <a:ln>
-            <a:noFill/>
-          </a:ln>
-          <a:effectLst/>
-        </p:spPr>
-        <p:style>
-          <a:lnRef idx="1">
-            <a:schemeClr val="accent1"/>
-          </a:lnRef>
-          <a:fillRef idx="3">
-            <a:schemeClr val="accent1"/>
-          </a:fillRef>
-          <a:effectRef idx="2">
-            <a:schemeClr val="accent1"/>
-          </a:effectRef>
-          <a:fontRef idx="minor">
-            <a:schemeClr val="lt1"/>
-          </a:fontRef>
-        </p:style>
-        <p:txBody>
-          <a:bodyPr rtlCol="0" anchor="ctr"/>
-          <a:lstStyle/>
-          <a:p>
-            <a:pPr algn="ctr"/>
-            <a:endParaRPr/>
-          </a:p>
-        </p:txBody>
-      </p:sp>
-      <p:sp>
-        <p:nvSpPr>
-          <p:cNvPr id="29" name="Oval 28"/>
-          <p:cNvSpPr/>
-          <p:nvPr/>
-        </p:nvSpPr>
-        <p:spPr>
-          <a:xfrm>
-            <a:off x="1517904" y="6016752"/>
-            <a:ext cx="82296" cy="82296"/>
-          </a:xfrm>
-          <a:prstGeom prst="ellipse">
-            <a:avLst/>
-          </a:prstGeom>
-          <a:solidFill>
-            <a:srgbClr val="C79A52"/>
-          </a:solidFill>
-          <a:ln>
-            <a:noFill/>
-          </a:ln>
-          <a:effectLst/>
-        </p:spPr>
-        <p:style>
-          <a:lnRef idx="1">
-            <a:schemeClr val="accent1"/>
-          </a:lnRef>
-          <a:fillRef idx="3">
-            <a:schemeClr val="accent1"/>
-          </a:fillRef>
-          <a:effectRef idx="2">
-            <a:schemeClr val="accent1"/>
-          </a:effectRef>
-          <a:fontRef idx="minor">
-            <a:schemeClr val="lt1"/>
-          </a:fontRef>
-        </p:style>
-        <p:txBody>
-          <a:bodyPr rtlCol="0" anchor="ctr"/>
-          <a:lstStyle/>
-          <a:p>
-            <a:pPr algn="ctr"/>
-            <a:endParaRPr/>
-          </a:p>
-        </p:txBody>
-      </p:sp>
-      <p:sp>
-        <p:nvSpPr>
-          <p:cNvPr id="30" name="Oval 29"/>
-          <p:cNvSpPr/>
-          <p:nvPr/>
-        </p:nvSpPr>
-        <p:spPr>
-          <a:xfrm>
-            <a:off x="1810512" y="6016752"/>
-            <a:ext cx="82296" cy="82296"/>
-          </a:xfrm>
-          <a:prstGeom prst="ellipse">
-            <a:avLst/>
-          </a:prstGeom>
-          <a:solidFill>
-            <a:srgbClr val="C79A52"/>
-          </a:solidFill>
-          <a:ln>
-            <a:noFill/>
-          </a:ln>
-          <a:effectLst/>
-        </p:spPr>
-        <p:style>
-          <a:lnRef idx="1">
-            <a:schemeClr val="accent1"/>
-          </a:lnRef>
-          <a:fillRef idx="3">
-            <a:schemeClr val="accent1"/>
-          </a:fillRef>
-          <a:effectRef idx="2">
-            <a:schemeClr val="accent1"/>
-          </a:effectRef>
-          <a:fontRef idx="minor">
-            <a:schemeClr val="lt1"/>
-          </a:fontRef>
-        </p:style>
-        <p:txBody>
-          <a:bodyPr rtlCol="0" anchor="ctr"/>
-          <a:lstStyle/>
-          <a:p>
-            <a:pPr algn="ctr"/>
-            <a:endParaRPr/>
-          </a:p>
-        </p:txBody>
-      </p:sp>
-      <p:sp>
-        <p:nvSpPr>
-          <p:cNvPr id="31" name="Oval 30"/>
-          <p:cNvSpPr/>
-          <p:nvPr/>
-        </p:nvSpPr>
-        <p:spPr>
-          <a:xfrm>
-            <a:off x="2103120" y="6016752"/>
-            <a:ext cx="82296" cy="82296"/>
-          </a:xfrm>
-          <a:prstGeom prst="ellipse">
-            <a:avLst/>
-          </a:prstGeom>
-          <a:solidFill>
-            <a:srgbClr val="C79A52"/>
-          </a:solidFill>
-          <a:ln>
-            <a:noFill/>
-          </a:ln>
-          <a:effectLst/>
-        </p:spPr>
-        <p:style>
-          <a:lnRef idx="1">
-            <a:schemeClr val="accent1"/>
-          </a:lnRef>
-          <a:fillRef idx="3">
-            <a:schemeClr val="accent1"/>
-          </a:fillRef>
-          <a:effectRef idx="2">
-            <a:schemeClr val="accent1"/>
-          </a:effectRef>
-          <a:fontRef idx="minor">
-            <a:schemeClr val="lt1"/>
-          </a:fontRef>
-        </p:style>
-        <p:txBody>
-          <a:bodyPr rtlCol="0" anchor="ctr"/>
-          <a:lstStyle/>
-          <a:p>
-            <a:pPr algn="ctr"/>
-            <a:endParaRPr/>
-          </a:p>
-        </p:txBody>
-      </p:sp>
-      <p:sp>
-        <p:nvSpPr>
-          <p:cNvPr id="32" name="TextBox 31"/>
-          <p:cNvSpPr txBox="1"/>
-          <p:nvPr/>
-        </p:nvSpPr>
-        <p:spPr>
-          <a:xfrm>
-            <a:off x="868680" y="882396"/>
+          <p:cNvPr id="20" name="TextBox 19"/>
+          <p:cNvSpPr txBox="1"/>
+          <p:nvPr/>
+        </p:nvSpPr>
+        <p:spPr>
+          <a:xfrm>
+            <a:off x="868680" y="809802"/>
             <a:ext cx="7589520" cy="1280160"/>
           </a:xfrm>
           <a:prstGeom prst="rect">
@@ -20357,7 +19880,7 @@
                 <a:solidFill>
                   <a:srgbClr val="EFECE3"/>
                 </a:solidFill>
-                <a:latin typeface="Calibri"/>
+                <a:latin typeface="Helvetica Neue"/>
               </a:rPr>
               <a:t>Merci.</a:t>
             </a:r>
@@ -20366,13 +19889,13 @@
       </p:sp>
       <p:sp>
         <p:nvSpPr>
-          <p:cNvPr id="33" name="TextBox 32"/>
-          <p:cNvSpPr txBox="1"/>
-          <p:nvPr/>
-        </p:nvSpPr>
-        <p:spPr>
-          <a:xfrm>
-            <a:off x="868680" y="1732788"/>
+          <p:cNvPr id="21" name="TextBox 20"/>
+          <p:cNvSpPr txBox="1"/>
+          <p:nvPr/>
+        </p:nvSpPr>
+        <p:spPr>
+          <a:xfrm>
+            <a:off x="868680" y="1925370"/>
             <a:ext cx="7589520" cy="640080"/>
           </a:xfrm>
           <a:prstGeom prst="rect">
@@ -20399,7 +19922,7 @@
                 <a:solidFill>
                   <a:srgbClr val="C79A52"/>
                 </a:solidFill>
-                <a:latin typeface="Calibri"/>
+                <a:latin typeface="Helvetica Neue"/>
               </a:rPr>
               <a:t>Questions ?</a:t>
             </a:r>
@@ -20408,14 +19931,14 @@
       </p:sp>
       <p:sp>
         <p:nvSpPr>
-          <p:cNvPr id="34" name="TextBox 33"/>
-          <p:cNvSpPr txBox="1"/>
-          <p:nvPr/>
-        </p:nvSpPr>
-        <p:spPr>
-          <a:xfrm>
-            <a:off x="1098395" y="2936557"/>
-            <a:ext cx="7359805" cy="984885"/>
+          <p:cNvPr id="22" name="TextBox 21"/>
+          <p:cNvSpPr txBox="1"/>
+          <p:nvPr/>
+        </p:nvSpPr>
+        <p:spPr>
+          <a:xfrm>
+            <a:off x="356839" y="2837205"/>
+            <a:ext cx="8090210" cy="1231106"/>
           </a:xfrm>
           <a:prstGeom prst="rect">
             <a:avLst/>
@@ -20437,82 +19960,98 @@
               </a:spcAft>
             </a:pPr>
             <a:r>
-              <a:rPr sz="2000" b="0" i="0" dirty="0">
+              <a:rPr lang="fr-FR" sz="2000" b="0" i="0" dirty="0">
                 <a:solidFill>
                   <a:srgbClr val="8B93A1"/>
                 </a:solidFill>
-                <a:latin typeface="Calibri"/>
+                <a:latin typeface="Helvetica Neue"/>
               </a:rPr>
               <a:t>https://</a:t>
             </a:r>
             <a:r>
-              <a:rPr sz="2000" b="0" i="0" dirty="0" err="1">
+              <a:rPr lang="fr-FR" sz="2000" b="0" i="0" dirty="0" err="1">
                 <a:solidFill>
                   <a:srgbClr val="8B93A1"/>
                 </a:solidFill>
-                <a:latin typeface="Calibri"/>
+                <a:latin typeface="Helvetica Neue"/>
               </a:rPr>
               <a:t>github.com</a:t>
             </a:r>
             <a:r>
-              <a:rPr sz="2000" b="0" i="0" dirty="0">
+              <a:rPr lang="fr-FR" sz="2000" b="0" i="0" dirty="0">
                 <a:solidFill>
                   <a:srgbClr val="8B93A1"/>
                 </a:solidFill>
-                <a:latin typeface="Calibri"/>
+                <a:latin typeface="Helvetica Neue"/>
               </a:rPr>
               <a:t>/</a:t>
             </a:r>
             <a:r>
-              <a:rPr sz="2000" b="0" i="0" dirty="0" err="1">
+              <a:rPr lang="fr-FR" sz="2000" b="0" i="0" dirty="0" err="1">
                 <a:solidFill>
                   <a:srgbClr val="8B93A1"/>
                 </a:solidFill>
-                <a:latin typeface="Calibri"/>
+                <a:latin typeface="Helvetica Neue"/>
               </a:rPr>
               <a:t>sidevconcept</a:t>
             </a:r>
             <a:r>
-              <a:rPr sz="2000" b="0" i="0" dirty="0">
+              <a:rPr lang="fr-FR" sz="2000" b="0" i="0" dirty="0">
                 <a:solidFill>
                   <a:srgbClr val="8B93A1"/>
                 </a:solidFill>
-                <a:latin typeface="Calibri"/>
+                <a:latin typeface="Helvetica Neue"/>
               </a:rPr>
               <a:t>/couverture-</a:t>
             </a:r>
             <a:r>
-              <a:rPr sz="2000" b="0" i="0" dirty="0" err="1">
+              <a:rPr lang="fr-FR" sz="2000" b="0" i="0" dirty="0" err="1">
                 <a:solidFill>
                   <a:srgbClr val="8B93A1"/>
                 </a:solidFill>
-                <a:latin typeface="Calibri"/>
+                <a:latin typeface="Helvetica Neue"/>
               </a:rPr>
               <a:t>junit</a:t>
             </a:r>
             <a:r>
-              <a:rPr sz="2000" b="0" i="0" dirty="0">
+              <a:rPr lang="fr-FR" sz="2000" b="0" i="0" dirty="0">
                 <a:solidFill>
                   <a:srgbClr val="8B93A1"/>
                 </a:solidFill>
-                <a:latin typeface="Calibri"/>
-              </a:rPr>
-              <a:t>-cucumber-</a:t>
-            </a:r>
-            <a:r>
-              <a:rPr sz="2000" b="0" i="0" dirty="0" err="1">
+                <a:latin typeface="Helvetica Neue"/>
+              </a:rPr>
+              <a:t>-</a:t>
+            </a:r>
+            <a:r>
+              <a:rPr lang="fr-FR" sz="2000" b="0" i="0" dirty="0" err="1">
                 <a:solidFill>
                   <a:srgbClr val="8B93A1"/>
                 </a:solidFill>
-                <a:latin typeface="Calibri"/>
-              </a:rPr>
-              <a:t>jacoco</a:t>
-            </a:r>
+                <a:latin typeface="Helvetica Neue"/>
+              </a:rPr>
+              <a:t>cucumber-jacoco</a:t>
+            </a:r>
+            <a:endParaRPr lang="fr-FR" sz="2000" dirty="0">
+              <a:solidFill>
+                <a:srgbClr val="8B93A1"/>
+              </a:solidFill>
+              <a:latin typeface="Helvetica Neue"/>
+            </a:endParaRPr>
+          </a:p>
+          <a:p>
+            <a:pPr algn="l">
+              <a:lnSpc>
+                <a:spcPct val="100000"/>
+              </a:lnSpc>
+              <a:spcAft>
+                <a:spcPts val="0"/>
+              </a:spcAft>
+            </a:pPr>
             <a:endParaRPr lang="fr-FR" sz="2000" b="0" i="0" dirty="0">
               <a:solidFill>
                 <a:srgbClr val="8B93A1"/>
               </a:solidFill>
-              <a:latin typeface="Calibri"/>
+              <a:latin typeface="Helvetica Neue"/>
             </a:endParaRPr>
           </a:p>
           <a:p>
@@ -20524,11 +20063,11 @@
                 <a:spcPts val="0"/>
               </a:spcAft>
             </a:pPr>
-            <a:endParaRPr lang="fr-FR" sz="2400" dirty="0">
+            <a:endParaRPr lang="fr-FR" sz="2000" dirty="0">
               <a:solidFill>
                 <a:srgbClr val="8B93A1"/>
               </a:solidFill>
-              <a:latin typeface="Calibri"/>
+              <a:latin typeface="Helvetica Neue"/>
             </a:endParaRPr>
           </a:p>
           <a:p>
@@ -20541,20 +20080,26 @@
               </a:spcAft>
             </a:pPr>
             <a:r>
-              <a:rPr sz="2000" b="0" i="0" dirty="0">
+              <a:rPr lang="fr-FR" sz="2000" b="0" i="0" dirty="0">
                 <a:solidFill>
                   <a:srgbClr val="8B93A1"/>
                 </a:solidFill>
-                <a:latin typeface="Calibri"/>
+                <a:latin typeface="Helvetica Neue"/>
               </a:rPr>
               <a:t>sidev.concept06@gmail.com</a:t>
             </a:r>
-          </a:p>
-        </p:txBody>
-      </p:sp>
-      <p:sp>
-        <p:nvSpPr>
-          <p:cNvPr id="35" name="TextBox 34"/>
+            <a:endParaRPr sz="2000" b="0" i="0" dirty="0">
+              <a:solidFill>
+                <a:srgbClr val="8B93A1"/>
+              </a:solidFill>
+              <a:latin typeface="Helvetica Neue"/>
+            </a:endParaRPr>
+          </a:p>
+        </p:txBody>
+      </p:sp>
+      <p:sp>
+        <p:nvSpPr>
+          <p:cNvPr id="23" name="TextBox 22"/>
           <p:cNvSpPr txBox="1"/>
           <p:nvPr/>
         </p:nvSpPr>
@@ -20583,29 +20128,20 @@
               </a:spcAft>
             </a:pPr>
             <a:r>
-              <a:rPr sz="1300" b="1" i="0" dirty="0" err="1">
+              <a:rPr sz="1300" b="1" i="0">
                 <a:solidFill>
                   <a:srgbClr val="C79A52"/>
                 </a:solidFill>
-                <a:latin typeface="Calibri"/>
-              </a:rPr>
-              <a:t>Scanne</a:t>
-            </a:r>
-            <a:r>
-              <a:rPr sz="1300" b="1" i="0" dirty="0">
-                <a:solidFill>
-                  <a:srgbClr val="C79A52"/>
-                </a:solidFill>
-                <a:latin typeface="Calibri"/>
-              </a:rPr>
-              <a:t>-moi</a:t>
-            </a:r>
-          </a:p>
-        </p:txBody>
-      </p:sp>
-      <p:sp>
-        <p:nvSpPr>
-          <p:cNvPr id="36" name="Rectangle 35"/>
+                <a:latin typeface="Helvetica Neue"/>
+              </a:rPr>
+              <a:t>Scanne-moi</a:t>
+            </a:r>
+          </a:p>
+        </p:txBody>
+      </p:sp>
+      <p:sp>
+        <p:nvSpPr>
+          <p:cNvPr id="24" name="Rectangle 23"/>
           <p:cNvSpPr/>
           <p:nvPr/>
         </p:nvSpPr>
@@ -20650,7 +20186,7 @@
       </p:sp>
       <p:pic>
         <p:nvPicPr>
-          <p:cNvPr id="37" name="Picture 36" descr="qr-github.png"/>
+          <p:cNvPr id="25" name="Picture 24" descr="qr-github.png"/>
           <p:cNvPicPr>
             <a:picLocks noChangeAspect="1"/>
           </p:cNvPicPr>
@@ -20740,7 +20276,7 @@
                 <a:solidFill>
                   <a:srgbClr val="C79A52"/>
                 </a:solidFill>
-                <a:latin typeface="Calibri"/>
+                <a:latin typeface="Helvetica Neue"/>
               </a:rPr>
               <a:t>POUR COMMENCER</a:t>
             </a:r>
@@ -20782,7 +20318,7 @@
                 <a:solidFill>
                   <a:srgbClr val="EFECE3"/>
                 </a:solidFill>
-                <a:latin typeface="Calibri"/>
+                <a:latin typeface="Helvetica Neue"/>
               </a:rPr>
               <a:t>Levez la main si...</a:t>
             </a:r>
@@ -20869,7 +20405,7 @@
                 <a:solidFill>
                   <a:srgbClr val="EFECE3"/>
                 </a:solidFill>
-                <a:latin typeface="Calibri"/>
+                <a:latin typeface="Helvetica Neue"/>
               </a:rPr>
               <a:t>...vous avez déjà écrit un test juste pour faire plaisir à la CI.</a:t>
             </a:r>
@@ -20956,7 +20492,7 @@
                 <a:solidFill>
                   <a:srgbClr val="EFECE3"/>
                 </a:solidFill>
-                <a:latin typeface="Calibri"/>
+                <a:latin typeface="Helvetica Neue"/>
               </a:rPr>
               <a:t>...vous avez déjà vu 100 % de couverture sur un fichier plein de bugs.</a:t>
             </a:r>
@@ -21043,7 +20579,7 @@
                 <a:solidFill>
                   <a:srgbClr val="EFECE3"/>
                 </a:solidFill>
-                <a:latin typeface="Calibri"/>
+                <a:latin typeface="Helvetica Neue"/>
               </a:rPr>
               <a:t>...vous ne savez pas, là, maintenant, ce que couvrent VOS tests.</a:t>
             </a:r>
@@ -21085,7 +20621,7 @@
                 <a:solidFill>
                   <a:srgbClr val="C79A52"/>
                 </a:solidFill>
-                <a:latin typeface="Calibri"/>
+                <a:latin typeface="Helvetica Neue"/>
               </a:rPr>
               <a:t>Pas de jugement. Enfin... un peu.</a:t>
             </a:r>
@@ -21125,9 +20661,9 @@
             <a:r>
               <a:rPr sz="1000" b="0" i="0">
                 <a:solidFill>
-                  <a:srgbClr val="6E7A8E"/>
-                </a:solidFill>
-                <a:latin typeface="Calibri"/>
+                  <a:srgbClr val="8B93A1"/>
+                </a:solidFill>
+                <a:latin typeface="Helvetica Neue"/>
               </a:rPr>
               <a:t>03 / 28</a:t>
             </a:r>
@@ -21167,9 +20703,9 @@
             <a:r>
               <a:rPr sz="800" b="0" i="0">
                 <a:solidFill>
-                  <a:srgbClr val="6E7A8E"/>
-                </a:solidFill>
-                <a:latin typeface="Calibri"/>
+                  <a:srgbClr val="8B93A1"/>
+                </a:solidFill>
+                <a:latin typeface="Helvetica Neue"/>
               </a:rPr>
               <a:t>COUVERTURE DE CODE — QUARKUS · JUNIT · CUCUMBER · JACOCO</a:t>
             </a:r>
@@ -21287,9 +20823,9 @@
             <a:r>
               <a:rPr sz="1300" b="1" i="0">
                 <a:solidFill>
-                  <a:srgbClr val="C79A52"/>
-                </a:solidFill>
-                <a:latin typeface="Calibri"/>
+                  <a:srgbClr val="8A6530"/>
+                </a:solidFill>
+                <a:latin typeface="Helvetica Neue"/>
               </a:rPr>
               <a:t>AU PROGRAMME</a:t>
             </a:r>
@@ -21331,7 +20867,7 @@
                 <a:solidFill>
                   <a:srgbClr val="162844"/>
                 </a:solidFill>
-                <a:latin typeface="Calibri"/>
+                <a:latin typeface="Helvetica Neue"/>
               </a:rPr>
               <a:t>Une heure, quatre outils, zéro slide inutile (promis)</a:t>
             </a:r>
@@ -21371,9 +20907,9 @@
             <a:r>
               <a:rPr sz="2000" b="1" i="0">
                 <a:solidFill>
-                  <a:srgbClr val="C79A52"/>
-                </a:solidFill>
-                <a:latin typeface="Calibri"/>
+                  <a:srgbClr val="8A6530"/>
+                </a:solidFill>
+                <a:latin typeface="Helvetica Neue"/>
               </a:rPr>
               <a:t>1</a:t>
             </a:r>
@@ -21415,7 +20951,7 @@
                 <a:solidFill>
                   <a:srgbClr val="162844"/>
                 </a:solidFill>
-                <a:latin typeface="Calibri"/>
+                <a:latin typeface="Helvetica Neue"/>
               </a:rPr>
               <a:t>Le problème</a:t>
             </a:r>
@@ -21457,7 +20993,7 @@
                 <a:solidFill>
                   <a:srgbClr val="333A47"/>
                 </a:solidFill>
-                <a:latin typeface="Calibri"/>
+                <a:latin typeface="Helvetica Neue"/>
               </a:rPr>
               <a:t>Pourquoi une suite de tests verte ne suffit pas</a:t>
             </a:r>
@@ -21497,9 +21033,9 @@
             <a:r>
               <a:rPr sz="1300" b="0" i="0">
                 <a:solidFill>
-                  <a:srgbClr val="8B93A1"/>
-                </a:solidFill>
-                <a:latin typeface="Calibri"/>
+                  <a:srgbClr val="5E6674"/>
+                </a:solidFill>
+                <a:latin typeface="Helvetica Neue"/>
               </a:rPr>
               <a:t>5 min</a:t>
             </a:r>
@@ -21539,9 +21075,9 @@
             <a:r>
               <a:rPr sz="2000" b="1" i="0">
                 <a:solidFill>
-                  <a:srgbClr val="C79A52"/>
-                </a:solidFill>
-                <a:latin typeface="Calibri"/>
+                  <a:srgbClr val="8A6530"/>
+                </a:solidFill>
+                <a:latin typeface="Helvetica Neue"/>
               </a:rPr>
               <a:t>2</a:t>
             </a:r>
@@ -21583,7 +21119,7 @@
                 <a:solidFill>
                   <a:srgbClr val="162844"/>
                 </a:solidFill>
-                <a:latin typeface="Calibri"/>
+                <a:latin typeface="Helvetica Neue"/>
               </a:rPr>
               <a:t>La stack</a:t>
             </a:r>
@@ -21625,7 +21161,7 @@
                 <a:solidFill>
                   <a:srgbClr val="333A47"/>
                 </a:solidFill>
-                <a:latin typeface="Calibri"/>
+                <a:latin typeface="Helvetica Neue"/>
               </a:rPr>
               <a:t>JUnit, Cucumber, Quarkus, Jacoco — qui fait quoi</a:t>
             </a:r>
@@ -21665,9 +21201,9 @@
             <a:r>
               <a:rPr sz="1300" b="0" i="0">
                 <a:solidFill>
-                  <a:srgbClr val="8B93A1"/>
-                </a:solidFill>
-                <a:latin typeface="Calibri"/>
+                  <a:srgbClr val="5E6674"/>
+                </a:solidFill>
+                <a:latin typeface="Helvetica Neue"/>
               </a:rPr>
               <a:t>10 min</a:t>
             </a:r>
@@ -21707,9 +21243,9 @@
             <a:r>
               <a:rPr sz="2000" b="1" i="0">
                 <a:solidFill>
-                  <a:srgbClr val="C79A52"/>
-                </a:solidFill>
-                <a:latin typeface="Calibri"/>
+                  <a:srgbClr val="8A6530"/>
+                </a:solidFill>
+                <a:latin typeface="Helvetica Neue"/>
               </a:rPr>
               <a:t>3</a:t>
             </a:r>
@@ -21751,7 +21287,7 @@
                 <a:solidFill>
                   <a:srgbClr val="162844"/>
                 </a:solidFill>
-                <a:latin typeface="Calibri"/>
+                <a:latin typeface="Helvetica Neue"/>
               </a:rPr>
               <a:t>Démo : le projet</a:t>
             </a:r>
@@ -21793,7 +21329,7 @@
                 <a:solidFill>
                   <a:srgbClr val="333A47"/>
                 </a:solidFill>
-                <a:latin typeface="Calibri"/>
+                <a:latin typeface="Helvetica Neue"/>
               </a:rPr>
               <a:t>Un agenda malin, ses tests, ses angles morts</a:t>
             </a:r>
@@ -21833,9 +21369,9 @@
             <a:r>
               <a:rPr sz="1300" b="0" i="0">
                 <a:solidFill>
-                  <a:srgbClr val="8B93A1"/>
-                </a:solidFill>
-                <a:latin typeface="Calibri"/>
+                  <a:srgbClr val="5E6674"/>
+                </a:solidFill>
+                <a:latin typeface="Helvetica Neue"/>
               </a:rPr>
               <a:t>10 min</a:t>
             </a:r>
@@ -21875,9 +21411,9 @@
             <a:r>
               <a:rPr sz="2000" b="1" i="0">
                 <a:solidFill>
-                  <a:srgbClr val="C79A52"/>
-                </a:solidFill>
-                <a:latin typeface="Calibri"/>
+                  <a:srgbClr val="8A6530"/>
+                </a:solidFill>
+                <a:latin typeface="Helvetica Neue"/>
               </a:rPr>
               <a:t>4</a:t>
             </a:r>
@@ -21919,7 +21455,7 @@
                 <a:solidFill>
                   <a:srgbClr val="162844"/>
                 </a:solidFill>
-                <a:latin typeface="Calibri"/>
+                <a:latin typeface="Helvetica Neue"/>
               </a:rPr>
               <a:t>Le rapport qui ne ment pas</a:t>
             </a:r>
@@ -21961,7 +21497,7 @@
                 <a:solidFill>
                   <a:srgbClr val="333A47"/>
                 </a:solidFill>
-                <a:latin typeface="Calibri"/>
+                <a:latin typeface="Helvetica Neue"/>
               </a:rPr>
               <a:t>Jacoco en direct, JUnit contre Cucumber</a:t>
             </a:r>
@@ -22001,9 +21537,9 @@
             <a:r>
               <a:rPr sz="1300" b="0" i="0">
                 <a:solidFill>
-                  <a:srgbClr val="8B93A1"/>
-                </a:solidFill>
-                <a:latin typeface="Calibri"/>
+                  <a:srgbClr val="5E6674"/>
+                </a:solidFill>
+                <a:latin typeface="Helvetica Neue"/>
               </a:rPr>
               <a:t>15 min</a:t>
             </a:r>
@@ -22043,9 +21579,9 @@
             <a:r>
               <a:rPr sz="2000" b="1" i="0">
                 <a:solidFill>
-                  <a:srgbClr val="C79A52"/>
-                </a:solidFill>
-                <a:latin typeface="Calibri"/>
+                  <a:srgbClr val="8A6530"/>
+                </a:solidFill>
+                <a:latin typeface="Helvetica Neue"/>
               </a:rPr>
               <a:t>5</a:t>
             </a:r>
@@ -22087,7 +21623,7 @@
                 <a:solidFill>
                   <a:srgbClr val="162844"/>
                 </a:solidFill>
-                <a:latin typeface="Calibri"/>
+                <a:latin typeface="Helvetica Neue"/>
               </a:rPr>
               <a:t>Bonus : SonarQube</a:t>
             </a:r>
@@ -22129,7 +21665,7 @@
                 <a:solidFill>
                   <a:srgbClr val="333A47"/>
                 </a:solidFill>
-                <a:latin typeface="Calibri"/>
+                <a:latin typeface="Helvetica Neue"/>
               </a:rPr>
               <a:t>Le même rapport, dans un vrai dashboard</a:t>
             </a:r>
@@ -22169,9 +21705,9 @@
             <a:r>
               <a:rPr sz="1300" b="0" i="0">
                 <a:solidFill>
-                  <a:srgbClr val="8B93A1"/>
-                </a:solidFill>
-                <a:latin typeface="Calibri"/>
+                  <a:srgbClr val="5E6674"/>
+                </a:solidFill>
+                <a:latin typeface="Helvetica Neue"/>
               </a:rPr>
               <a:t>10 min</a:t>
             </a:r>
@@ -22211,9 +21747,9 @@
             <a:r>
               <a:rPr sz="2000" b="1" i="0">
                 <a:solidFill>
-                  <a:srgbClr val="C79A52"/>
-                </a:solidFill>
-                <a:latin typeface="Calibri"/>
+                  <a:srgbClr val="8A6530"/>
+                </a:solidFill>
+                <a:latin typeface="Helvetica Neue"/>
               </a:rPr>
               <a:t>6</a:t>
             </a:r>
@@ -22255,7 +21791,7 @@
                 <a:solidFill>
                   <a:srgbClr val="162844"/>
                 </a:solidFill>
-                <a:latin typeface="Calibri"/>
+                <a:latin typeface="Helvetica Neue"/>
               </a:rPr>
               <a:t>Ce qu'on retient</a:t>
             </a:r>
@@ -22297,7 +21833,7 @@
                 <a:solidFill>
                   <a:srgbClr val="333A47"/>
                 </a:solidFill>
-                <a:latin typeface="Calibri"/>
+                <a:latin typeface="Helvetica Neue"/>
               </a:rPr>
               <a:t>Et deux ou trois pièges qu'on a vraiment eus</a:t>
             </a:r>
@@ -22337,9 +21873,9 @@
             <a:r>
               <a:rPr sz="1300" b="0" i="0">
                 <a:solidFill>
-                  <a:srgbClr val="8B93A1"/>
-                </a:solidFill>
-                <a:latin typeface="Calibri"/>
+                  <a:srgbClr val="5E6674"/>
+                </a:solidFill>
+                <a:latin typeface="Helvetica Neue"/>
               </a:rPr>
               <a:t>5 min</a:t>
             </a:r>
@@ -22379,9 +21915,9 @@
             <a:r>
               <a:rPr sz="1000" b="0" i="0">
                 <a:solidFill>
-                  <a:srgbClr val="8B93A1"/>
-                </a:solidFill>
-                <a:latin typeface="Calibri"/>
+                  <a:srgbClr val="5E6674"/>
+                </a:solidFill>
+                <a:latin typeface="Helvetica Neue"/>
               </a:rPr>
               <a:t>04 / 28</a:t>
             </a:r>
@@ -22421,9 +21957,9 @@
             <a:r>
               <a:rPr sz="800" b="0" i="0">
                 <a:solidFill>
-                  <a:srgbClr val="8B93A1"/>
-                </a:solidFill>
-                <a:latin typeface="Calibri"/>
+                  <a:srgbClr val="5E6674"/>
+                </a:solidFill>
+                <a:latin typeface="Helvetica Neue"/>
               </a:rPr>
               <a:t>COUVERTURE DE CODE — QUARKUS · JUNIT · CUCUMBER · JACOCO</a:t>
             </a:r>
@@ -22541,9 +22077,9 @@
             <a:r>
               <a:rPr sz="1300" b="1" i="0">
                 <a:solidFill>
-                  <a:srgbClr val="C79A52"/>
-                </a:solidFill>
-                <a:latin typeface="Calibri"/>
+                  <a:srgbClr val="8A6530"/>
+                </a:solidFill>
+                <a:latin typeface="Helvetica Neue"/>
               </a:rPr>
               <a:t>LE CONSTAT</a:t>
             </a:r>
@@ -22585,7 +22121,7 @@
                 <a:solidFill>
                   <a:srgbClr val="162844"/>
                 </a:solidFill>
-                <a:latin typeface="Calibri"/>
+                <a:latin typeface="Helvetica Neue"/>
               </a:rPr>
               <a:t>On a des tests. On n'a pas de visibilité.</a:t>
             </a:r>
@@ -22715,9 +22251,9 @@
             <a:r>
               <a:rPr sz="3000" b="1" i="0">
                 <a:solidFill>
-                  <a:srgbClr val="5C8C86"/>
-                </a:solidFill>
-                <a:latin typeface="Calibri"/>
+                  <a:srgbClr val="355C57"/>
+                </a:solidFill>
+                <a:latin typeface="Helvetica Neue"/>
               </a:rPr>
               <a:t>01</a:t>
             </a:r>
@@ -22759,7 +22295,7 @@
                 <a:solidFill>
                   <a:srgbClr val="162844"/>
                 </a:solidFill>
-                <a:latin typeface="Calibri"/>
+                <a:latin typeface="Helvetica Neue"/>
               </a:rPr>
               <a:t>On écrit des tests</a:t>
             </a:r>
@@ -22801,7 +22337,7 @@
                 <a:solidFill>
                   <a:srgbClr val="333A47"/>
                 </a:solidFill>
-                <a:latin typeface="Calibri"/>
+                <a:latin typeface="Helvetica Neue"/>
               </a:rPr>
               <a:t>JUnit, Cucumber : les suites tournent au vert à chaque build.</a:t>
             </a:r>
@@ -22931,9 +22467,9 @@
             <a:r>
               <a:rPr sz="3000" b="1" i="0">
                 <a:solidFill>
-                  <a:srgbClr val="C79A52"/>
-                </a:solidFill>
-                <a:latin typeface="Calibri"/>
+                  <a:srgbClr val="8A6530"/>
+                </a:solidFill>
+                <a:latin typeface="Helvetica Neue"/>
               </a:rPr>
               <a:t>02</a:t>
             </a:r>
@@ -22975,7 +22511,7 @@
                 <a:solidFill>
                   <a:srgbClr val="162844"/>
                 </a:solidFill>
-                <a:latin typeface="Calibri"/>
+                <a:latin typeface="Helvetica Neue"/>
               </a:rPr>
               <a:t>On ne sait pas ce qu'ils couvrent</a:t>
             </a:r>
@@ -23017,7 +22553,7 @@
                 <a:solidFill>
                   <a:srgbClr val="333A47"/>
                 </a:solidFill>
-                <a:latin typeface="Calibri"/>
+                <a:latin typeface="Helvetica Neue"/>
               </a:rPr>
               <a:t>Quelles classes ? Quelles branches ? Personne ne regarde vraiment.</a:t>
             </a:r>
@@ -23147,9 +22683,9 @@
             <a:r>
               <a:rPr sz="3000" b="1" i="0">
                 <a:solidFill>
-                  <a:srgbClr val="BF6F5D"/>
-                </a:solidFill>
-                <a:latin typeface="Calibri"/>
+                  <a:srgbClr val="8F4536"/>
+                </a:solidFill>
+                <a:latin typeface="Helvetica Neue"/>
               </a:rPr>
               <a:t>03</a:t>
             </a:r>
@@ -23191,7 +22727,7 @@
                 <a:solidFill>
                   <a:srgbClr val="162844"/>
                 </a:solidFill>
-                <a:latin typeface="Calibri"/>
+                <a:latin typeface="Helvetica Neue"/>
               </a:rPr>
               <a:t>Les angles morts restent invisibles</a:t>
             </a:r>
@@ -23233,7 +22769,7 @@
                 <a:solidFill>
                   <a:srgbClr val="333A47"/>
                 </a:solidFill>
-                <a:latin typeface="Calibri"/>
+                <a:latin typeface="Helvetica Neue"/>
               </a:rPr>
               <a:t>Jusqu'au bug en prod, dans le code qu'aucun test n'a jamais exécuté.</a:t>
             </a:r>
@@ -23273,9 +22809,9 @@
             <a:r>
               <a:rPr sz="1000" b="0" i="0">
                 <a:solidFill>
-                  <a:srgbClr val="8B93A1"/>
-                </a:solidFill>
-                <a:latin typeface="Calibri"/>
+                  <a:srgbClr val="5E6674"/>
+                </a:solidFill>
+                <a:latin typeface="Helvetica Neue"/>
               </a:rPr>
               <a:t>05 / 28</a:t>
             </a:r>
@@ -23315,9 +22851,9 @@
             <a:r>
               <a:rPr sz="800" b="0" i="0">
                 <a:solidFill>
-                  <a:srgbClr val="8B93A1"/>
-                </a:solidFill>
-                <a:latin typeface="Calibri"/>
+                  <a:srgbClr val="5E6674"/>
+                </a:solidFill>
+                <a:latin typeface="Helvetica Neue"/>
               </a:rPr>
               <a:t>COUVERTURE DE CODE — QUARKUS · JUNIT · CUCUMBER · JACOCO</a:t>
             </a:r>
@@ -23435,9 +22971,9 @@
             <a:r>
               <a:rPr sz="1300" b="1" i="0">
                 <a:solidFill>
-                  <a:srgbClr val="C79A52"/>
-                </a:solidFill>
-                <a:latin typeface="Calibri"/>
+                  <a:srgbClr val="8A6530"/>
+                </a:solidFill>
+                <a:latin typeface="Helvetica Neue"/>
               </a:rPr>
               <a:t>LA STACK TECHNIQUE</a:t>
             </a:r>
@@ -23479,7 +23015,7 @@
                 <a:solidFill>
                   <a:srgbClr val="162844"/>
                 </a:solidFill>
-                <a:latin typeface="Calibri"/>
+                <a:latin typeface="Helvetica Neue"/>
               </a:rPr>
               <a:t>Quatre outils, quatre questions différentes</a:t>
             </a:r>
@@ -23611,7 +23147,7 @@
                 <a:solidFill>
                   <a:srgbClr val="162844"/>
                 </a:solidFill>
-                <a:latin typeface="Calibri"/>
+                <a:latin typeface="Helvetica Neue"/>
               </a:rPr>
               <a:t>JUnit 5</a:t>
             </a:r>
@@ -23653,7 +23189,7 @@
                 <a:solidFill>
                   <a:srgbClr val="333A47"/>
                 </a:solidFill>
-                <a:latin typeface="Calibri"/>
+                <a:latin typeface="Helvetica Neue"/>
               </a:rPr>
               <a:t>« La logique métier fait-elle ce qu'elle doit ? »</a:t>
             </a:r>
@@ -23672,7 +23208,7 @@
                 <a:solidFill>
                   <a:srgbClr val="333A47"/>
                 </a:solidFill>
-                <a:latin typeface="Calibri"/>
+                <a:latin typeface="Helvetica Neue"/>
               </a:rPr>
               <a:t>Tests unitaires ciblés, rapides, isolés.</a:t>
             </a:r>
@@ -23804,7 +23340,7 @@
                 <a:solidFill>
                   <a:srgbClr val="162844"/>
                 </a:solidFill>
-                <a:latin typeface="Calibri"/>
+                <a:latin typeface="Helvetica Neue"/>
               </a:rPr>
               <a:t>Cucumber</a:t>
             </a:r>
@@ -23846,7 +23382,7 @@
                 <a:solidFill>
                   <a:srgbClr val="333A47"/>
                 </a:solidFill>
-                <a:latin typeface="Calibri"/>
+                <a:latin typeface="Helvetica Neue"/>
               </a:rPr>
               <a:t>« Le comportement attendu est-il respecté ? »</a:t>
             </a:r>
@@ -23865,7 +23401,7 @@
                 <a:solidFill>
                   <a:srgbClr val="333A47"/>
                 </a:solidFill>
-                <a:latin typeface="Calibri"/>
+                <a:latin typeface="Helvetica Neue"/>
               </a:rPr>
               <a:t>Scénarios Gherkin lisibles, exécutés via l'API REST.</a:t>
             </a:r>
@@ -23997,7 +23533,7 @@
                 <a:solidFill>
                   <a:srgbClr val="162844"/>
                 </a:solidFill>
-                <a:latin typeface="Calibri"/>
+                <a:latin typeface="Helvetica Neue"/>
               </a:rPr>
               <a:t>Quarkus</a:t>
             </a:r>
@@ -24039,7 +23575,7 @@
                 <a:solidFill>
                   <a:srgbClr val="333A47"/>
                 </a:solidFill>
-                <a:latin typeface="Calibri"/>
+                <a:latin typeface="Helvetica Neue"/>
               </a:rPr>
               <a:t>« Comment tout ça tourne ensemble ? »</a:t>
             </a:r>
@@ -24058,7 +23594,7 @@
                 <a:solidFill>
                   <a:srgbClr val="333A47"/>
                 </a:solidFill>
-                <a:latin typeface="Calibri"/>
+                <a:latin typeface="Helvetica Neue"/>
               </a:rPr>
               <a:t>Le framework qui démarre l'appli et pilote les tests.</a:t>
             </a:r>
@@ -24190,7 +23726,7 @@
                 <a:solidFill>
                   <a:srgbClr val="162844"/>
                 </a:solidFill>
-                <a:latin typeface="Calibri"/>
+                <a:latin typeface="Helvetica Neue"/>
               </a:rPr>
               <a:t>Jacoco</a:t>
             </a:r>
@@ -24232,7 +23768,7 @@
                 <a:solidFill>
                   <a:srgbClr val="333A47"/>
                 </a:solidFill>
-                <a:latin typeface="Calibri"/>
+                <a:latin typeface="Helvetica Neue"/>
               </a:rPr>
               <a:t>« Qu'est-ce qui a vraiment été exécuté ? »</a:t>
             </a:r>
@@ -24251,7 +23787,7 @@
                 <a:solidFill>
                   <a:srgbClr val="333A47"/>
                 </a:solidFill>
-                <a:latin typeface="Calibri"/>
+                <a:latin typeface="Helvetica Neue"/>
               </a:rPr>
               <a:t>L'instrument de mesure de la couverture, à chaque build.</a:t>
             </a:r>
@@ -24291,9 +23827,9 @@
             <a:r>
               <a:rPr sz="1000" b="0" i="0">
                 <a:solidFill>
-                  <a:srgbClr val="8B93A1"/>
-                </a:solidFill>
-                <a:latin typeface="Calibri"/>
+                  <a:srgbClr val="5E6674"/>
+                </a:solidFill>
+                <a:latin typeface="Helvetica Neue"/>
               </a:rPr>
               <a:t>06 / 28</a:t>
             </a:r>
@@ -24333,9 +23869,9 @@
             <a:r>
               <a:rPr sz="800" b="0" i="0">
                 <a:solidFill>
-                  <a:srgbClr val="8B93A1"/>
-                </a:solidFill>
-                <a:latin typeface="Calibri"/>
+                  <a:srgbClr val="5E6674"/>
+                </a:solidFill>
+                <a:latin typeface="Helvetica Neue"/>
               </a:rPr>
               <a:t>COUVERTURE DE CODE — QUARKUS · JUNIT · CUCUMBER · JACOCO</a:t>
             </a:r>
@@ -24410,7 +23946,7 @@
                 <a:solidFill>
                   <a:srgbClr val="C79A52"/>
                 </a:solidFill>
-                <a:latin typeface="Calibri"/>
+                <a:latin typeface="Helvetica Neue"/>
               </a:rPr>
               <a:t>LE TERRAIN DE JEU</a:t>
             </a:r>
@@ -24452,7 +23988,7 @@
                 <a:solidFill>
                   <a:srgbClr val="EFECE3"/>
                 </a:solidFill>
-                <a:latin typeface="Calibri"/>
+                <a:latin typeface="Helvetica Neue"/>
               </a:rPr>
               <a:t>Un agenda malin</a:t>
             </a:r>
@@ -24494,7 +24030,7 @@
                 <a:solidFill>
                   <a:srgbClr val="C8CFDA"/>
                 </a:solidFill>
-                <a:latin typeface="Calibri"/>
+                <a:latin typeface="Helvetica Neue"/>
               </a:rPr>
               <a:t>Une API Quarkus qui planifie des événements, détecte les conflits d'horaire,</a:t>
             </a:r>
@@ -24513,7 +24049,7 @@
                 <a:solidFill>
                   <a:srgbClr val="C8CFDA"/>
                 </a:solidFill>
-                <a:latin typeface="Calibri"/>
+                <a:latin typeface="Helvetica Neue"/>
               </a:rPr>
               <a:t>génère des récurrences, et glisse une citation du jour.</a:t>
             </a:r>
@@ -24645,7 +24181,7 @@
                 <a:solidFill>
                   <a:srgbClr val="EFECE3"/>
                 </a:solidFill>
-                <a:latin typeface="Calibri"/>
+                <a:latin typeface="Helvetica Neue"/>
               </a:rPr>
               <a:t>CalendarResource</a:t>
             </a:r>
@@ -24685,9 +24221,9 @@
             <a:r>
               <a:rPr sz="1050" b="0" i="0">
                 <a:solidFill>
-                  <a:srgbClr val="8B93A1"/>
-                </a:solidFill>
-                <a:latin typeface="Calibri"/>
+                  <a:srgbClr val="9BA3B1"/>
+                </a:solidFill>
+                <a:latin typeface="Helvetica Neue"/>
               </a:rPr>
               <a:t>Couche REST — JSON in/out</a:t>
             </a:r>
@@ -24864,7 +24400,7 @@
                 <a:solidFill>
                   <a:srgbClr val="EFECE3"/>
                 </a:solidFill>
-                <a:latin typeface="Calibri"/>
+                <a:latin typeface="Helvetica Neue"/>
               </a:rPr>
               <a:t>EventService</a:t>
             </a:r>
@@ -24904,9 +24440,9 @@
             <a:r>
               <a:rPr sz="1050" b="0" i="0">
                 <a:solidFill>
-                  <a:srgbClr val="8B93A1"/>
-                </a:solidFill>
-                <a:latin typeface="Calibri"/>
+                  <a:srgbClr val="9BA3B1"/>
+                </a:solidFill>
+                <a:latin typeface="Helvetica Neue"/>
               </a:rPr>
               <a:t>création + recherche</a:t>
             </a:r>
@@ -25038,7 +24574,7 @@
                 <a:solidFill>
                   <a:srgbClr val="EFECE3"/>
                 </a:solidFill>
-                <a:latin typeface="Calibri"/>
+                <a:latin typeface="Helvetica Neue"/>
               </a:rPr>
               <a:t>RecurrenceService</a:t>
             </a:r>
@@ -25078,9 +24614,9 @@
             <a:r>
               <a:rPr sz="1050" b="0" i="0">
                 <a:solidFill>
-                  <a:srgbClr val="8B93A1"/>
-                </a:solidFill>
-                <a:latin typeface="Calibri"/>
+                  <a:srgbClr val="9BA3B1"/>
+                </a:solidFill>
+                <a:latin typeface="Helvetica Neue"/>
               </a:rPr>
               <a:t>quotidien / hebdo / mensuel</a:t>
             </a:r>
@@ -25212,7 +24748,7 @@
                 <a:solidFill>
                   <a:srgbClr val="EFECE3"/>
                 </a:solidFill>
-                <a:latin typeface="Calibri"/>
+                <a:latin typeface="Helvetica Neue"/>
               </a:rPr>
               <a:t>HolidayService</a:t>
             </a:r>
@@ -25252,9 +24788,9 @@
             <a:r>
               <a:rPr sz="1050" b="0" i="0">
                 <a:solidFill>
-                  <a:srgbClr val="8B93A1"/>
-                </a:solidFill>
-                <a:latin typeface="Calibri"/>
+                  <a:srgbClr val="9BA3B1"/>
+                </a:solidFill>
+                <a:latin typeface="Helvetica Neue"/>
               </a:rPr>
               <a:t>jours fériés</a:t>
             </a:r>
@@ -25386,7 +24922,7 @@
                 <a:solidFill>
                   <a:srgbClr val="EFECE3"/>
                 </a:solidFill>
-                <a:latin typeface="Calibri"/>
+                <a:latin typeface="Helvetica Neue"/>
               </a:rPr>
               <a:t>QuoteOfTheDayService</a:t>
             </a:r>
@@ -25426,9 +24962,9 @@
             <a:r>
               <a:rPr sz="1050" b="0" i="0">
                 <a:solidFill>
-                  <a:srgbClr val="8B93A1"/>
-                </a:solidFill>
-                <a:latin typeface="Calibri"/>
+                  <a:srgbClr val="9BA3B1"/>
+                </a:solidFill>
+                <a:latin typeface="Helvetica Neue"/>
               </a:rPr>
               <a:t>citation du jour</a:t>
             </a:r>
@@ -25605,7 +25141,7 @@
                 <a:solidFill>
                   <a:srgbClr val="EFECE3"/>
                 </a:solidFill>
-                <a:latin typeface="Calibri"/>
+                <a:latin typeface="Helvetica Neue"/>
               </a:rPr>
               <a:t>ConflictDetector</a:t>
             </a:r>
@@ -25645,9 +25181,9 @@
             <a:r>
               <a:rPr sz="1050" b="0" i="0">
                 <a:solidFill>
-                  <a:srgbClr val="8B93A1"/>
-                </a:solidFill>
-                <a:latin typeface="Calibri"/>
+                  <a:srgbClr val="9BA3B1"/>
+                </a:solidFill>
+                <a:latin typeface="Helvetica Neue"/>
               </a:rPr>
               <a:t>logique pure — aucune dépendance</a:t>
             </a:r>
@@ -25689,7 +25225,7 @@
                 <a:solidFill>
                   <a:srgbClr val="8B93A1"/>
                 </a:solidFill>
-                <a:latin typeface="Calibri"/>
+                <a:latin typeface="Helvetica Neue"/>
               </a:rPr>
               <a:t>Aucune base de données : le sujet du jour, c'est la couverture</a:t>
             </a:r>
@@ -25708,7 +25244,7 @@
                 <a:solidFill>
                   <a:srgbClr val="8B93A1"/>
                 </a:solidFill>
-                <a:latin typeface="Calibri"/>
+                <a:latin typeface="Helvetica Neue"/>
               </a:rPr>
               <a:t>de tests — pas la persistance.</a:t>
             </a:r>
@@ -25748,9 +25284,9 @@
             <a:r>
               <a:rPr sz="1000" b="0" i="0">
                 <a:solidFill>
-                  <a:srgbClr val="6E7A8E"/>
-                </a:solidFill>
-                <a:latin typeface="Calibri"/>
+                  <a:srgbClr val="8B93A1"/>
+                </a:solidFill>
+                <a:latin typeface="Helvetica Neue"/>
               </a:rPr>
               <a:t>07 / 28</a:t>
             </a:r>
@@ -25790,9 +25326,9 @@
             <a:r>
               <a:rPr sz="800" b="0" i="0">
                 <a:solidFill>
-                  <a:srgbClr val="6E7A8E"/>
-                </a:solidFill>
-                <a:latin typeface="Calibri"/>
+                  <a:srgbClr val="8B93A1"/>
+                </a:solidFill>
+                <a:latin typeface="Helvetica Neue"/>
               </a:rPr>
               <a:t>COUVERTURE DE CODE — QUARKUS · JUNIT · CUCUMBER · JACOCO</a:t>
             </a:r>
@@ -25910,9 +25446,9 @@
             <a:r>
               <a:rPr sz="1300" b="1" i="0">
                 <a:solidFill>
-                  <a:srgbClr val="C79A52"/>
-                </a:solidFill>
-                <a:latin typeface="Calibri"/>
+                  <a:srgbClr val="8A6530"/>
+                </a:solidFill>
+                <a:latin typeface="Helvetica Neue"/>
               </a:rPr>
               <a:t>ZOOM — JUNIT</a:t>
             </a:r>
@@ -25954,7 +25490,7 @@
                 <a:solidFill>
                   <a:srgbClr val="162844"/>
                 </a:solidFill>
-                <a:latin typeface="Calibri"/>
+                <a:latin typeface="Helvetica Neue"/>
               </a:rPr>
               <a:t>Le microscope</a:t>
             </a:r>
@@ -25996,7 +25532,7 @@
                 <a:solidFill>
                   <a:srgbClr val="333A47"/>
                 </a:solidFill>
-                <a:latin typeface="Calibri"/>
+                <a:latin typeface="Helvetica Neue"/>
               </a:rPr>
               <a:t>JUnit teste une unité de code isolée — une méthode, une classe — sans lancer</a:t>
             </a:r>
@@ -26015,7 +25551,7 @@
                 <a:solidFill>
                   <a:srgbClr val="333A47"/>
                 </a:solidFill>
-                <a:latin typeface="Calibri"/>
+                <a:latin typeface="Helvetica Neue"/>
               </a:rPr>
               <a:t>toute l'application. C'est rapide, précis, et ça ne pardonne rien.</a:t>
             </a:r>
@@ -26147,7 +25683,7 @@
                 <a:solidFill>
                   <a:srgbClr val="162844"/>
                 </a:solidFill>
-                <a:latin typeface="Calibri"/>
+                <a:latin typeface="Helvetica Neue"/>
               </a:rPr>
               <a:t>Rapide</a:t>
             </a:r>
@@ -26189,7 +25725,7 @@
                 <a:solidFill>
                   <a:srgbClr val="333A47"/>
                 </a:solidFill>
-                <a:latin typeface="Calibri"/>
+                <a:latin typeface="Helvetica Neue"/>
               </a:rPr>
               <a:t>Des milliers de tests en quelques secondes.</a:t>
             </a:r>
@@ -26321,7 +25857,7 @@
                 <a:solidFill>
                   <a:srgbClr val="162844"/>
                 </a:solidFill>
-                <a:latin typeface="Calibri"/>
+                <a:latin typeface="Helvetica Neue"/>
               </a:rPr>
               <a:t>Isolé</a:t>
             </a:r>
@@ -26363,7 +25899,7 @@
                 <a:solidFill>
                   <a:srgbClr val="333A47"/>
                 </a:solidFill>
-                <a:latin typeface="Calibri"/>
+                <a:latin typeface="Helvetica Neue"/>
               </a:rPr>
               <a:t>Pas de serveur, pas de réseau, pas de surprise.</a:t>
             </a:r>
@@ -26495,7 +26031,7 @@
                 <a:solidFill>
                   <a:srgbClr val="162844"/>
                 </a:solidFill>
-                <a:latin typeface="Calibri"/>
+                <a:latin typeface="Helvetica Neue"/>
               </a:rPr>
               <a:t>Technique</a:t>
             </a:r>
@@ -26537,7 +26073,7 @@
                 <a:solidFill>
                   <a:srgbClr val="333A47"/>
                 </a:solidFill>
-                <a:latin typeface="Calibri"/>
+                <a:latin typeface="Helvetica Neue"/>
               </a:rPr>
               <a:t>Pensé par et pour les développeurs.</a:t>
             </a:r>
@@ -26579,7 +26115,7 @@
                 <a:solidFill>
                   <a:srgbClr val="333A47"/>
                 </a:solidFill>
-                <a:latin typeface="Calibri"/>
+                <a:latin typeface="Helvetica Neue"/>
               </a:rPr>
               <a:t>Dans notre agenda malin : ConflictDetector, RecurrenceService — de la logique</a:t>
             </a:r>
@@ -26598,7 +26134,7 @@
                 <a:solidFill>
                   <a:srgbClr val="333A47"/>
                 </a:solidFill>
-                <a:latin typeface="Calibri"/>
+                <a:latin typeface="Helvetica Neue"/>
               </a:rPr>
               <a:t>pure, testée sans jamais démarrer Quarkus.</a:t>
             </a:r>
@@ -26638,9 +26174,9 @@
             <a:r>
               <a:rPr sz="1000" b="0" i="0">
                 <a:solidFill>
-                  <a:srgbClr val="8B93A1"/>
-                </a:solidFill>
-                <a:latin typeface="Calibri"/>
+                  <a:srgbClr val="5E6674"/>
+                </a:solidFill>
+                <a:latin typeface="Helvetica Neue"/>
               </a:rPr>
               <a:t>08 / 28</a:t>
             </a:r>
@@ -26680,9 +26216,9 @@
             <a:r>
               <a:rPr sz="800" b="0" i="0">
                 <a:solidFill>
-                  <a:srgbClr val="8B93A1"/>
-                </a:solidFill>
-                <a:latin typeface="Calibri"/>
+                  <a:srgbClr val="5E6674"/>
+                </a:solidFill>
+                <a:latin typeface="Helvetica Neue"/>
               </a:rPr>
               <a:t>COUVERTURE DE CODE — QUARKUS · JUNIT · CUCUMBER · JACOCO</a:t>
             </a:r>
@@ -26800,9 +26336,9 @@
             <a:r>
               <a:rPr sz="1300" b="1" i="0">
                 <a:solidFill>
-                  <a:srgbClr val="C79A52"/>
-                </a:solidFill>
-                <a:latin typeface="Calibri"/>
+                  <a:srgbClr val="8A6530"/>
+                </a:solidFill>
+                <a:latin typeface="Helvetica Neue"/>
               </a:rPr>
               <a:t>JUNIT — EN ACTION</a:t>
             </a:r>
@@ -26844,7 +26380,7 @@
                 <a:solidFill>
                   <a:srgbClr val="162844"/>
                 </a:solidFill>
-                <a:latin typeface="Calibri"/>
+                <a:latin typeface="Helvetica Neue"/>
               </a:rPr>
               <a:t>Viser juste, vite</a:t>
             </a:r>
@@ -26931,7 +26467,7 @@
                 <a:solidFill>
                   <a:srgbClr val="E3E8F0"/>
                 </a:solidFill>
-                <a:latin typeface="Consolas"/>
+                <a:latin typeface="Menlo"/>
               </a:rPr>
               <a:t>@Test</a:t>
             </a:r>
@@ -26950,7 +26486,7 @@
                 <a:solidFill>
                   <a:srgbClr val="E3E8F0"/>
                 </a:solidFill>
-                <a:latin typeface="Consolas"/>
+                <a:latin typeface="Menlo"/>
               </a:rPr>
               <a:t>void deuxEvenementsQuiSeTouchentNeSontPasEnConflit() {</a:t>
             </a:r>
@@ -26969,7 +26505,7 @@
                 <a:solidFill>
                   <a:srgbClr val="E3E8F0"/>
                 </a:solidFill>
-                <a:latin typeface="Consolas"/>
+                <a:latin typeface="Menlo"/>
               </a:rPr>
               <a:t>    Event a = eventAt("a", 9, 10);</a:t>
             </a:r>
@@ -26988,7 +26524,7 @@
                 <a:solidFill>
                   <a:srgbClr val="E3E8F0"/>
                 </a:solidFill>
-                <a:latin typeface="Consolas"/>
+                <a:latin typeface="Menlo"/>
               </a:rPr>
               <a:t>    Event b = eventAt("b", 10, 11);</a:t>
             </a:r>
@@ -27006,7 +26542,7 @@
               <a:solidFill>
                 <a:srgbClr val="E3E8F0"/>
               </a:solidFill>
-              <a:latin typeface="Consolas"/>
+              <a:latin typeface="Menlo"/>
             </a:endParaRPr>
           </a:p>
           <a:p>
@@ -27023,7 +26559,7 @@
                 <a:solidFill>
                   <a:srgbClr val="E3E8F0"/>
                 </a:solidFill>
-                <a:latin typeface="Consolas"/>
+                <a:latin typeface="Menlo"/>
               </a:rPr>
               <a:t>    assertFalse(detector.isConflicting(a, b));</a:t>
             </a:r>
@@ -27042,7 +26578,7 @@
                 <a:solidFill>
                   <a:srgbClr val="E3E8F0"/>
                 </a:solidFill>
-                <a:latin typeface="Consolas"/>
+                <a:latin typeface="Menlo"/>
               </a:rPr>
               <a:t>}</a:t>
             </a:r>
@@ -27084,7 +26620,7 @@
                 <a:solidFill>
                   <a:srgbClr val="333A47"/>
                 </a:solidFill>
-                <a:latin typeface="Calibri"/>
+                <a:latin typeface="Helvetica Neue"/>
               </a:rPr>
               <a:t>ConflictDetectorTest : 4 tests, 4 cas limites — chevauchement, contact exact,</a:t>
             </a:r>
@@ -27103,7 +26639,7 @@
                 <a:solidFill>
                   <a:srgbClr val="333A47"/>
                 </a:solidFill>
-                <a:latin typeface="Calibri"/>
+                <a:latin typeface="Helvetica Neue"/>
               </a:rPr>
               <a:t>séparation nette, réflexivité. Une classe pure, sans Quarkus, testée en quelques ms.</a:t>
             </a:r>
@@ -27143,9 +26679,9 @@
             <a:r>
               <a:rPr sz="1000" b="0" i="0">
                 <a:solidFill>
-                  <a:srgbClr val="8B93A1"/>
-                </a:solidFill>
-                <a:latin typeface="Calibri"/>
+                  <a:srgbClr val="5E6674"/>
+                </a:solidFill>
+                <a:latin typeface="Helvetica Neue"/>
               </a:rPr>
               <a:t>09 / 28</a:t>
             </a:r>
@@ -27185,9 +26721,9 @@
             <a:r>
               <a:rPr sz="800" b="0" i="0">
                 <a:solidFill>
-                  <a:srgbClr val="8B93A1"/>
-                </a:solidFill>
-                <a:latin typeface="Calibri"/>
+                  <a:srgbClr val="5E6674"/>
+                </a:solidFill>
+                <a:latin typeface="Helvetica Neue"/>
               </a:rPr>
               <a:t>COUVERTURE DE CODE — QUARKUS · JUNIT · CUCUMBER · JACOCO</a:t>
             </a:r>

</xml_diff>